<commit_message>
Prezentace upravena - zelené jsou části navíc
</commit_message>
<xml_diff>
--- a/03_MATURITA/01_Jednoduche_a_slozene_typy/StandardniDatoveTypy.pptx
+++ b/03_MATURITA/01_Jednoduche_a_slozene_typy/StandardniDatoveTypy.pptx
@@ -5,32 +5,33 @@
     <p:sldMasterId id="2147483648" r:id="rId1"/>
   </p:sldMasterIdLst>
   <p:notesMasterIdLst>
-    <p:notesMasterId r:id="rId25"/>
+    <p:notesMasterId r:id="rId26"/>
   </p:notesMasterIdLst>
   <p:sldIdLst>
     <p:sldId id="256" r:id="rId2"/>
-    <p:sldId id="262" r:id="rId3"/>
-    <p:sldId id="273" r:id="rId4"/>
-    <p:sldId id="276" r:id="rId5"/>
-    <p:sldId id="257" r:id="rId6"/>
-    <p:sldId id="258" r:id="rId7"/>
-    <p:sldId id="263" r:id="rId8"/>
-    <p:sldId id="259" r:id="rId9"/>
-    <p:sldId id="260" r:id="rId10"/>
-    <p:sldId id="261" r:id="rId11"/>
-    <p:sldId id="264" r:id="rId12"/>
-    <p:sldId id="265" r:id="rId13"/>
-    <p:sldId id="267" r:id="rId14"/>
-    <p:sldId id="266" r:id="rId15"/>
-    <p:sldId id="268" r:id="rId16"/>
-    <p:sldId id="269" r:id="rId17"/>
-    <p:sldId id="270" r:id="rId18"/>
-    <p:sldId id="272" r:id="rId19"/>
-    <p:sldId id="277" r:id="rId20"/>
-    <p:sldId id="271" r:id="rId21"/>
-    <p:sldId id="275" r:id="rId22"/>
-    <p:sldId id="278" r:id="rId23"/>
-    <p:sldId id="274" r:id="rId24"/>
+    <p:sldId id="279" r:id="rId3"/>
+    <p:sldId id="262" r:id="rId4"/>
+    <p:sldId id="273" r:id="rId5"/>
+    <p:sldId id="276" r:id="rId6"/>
+    <p:sldId id="257" r:id="rId7"/>
+    <p:sldId id="258" r:id="rId8"/>
+    <p:sldId id="263" r:id="rId9"/>
+    <p:sldId id="259" r:id="rId10"/>
+    <p:sldId id="260" r:id="rId11"/>
+    <p:sldId id="261" r:id="rId12"/>
+    <p:sldId id="264" r:id="rId13"/>
+    <p:sldId id="265" r:id="rId14"/>
+    <p:sldId id="267" r:id="rId15"/>
+    <p:sldId id="266" r:id="rId16"/>
+    <p:sldId id="268" r:id="rId17"/>
+    <p:sldId id="269" r:id="rId18"/>
+    <p:sldId id="270" r:id="rId19"/>
+    <p:sldId id="272" r:id="rId20"/>
+    <p:sldId id="277" r:id="rId21"/>
+    <p:sldId id="271" r:id="rId22"/>
+    <p:sldId id="275" r:id="rId23"/>
+    <p:sldId id="278" r:id="rId24"/>
+    <p:sldId id="274" r:id="rId25"/>
   </p:sldIdLst>
   <p:sldSz cx="12192000" cy="6858000"/>
   <p:notesSz cx="6858000" cy="9144000"/>
@@ -551,7 +552,7 @@
           <a:p>
             <a:fld id="{4514EFDE-C67E-4B46-B5A2-5FE0F82A80D0}" type="slidenum">
               <a:rPr lang="cs-CZ" smtClean="0"/>
-              <a:t>2</a:t>
+              <a:t>3</a:t>
             </a:fld>
             <a:endParaRPr lang="cs-CZ"/>
           </a:p>
@@ -635,7 +636,7 @@
           <a:p>
             <a:fld id="{4514EFDE-C67E-4B46-B5A2-5FE0F82A80D0}" type="slidenum">
               <a:rPr lang="cs-CZ" smtClean="0"/>
-              <a:t>11</a:t>
+              <a:t>12</a:t>
             </a:fld>
             <a:endParaRPr lang="cs-CZ"/>
           </a:p>
@@ -719,7 +720,7 @@
           <a:p>
             <a:fld id="{4514EFDE-C67E-4B46-B5A2-5FE0F82A80D0}" type="slidenum">
               <a:rPr lang="cs-CZ" smtClean="0"/>
-              <a:t>12</a:t>
+              <a:t>13</a:t>
             </a:fld>
             <a:endParaRPr lang="cs-CZ"/>
           </a:p>
@@ -4005,6 +4006,1424 @@
   <p:cSld>
     <p:spTree>
       <p:nvGrpSpPr>
+        <p:cNvPr id="1" name=""/>
+        <p:cNvGrpSpPr/>
+        <p:nvPr/>
+      </p:nvGrpSpPr>
+      <p:grpSpPr>
+        <a:xfrm>
+          <a:off x="0" y="0"/>
+          <a:ext cx="0" cy="0"/>
+          <a:chOff x="0" y="0"/>
+          <a:chExt cx="0" cy="0"/>
+        </a:xfrm>
+      </p:grpSpPr>
+      <p:sp>
+        <p:nvSpPr>
+          <p:cNvPr id="2" name="Nadpis 1">
+            <a:extLst>
+              <a:ext uri="{FF2B5EF4-FFF2-40B4-BE49-F238E27FC236}">
+                <a16:creationId xmlns:a16="http://schemas.microsoft.com/office/drawing/2014/main" id="{F7D93DF5-4BC0-2B15-3889-75B6505A408B}"/>
+              </a:ext>
+            </a:extLst>
+          </p:cNvPr>
+          <p:cNvSpPr>
+            <a:spLocks noGrp="1"/>
+          </p:cNvSpPr>
+          <p:nvPr>
+            <p:ph type="title"/>
+          </p:nvPr>
+        </p:nvSpPr>
+        <p:spPr/>
+        <p:txBody>
+          <a:bodyPr/>
+          <a:lstStyle/>
+          <a:p>
+            <a:r>
+              <a:rPr lang="cs-CZ" dirty="0"/>
+              <a:t>Základní jednoduché datové typy</a:t>
+            </a:r>
+          </a:p>
+        </p:txBody>
+      </p:sp>
+      <p:sp>
+        <p:nvSpPr>
+          <p:cNvPr id="3" name="Zástupný obsah 2">
+            <a:extLst>
+              <a:ext uri="{FF2B5EF4-FFF2-40B4-BE49-F238E27FC236}">
+                <a16:creationId xmlns:a16="http://schemas.microsoft.com/office/drawing/2014/main" id="{B1046E1E-20A0-2EA3-F4F9-878093D89111}"/>
+              </a:ext>
+            </a:extLst>
+          </p:cNvPr>
+          <p:cNvSpPr>
+            <a:spLocks noGrp="1"/>
+          </p:cNvSpPr>
+          <p:nvPr>
+            <p:ph idx="1"/>
+          </p:nvPr>
+        </p:nvSpPr>
+        <p:spPr>
+          <a:xfrm>
+            <a:off x="838200" y="1825625"/>
+            <a:ext cx="10515600" cy="718399"/>
+          </a:xfrm>
+        </p:spPr>
+        <p:txBody>
+          <a:bodyPr/>
+          <a:lstStyle/>
+          <a:p>
+            <a:r>
+              <a:rPr lang="cs-CZ" dirty="0"/>
+              <a:t>Celočíselné neznaménkové (</a:t>
+            </a:r>
+            <a:r>
+              <a:rPr lang="cs-CZ" dirty="0" err="1"/>
+              <a:t>unsigned</a:t>
+            </a:r>
+            <a:r>
+              <a:rPr lang="cs-CZ" dirty="0"/>
+              <a:t>) typy</a:t>
+            </a:r>
+          </a:p>
+          <a:p>
+            <a:endParaRPr lang="cs-CZ" dirty="0"/>
+          </a:p>
+        </p:txBody>
+      </p:sp>
+      <p:graphicFrame>
+        <p:nvGraphicFramePr>
+          <p:cNvPr id="4" name="Tabulka 3">
+            <a:extLst>
+              <a:ext uri="{FF2B5EF4-FFF2-40B4-BE49-F238E27FC236}">
+                <a16:creationId xmlns:a16="http://schemas.microsoft.com/office/drawing/2014/main" id="{8653E899-3479-1EB1-172B-323EDCC90B0C}"/>
+              </a:ext>
+            </a:extLst>
+          </p:cNvPr>
+          <p:cNvGraphicFramePr>
+            <a:graphicFrameLocks noGrp="1"/>
+          </p:cNvGraphicFramePr>
+          <p:nvPr>
+            <p:extLst>
+              <p:ext uri="{D42A27DB-BD31-4B8C-83A1-F6EECF244321}">
+                <p14:modId xmlns:p14="http://schemas.microsoft.com/office/powerpoint/2010/main" val="2276069598"/>
+              </p:ext>
+            </p:extLst>
+          </p:nvPr>
+        </p:nvGraphicFramePr>
+        <p:xfrm>
+          <a:off x="838200" y="3086894"/>
+          <a:ext cx="10515600" cy="1828800"/>
+        </p:xfrm>
+        <a:graphic>
+          <a:graphicData uri="http://schemas.openxmlformats.org/drawingml/2006/table">
+            <a:tbl>
+              <a:tblPr/>
+              <a:tblGrid>
+                <a:gridCol w="2628900">
+                  <a:extLst>
+                    <a:ext uri="{9D8B030D-6E8A-4147-A177-3AD203B41FA5}">
+                      <a16:colId xmlns:a16="http://schemas.microsoft.com/office/drawing/2014/main" val="1018705036"/>
+                    </a:ext>
+                  </a:extLst>
+                </a:gridCol>
+                <a:gridCol w="2628900">
+                  <a:extLst>
+                    <a:ext uri="{9D8B030D-6E8A-4147-A177-3AD203B41FA5}">
+                      <a16:colId xmlns:a16="http://schemas.microsoft.com/office/drawing/2014/main" val="2030810957"/>
+                    </a:ext>
+                  </a:extLst>
+                </a:gridCol>
+                <a:gridCol w="2628900">
+                  <a:extLst>
+                    <a:ext uri="{9D8B030D-6E8A-4147-A177-3AD203B41FA5}">
+                      <a16:colId xmlns:a16="http://schemas.microsoft.com/office/drawing/2014/main" val="220766276"/>
+                    </a:ext>
+                  </a:extLst>
+                </a:gridCol>
+                <a:gridCol w="2628900">
+                  <a:extLst>
+                    <a:ext uri="{9D8B030D-6E8A-4147-A177-3AD203B41FA5}">
+                      <a16:colId xmlns:a16="http://schemas.microsoft.com/office/drawing/2014/main" val="12375235"/>
+                    </a:ext>
+                  </a:extLst>
+                </a:gridCol>
+              </a:tblGrid>
+              <a:tr h="0">
+                <a:tc>
+                  <a:txBody>
+                    <a:bodyPr/>
+                    <a:lstStyle/>
+                    <a:p>
+                      <a:pPr>
+                        <a:buNone/>
+                      </a:pPr>
+                      <a:r>
+                        <a:rPr lang="cs-CZ" b="1">
+                          <a:effectLst/>
+                          <a:latin typeface="Google Sans Text"/>
+                        </a:rPr>
+                        <a:t>C# Typ</a:t>
+                      </a:r>
+                      <a:endParaRPr lang="cs-CZ">
+                        <a:effectLst/>
+                        <a:latin typeface="Google Sans Text"/>
+                      </a:endParaRPr>
+                    </a:p>
+                  </a:txBody>
+                  <a:tcPr anchor="ctr">
+                    <a:lnL w="9525" cap="flat" cmpd="sng" algn="ctr">
+                      <a:solidFill>
+                        <a:schemeClr val="bg1"/>
+                      </a:solidFill>
+                      <a:prstDash val="solid"/>
+                      <a:round/>
+                      <a:headEnd type="none" w="med" len="med"/>
+                      <a:tailEnd type="none" w="med" len="med"/>
+                    </a:lnL>
+                    <a:lnR w="9525" cap="flat" cmpd="sng" algn="ctr">
+                      <a:solidFill>
+                        <a:schemeClr val="bg1"/>
+                      </a:solidFill>
+                      <a:prstDash val="solid"/>
+                      <a:round/>
+                      <a:headEnd type="none" w="med" len="med"/>
+                      <a:tailEnd type="none" w="med" len="med"/>
+                    </a:lnR>
+                    <a:lnT w="9525" cap="flat" cmpd="sng" algn="ctr">
+                      <a:solidFill>
+                        <a:schemeClr val="bg1"/>
+                      </a:solidFill>
+                      <a:prstDash val="solid"/>
+                      <a:round/>
+                      <a:headEnd type="none" w="med" len="med"/>
+                      <a:tailEnd type="none" w="med" len="med"/>
+                    </a:lnT>
+                    <a:lnB w="9525" cap="flat" cmpd="sng" algn="ctr">
+                      <a:solidFill>
+                        <a:schemeClr val="bg1"/>
+                      </a:solidFill>
+                      <a:prstDash val="solid"/>
+                      <a:round/>
+                      <a:headEnd type="none" w="med" len="med"/>
+                      <a:tailEnd type="none" w="med" len="med"/>
+                    </a:lnB>
+                    <a:noFill/>
+                  </a:tcPr>
+                </a:tc>
+                <a:tc>
+                  <a:txBody>
+                    <a:bodyPr/>
+                    <a:lstStyle/>
+                    <a:p>
+                      <a:pPr>
+                        <a:buNone/>
+                      </a:pPr>
+                      <a:r>
+                        <a:rPr lang="cs-CZ" b="1">
+                          <a:effectLst/>
+                          <a:latin typeface="Google Sans Text"/>
+                        </a:rPr>
+                        <a:t>.NET Typ</a:t>
+                      </a:r>
+                      <a:endParaRPr lang="cs-CZ">
+                        <a:effectLst/>
+                        <a:latin typeface="Google Sans Text"/>
+                      </a:endParaRPr>
+                    </a:p>
+                  </a:txBody>
+                  <a:tcPr anchor="ctr">
+                    <a:lnL w="9525" cap="flat" cmpd="sng" algn="ctr">
+                      <a:solidFill>
+                        <a:schemeClr val="bg1"/>
+                      </a:solidFill>
+                      <a:prstDash val="solid"/>
+                      <a:round/>
+                      <a:headEnd type="none" w="med" len="med"/>
+                      <a:tailEnd type="none" w="med" len="med"/>
+                    </a:lnL>
+                    <a:lnR w="9525" cap="flat" cmpd="sng" algn="ctr">
+                      <a:solidFill>
+                        <a:schemeClr val="bg1"/>
+                      </a:solidFill>
+                      <a:prstDash val="solid"/>
+                      <a:round/>
+                      <a:headEnd type="none" w="med" len="med"/>
+                      <a:tailEnd type="none" w="med" len="med"/>
+                    </a:lnR>
+                    <a:lnT w="9525" cap="flat" cmpd="sng" algn="ctr">
+                      <a:solidFill>
+                        <a:schemeClr val="bg1"/>
+                      </a:solidFill>
+                      <a:prstDash val="solid"/>
+                      <a:round/>
+                      <a:headEnd type="none" w="med" len="med"/>
+                      <a:tailEnd type="none" w="med" len="med"/>
+                    </a:lnT>
+                    <a:lnB w="9525" cap="flat" cmpd="sng" algn="ctr">
+                      <a:solidFill>
+                        <a:schemeClr val="bg1"/>
+                      </a:solidFill>
+                      <a:prstDash val="solid"/>
+                      <a:round/>
+                      <a:headEnd type="none" w="med" len="med"/>
+                      <a:tailEnd type="none" w="med" len="med"/>
+                    </a:lnB>
+                    <a:noFill/>
+                  </a:tcPr>
+                </a:tc>
+                <a:tc>
+                  <a:txBody>
+                    <a:bodyPr/>
+                    <a:lstStyle/>
+                    <a:p>
+                      <a:pPr>
+                        <a:buNone/>
+                      </a:pPr>
+                      <a:r>
+                        <a:rPr lang="cs-CZ" b="1">
+                          <a:effectLst/>
+                          <a:latin typeface="Google Sans Text"/>
+                        </a:rPr>
+                        <a:t>Velikost (Byty)</a:t>
+                      </a:r>
+                      <a:endParaRPr lang="cs-CZ">
+                        <a:effectLst/>
+                        <a:latin typeface="Google Sans Text"/>
+                      </a:endParaRPr>
+                    </a:p>
+                  </a:txBody>
+                  <a:tcPr anchor="ctr">
+                    <a:lnL w="9525" cap="flat" cmpd="sng" algn="ctr">
+                      <a:solidFill>
+                        <a:schemeClr val="bg1"/>
+                      </a:solidFill>
+                      <a:prstDash val="solid"/>
+                      <a:round/>
+                      <a:headEnd type="none" w="med" len="med"/>
+                      <a:tailEnd type="none" w="med" len="med"/>
+                    </a:lnL>
+                    <a:lnR w="9525" cap="flat" cmpd="sng" algn="ctr">
+                      <a:solidFill>
+                        <a:schemeClr val="bg1"/>
+                      </a:solidFill>
+                      <a:prstDash val="solid"/>
+                      <a:round/>
+                      <a:headEnd type="none" w="med" len="med"/>
+                      <a:tailEnd type="none" w="med" len="med"/>
+                    </a:lnR>
+                    <a:lnT w="9525" cap="flat" cmpd="sng" algn="ctr">
+                      <a:solidFill>
+                        <a:schemeClr val="bg1"/>
+                      </a:solidFill>
+                      <a:prstDash val="solid"/>
+                      <a:round/>
+                      <a:headEnd type="none" w="med" len="med"/>
+                      <a:tailEnd type="none" w="med" len="med"/>
+                    </a:lnT>
+                    <a:lnB w="9525" cap="flat" cmpd="sng" algn="ctr">
+                      <a:solidFill>
+                        <a:schemeClr val="bg1"/>
+                      </a:solidFill>
+                      <a:prstDash val="solid"/>
+                      <a:round/>
+                      <a:headEnd type="none" w="med" len="med"/>
+                      <a:tailEnd type="none" w="med" len="med"/>
+                    </a:lnB>
+                    <a:noFill/>
+                  </a:tcPr>
+                </a:tc>
+                <a:tc>
+                  <a:txBody>
+                    <a:bodyPr/>
+                    <a:lstStyle/>
+                    <a:p>
+                      <a:pPr>
+                        <a:buNone/>
+                      </a:pPr>
+                      <a:r>
+                        <a:rPr lang="cs-CZ" b="1">
+                          <a:effectLst/>
+                          <a:latin typeface="Google Sans Text"/>
+                        </a:rPr>
+                        <a:t>Rozsah</a:t>
+                      </a:r>
+                      <a:endParaRPr lang="cs-CZ">
+                        <a:effectLst/>
+                        <a:latin typeface="Google Sans Text"/>
+                      </a:endParaRPr>
+                    </a:p>
+                  </a:txBody>
+                  <a:tcPr anchor="ctr">
+                    <a:lnL w="9525" cap="flat" cmpd="sng" algn="ctr">
+                      <a:solidFill>
+                        <a:schemeClr val="bg1"/>
+                      </a:solidFill>
+                      <a:prstDash val="solid"/>
+                      <a:round/>
+                      <a:headEnd type="none" w="med" len="med"/>
+                      <a:tailEnd type="none" w="med" len="med"/>
+                    </a:lnL>
+                    <a:lnR w="9525" cap="flat" cmpd="sng" algn="ctr">
+                      <a:solidFill>
+                        <a:schemeClr val="bg1"/>
+                      </a:solidFill>
+                      <a:prstDash val="solid"/>
+                      <a:round/>
+                      <a:headEnd type="none" w="med" len="med"/>
+                      <a:tailEnd type="none" w="med" len="med"/>
+                    </a:lnR>
+                    <a:lnT w="9525" cap="flat" cmpd="sng" algn="ctr">
+                      <a:solidFill>
+                        <a:schemeClr val="bg1"/>
+                      </a:solidFill>
+                      <a:prstDash val="solid"/>
+                      <a:round/>
+                      <a:headEnd type="none" w="med" len="med"/>
+                      <a:tailEnd type="none" w="med" len="med"/>
+                    </a:lnT>
+                    <a:lnB w="9525" cap="flat" cmpd="sng" algn="ctr">
+                      <a:solidFill>
+                        <a:schemeClr val="bg1"/>
+                      </a:solidFill>
+                      <a:prstDash val="solid"/>
+                      <a:round/>
+                      <a:headEnd type="none" w="med" len="med"/>
+                      <a:tailEnd type="none" w="med" len="med"/>
+                    </a:lnB>
+                    <a:noFill/>
+                  </a:tcPr>
+                </a:tc>
+                <a:extLst>
+                  <a:ext uri="{0D108BD9-81ED-4DB2-BD59-A6C34878D82A}">
+                    <a16:rowId xmlns:a16="http://schemas.microsoft.com/office/drawing/2014/main" val="1365557383"/>
+                  </a:ext>
+                </a:extLst>
+              </a:tr>
+              <a:tr h="0">
+                <a:tc>
+                  <a:txBody>
+                    <a:bodyPr/>
+                    <a:lstStyle/>
+                    <a:p>
+                      <a:pPr>
+                        <a:buNone/>
+                      </a:pPr>
+                      <a:r>
+                        <a:rPr lang="cs-CZ" b="1">
+                          <a:effectLst/>
+                          <a:latin typeface="Google Sans Text"/>
+                        </a:rPr>
+                        <a:t>byte</a:t>
+                      </a:r>
+                      <a:endParaRPr lang="cs-CZ">
+                        <a:effectLst/>
+                        <a:latin typeface="Google Sans Text"/>
+                      </a:endParaRPr>
+                    </a:p>
+                  </a:txBody>
+                  <a:tcPr anchor="ctr">
+                    <a:lnL w="9525" cap="flat" cmpd="sng" algn="ctr">
+                      <a:solidFill>
+                        <a:schemeClr val="bg1"/>
+                      </a:solidFill>
+                      <a:prstDash val="solid"/>
+                      <a:round/>
+                      <a:headEnd type="none" w="med" len="med"/>
+                      <a:tailEnd type="none" w="med" len="med"/>
+                    </a:lnL>
+                    <a:lnR w="9525" cap="flat" cmpd="sng" algn="ctr">
+                      <a:solidFill>
+                        <a:schemeClr val="bg1"/>
+                      </a:solidFill>
+                      <a:prstDash val="solid"/>
+                      <a:round/>
+                      <a:headEnd type="none" w="med" len="med"/>
+                      <a:tailEnd type="none" w="med" len="med"/>
+                    </a:lnR>
+                    <a:lnT w="9525" cap="flat" cmpd="sng" algn="ctr">
+                      <a:solidFill>
+                        <a:schemeClr val="bg1"/>
+                      </a:solidFill>
+                      <a:prstDash val="solid"/>
+                      <a:round/>
+                      <a:headEnd type="none" w="med" len="med"/>
+                      <a:tailEnd type="none" w="med" len="med"/>
+                    </a:lnT>
+                    <a:lnB w="9525" cap="flat" cmpd="sng" algn="ctr">
+                      <a:solidFill>
+                        <a:schemeClr val="bg1"/>
+                      </a:solidFill>
+                      <a:prstDash val="solid"/>
+                      <a:round/>
+                      <a:headEnd type="none" w="med" len="med"/>
+                      <a:tailEnd type="none" w="med" len="med"/>
+                    </a:lnB>
+                    <a:noFill/>
+                  </a:tcPr>
+                </a:tc>
+                <a:tc>
+                  <a:txBody>
+                    <a:bodyPr/>
+                    <a:lstStyle/>
+                    <a:p>
+                      <a:pPr>
+                        <a:buNone/>
+                      </a:pPr>
+                      <a:r>
+                        <a:rPr lang="cs-CZ">
+                          <a:effectLst/>
+                          <a:latin typeface="Google Sans Text"/>
+                        </a:rPr>
+                        <a:t>Byte</a:t>
+                      </a:r>
+                    </a:p>
+                  </a:txBody>
+                  <a:tcPr anchor="ctr">
+                    <a:lnL w="9525" cap="flat" cmpd="sng" algn="ctr">
+                      <a:solidFill>
+                        <a:schemeClr val="bg1"/>
+                      </a:solidFill>
+                      <a:prstDash val="solid"/>
+                      <a:round/>
+                      <a:headEnd type="none" w="med" len="med"/>
+                      <a:tailEnd type="none" w="med" len="med"/>
+                    </a:lnL>
+                    <a:lnR w="9525" cap="flat" cmpd="sng" algn="ctr">
+                      <a:solidFill>
+                        <a:schemeClr val="bg1"/>
+                      </a:solidFill>
+                      <a:prstDash val="solid"/>
+                      <a:round/>
+                      <a:headEnd type="none" w="med" len="med"/>
+                      <a:tailEnd type="none" w="med" len="med"/>
+                    </a:lnR>
+                    <a:lnT w="9525" cap="flat" cmpd="sng" algn="ctr">
+                      <a:solidFill>
+                        <a:schemeClr val="bg1"/>
+                      </a:solidFill>
+                      <a:prstDash val="solid"/>
+                      <a:round/>
+                      <a:headEnd type="none" w="med" len="med"/>
+                      <a:tailEnd type="none" w="med" len="med"/>
+                    </a:lnT>
+                    <a:lnB w="9525" cap="flat" cmpd="sng" algn="ctr">
+                      <a:solidFill>
+                        <a:schemeClr val="bg1"/>
+                      </a:solidFill>
+                      <a:prstDash val="solid"/>
+                      <a:round/>
+                      <a:headEnd type="none" w="med" len="med"/>
+                      <a:tailEnd type="none" w="med" len="med"/>
+                    </a:lnB>
+                    <a:noFill/>
+                  </a:tcPr>
+                </a:tc>
+                <a:tc>
+                  <a:txBody>
+                    <a:bodyPr/>
+                    <a:lstStyle/>
+                    <a:p>
+                      <a:pPr>
+                        <a:buNone/>
+                      </a:pPr>
+                      <a:r>
+                        <a:rPr lang="cs-CZ">
+                          <a:effectLst/>
+                          <a:latin typeface="Google Sans Text"/>
+                        </a:rPr>
+                        <a:t>1 B</a:t>
+                      </a:r>
+                    </a:p>
+                  </a:txBody>
+                  <a:tcPr anchor="ctr">
+                    <a:lnL w="9525" cap="flat" cmpd="sng" algn="ctr">
+                      <a:solidFill>
+                        <a:schemeClr val="bg1"/>
+                      </a:solidFill>
+                      <a:prstDash val="solid"/>
+                      <a:round/>
+                      <a:headEnd type="none" w="med" len="med"/>
+                      <a:tailEnd type="none" w="med" len="med"/>
+                    </a:lnL>
+                    <a:lnR w="9525" cap="flat" cmpd="sng" algn="ctr">
+                      <a:solidFill>
+                        <a:schemeClr val="bg1"/>
+                      </a:solidFill>
+                      <a:prstDash val="solid"/>
+                      <a:round/>
+                      <a:headEnd type="none" w="med" len="med"/>
+                      <a:tailEnd type="none" w="med" len="med"/>
+                    </a:lnR>
+                    <a:lnT w="9525" cap="flat" cmpd="sng" algn="ctr">
+                      <a:solidFill>
+                        <a:schemeClr val="bg1"/>
+                      </a:solidFill>
+                      <a:prstDash val="solid"/>
+                      <a:round/>
+                      <a:headEnd type="none" w="med" len="med"/>
+                      <a:tailEnd type="none" w="med" len="med"/>
+                    </a:lnT>
+                    <a:lnB w="9525" cap="flat" cmpd="sng" algn="ctr">
+                      <a:solidFill>
+                        <a:schemeClr val="bg1"/>
+                      </a:solidFill>
+                      <a:prstDash val="solid"/>
+                      <a:round/>
+                      <a:headEnd type="none" w="med" len="med"/>
+                      <a:tailEnd type="none" w="med" len="med"/>
+                    </a:lnB>
+                    <a:noFill/>
+                  </a:tcPr>
+                </a:tc>
+                <a:tc>
+                  <a:txBody>
+                    <a:bodyPr/>
+                    <a:lstStyle/>
+                    <a:p>
+                      <a:pPr>
+                        <a:buNone/>
+                      </a:pPr>
+                      <a:r>
+                        <a:rPr lang="cs-CZ">
+                          <a:effectLst/>
+                          <a:latin typeface="Google Sans Text"/>
+                        </a:rPr>
+                        <a:t>0 až 255</a:t>
+                      </a:r>
+                    </a:p>
+                  </a:txBody>
+                  <a:tcPr anchor="ctr">
+                    <a:lnL w="9525" cap="flat" cmpd="sng" algn="ctr">
+                      <a:solidFill>
+                        <a:schemeClr val="bg1"/>
+                      </a:solidFill>
+                      <a:prstDash val="solid"/>
+                      <a:round/>
+                      <a:headEnd type="none" w="med" len="med"/>
+                      <a:tailEnd type="none" w="med" len="med"/>
+                    </a:lnL>
+                    <a:lnR w="9525" cap="flat" cmpd="sng" algn="ctr">
+                      <a:solidFill>
+                        <a:schemeClr val="bg1"/>
+                      </a:solidFill>
+                      <a:prstDash val="solid"/>
+                      <a:round/>
+                      <a:headEnd type="none" w="med" len="med"/>
+                      <a:tailEnd type="none" w="med" len="med"/>
+                    </a:lnR>
+                    <a:lnT w="9525" cap="flat" cmpd="sng" algn="ctr">
+                      <a:solidFill>
+                        <a:schemeClr val="bg1"/>
+                      </a:solidFill>
+                      <a:prstDash val="solid"/>
+                      <a:round/>
+                      <a:headEnd type="none" w="med" len="med"/>
+                      <a:tailEnd type="none" w="med" len="med"/>
+                    </a:lnT>
+                    <a:lnB w="9525" cap="flat" cmpd="sng" algn="ctr">
+                      <a:solidFill>
+                        <a:schemeClr val="bg1"/>
+                      </a:solidFill>
+                      <a:prstDash val="solid"/>
+                      <a:round/>
+                      <a:headEnd type="none" w="med" len="med"/>
+                      <a:tailEnd type="none" w="med" len="med"/>
+                    </a:lnB>
+                    <a:noFill/>
+                  </a:tcPr>
+                </a:tc>
+                <a:extLst>
+                  <a:ext uri="{0D108BD9-81ED-4DB2-BD59-A6C34878D82A}">
+                    <a16:rowId xmlns:a16="http://schemas.microsoft.com/office/drawing/2014/main" val="3477171418"/>
+                  </a:ext>
+                </a:extLst>
+              </a:tr>
+              <a:tr h="0">
+                <a:tc>
+                  <a:txBody>
+                    <a:bodyPr/>
+                    <a:lstStyle/>
+                    <a:p>
+                      <a:pPr>
+                        <a:buNone/>
+                      </a:pPr>
+                      <a:r>
+                        <a:rPr lang="cs-CZ" b="1">
+                          <a:effectLst/>
+                          <a:latin typeface="Google Sans Text"/>
+                        </a:rPr>
+                        <a:t>ushort</a:t>
+                      </a:r>
+                      <a:endParaRPr lang="cs-CZ">
+                        <a:effectLst/>
+                        <a:latin typeface="Google Sans Text"/>
+                      </a:endParaRPr>
+                    </a:p>
+                  </a:txBody>
+                  <a:tcPr anchor="ctr">
+                    <a:lnL w="9525" cap="flat" cmpd="sng" algn="ctr">
+                      <a:solidFill>
+                        <a:schemeClr val="bg1"/>
+                      </a:solidFill>
+                      <a:prstDash val="solid"/>
+                      <a:round/>
+                      <a:headEnd type="none" w="med" len="med"/>
+                      <a:tailEnd type="none" w="med" len="med"/>
+                    </a:lnL>
+                    <a:lnR w="9525" cap="flat" cmpd="sng" algn="ctr">
+                      <a:solidFill>
+                        <a:schemeClr val="bg1"/>
+                      </a:solidFill>
+                      <a:prstDash val="solid"/>
+                      <a:round/>
+                      <a:headEnd type="none" w="med" len="med"/>
+                      <a:tailEnd type="none" w="med" len="med"/>
+                    </a:lnR>
+                    <a:lnT w="9525" cap="flat" cmpd="sng" algn="ctr">
+                      <a:solidFill>
+                        <a:schemeClr val="bg1"/>
+                      </a:solidFill>
+                      <a:prstDash val="solid"/>
+                      <a:round/>
+                      <a:headEnd type="none" w="med" len="med"/>
+                      <a:tailEnd type="none" w="med" len="med"/>
+                    </a:lnT>
+                    <a:lnB w="9525" cap="flat" cmpd="sng" algn="ctr">
+                      <a:solidFill>
+                        <a:schemeClr val="bg1"/>
+                      </a:solidFill>
+                      <a:prstDash val="solid"/>
+                      <a:round/>
+                      <a:headEnd type="none" w="med" len="med"/>
+                      <a:tailEnd type="none" w="med" len="med"/>
+                    </a:lnB>
+                    <a:solidFill>
+                      <a:schemeClr val="accent6">
+                        <a:lumMod val="20000"/>
+                        <a:lumOff val="80000"/>
+                      </a:schemeClr>
+                    </a:solidFill>
+                  </a:tcPr>
+                </a:tc>
+                <a:tc>
+                  <a:txBody>
+                    <a:bodyPr/>
+                    <a:lstStyle/>
+                    <a:p>
+                      <a:pPr>
+                        <a:buNone/>
+                      </a:pPr>
+                      <a:r>
+                        <a:rPr lang="cs-CZ">
+                          <a:effectLst/>
+                          <a:latin typeface="Google Sans Text"/>
+                        </a:rPr>
+                        <a:t>UInt16</a:t>
+                      </a:r>
+                    </a:p>
+                  </a:txBody>
+                  <a:tcPr anchor="ctr">
+                    <a:lnL w="9525" cap="flat" cmpd="sng" algn="ctr">
+                      <a:solidFill>
+                        <a:schemeClr val="bg1"/>
+                      </a:solidFill>
+                      <a:prstDash val="solid"/>
+                      <a:round/>
+                      <a:headEnd type="none" w="med" len="med"/>
+                      <a:tailEnd type="none" w="med" len="med"/>
+                    </a:lnL>
+                    <a:lnR w="9525" cap="flat" cmpd="sng" algn="ctr">
+                      <a:solidFill>
+                        <a:schemeClr val="bg1"/>
+                      </a:solidFill>
+                      <a:prstDash val="solid"/>
+                      <a:round/>
+                      <a:headEnd type="none" w="med" len="med"/>
+                      <a:tailEnd type="none" w="med" len="med"/>
+                    </a:lnR>
+                    <a:lnT w="9525" cap="flat" cmpd="sng" algn="ctr">
+                      <a:solidFill>
+                        <a:schemeClr val="bg1"/>
+                      </a:solidFill>
+                      <a:prstDash val="solid"/>
+                      <a:round/>
+                      <a:headEnd type="none" w="med" len="med"/>
+                      <a:tailEnd type="none" w="med" len="med"/>
+                    </a:lnT>
+                    <a:lnB w="9525" cap="flat" cmpd="sng" algn="ctr">
+                      <a:solidFill>
+                        <a:schemeClr val="bg1"/>
+                      </a:solidFill>
+                      <a:prstDash val="solid"/>
+                      <a:round/>
+                      <a:headEnd type="none" w="med" len="med"/>
+                      <a:tailEnd type="none" w="med" len="med"/>
+                    </a:lnB>
+                    <a:solidFill>
+                      <a:schemeClr val="accent6">
+                        <a:lumMod val="20000"/>
+                        <a:lumOff val="80000"/>
+                      </a:schemeClr>
+                    </a:solidFill>
+                  </a:tcPr>
+                </a:tc>
+                <a:tc>
+                  <a:txBody>
+                    <a:bodyPr/>
+                    <a:lstStyle/>
+                    <a:p>
+                      <a:pPr>
+                        <a:buNone/>
+                      </a:pPr>
+                      <a:r>
+                        <a:rPr lang="cs-CZ">
+                          <a:effectLst/>
+                          <a:latin typeface="Google Sans Text"/>
+                        </a:rPr>
+                        <a:t>2 B</a:t>
+                      </a:r>
+                    </a:p>
+                  </a:txBody>
+                  <a:tcPr anchor="ctr">
+                    <a:lnL w="9525" cap="flat" cmpd="sng" algn="ctr">
+                      <a:solidFill>
+                        <a:schemeClr val="bg1"/>
+                      </a:solidFill>
+                      <a:prstDash val="solid"/>
+                      <a:round/>
+                      <a:headEnd type="none" w="med" len="med"/>
+                      <a:tailEnd type="none" w="med" len="med"/>
+                    </a:lnL>
+                    <a:lnR w="9525" cap="flat" cmpd="sng" algn="ctr">
+                      <a:solidFill>
+                        <a:schemeClr val="bg1"/>
+                      </a:solidFill>
+                      <a:prstDash val="solid"/>
+                      <a:round/>
+                      <a:headEnd type="none" w="med" len="med"/>
+                      <a:tailEnd type="none" w="med" len="med"/>
+                    </a:lnR>
+                    <a:lnT w="9525" cap="flat" cmpd="sng" algn="ctr">
+                      <a:solidFill>
+                        <a:schemeClr val="bg1"/>
+                      </a:solidFill>
+                      <a:prstDash val="solid"/>
+                      <a:round/>
+                      <a:headEnd type="none" w="med" len="med"/>
+                      <a:tailEnd type="none" w="med" len="med"/>
+                    </a:lnT>
+                    <a:lnB w="9525" cap="flat" cmpd="sng" algn="ctr">
+                      <a:solidFill>
+                        <a:schemeClr val="bg1"/>
+                      </a:solidFill>
+                      <a:prstDash val="solid"/>
+                      <a:round/>
+                      <a:headEnd type="none" w="med" len="med"/>
+                      <a:tailEnd type="none" w="med" len="med"/>
+                    </a:lnB>
+                    <a:solidFill>
+                      <a:schemeClr val="accent6">
+                        <a:lumMod val="20000"/>
+                        <a:lumOff val="80000"/>
+                      </a:schemeClr>
+                    </a:solidFill>
+                  </a:tcPr>
+                </a:tc>
+                <a:tc>
+                  <a:txBody>
+                    <a:bodyPr/>
+                    <a:lstStyle/>
+                    <a:p>
+                      <a:pPr>
+                        <a:buNone/>
+                      </a:pPr>
+                      <a:r>
+                        <a:rPr lang="cs-CZ" dirty="0">
+                          <a:effectLst/>
+                          <a:latin typeface="Google Sans Text"/>
+                        </a:rPr>
+                        <a:t>0 až 65 535</a:t>
+                      </a:r>
+                    </a:p>
+                  </a:txBody>
+                  <a:tcPr anchor="ctr">
+                    <a:lnL w="9525" cap="flat" cmpd="sng" algn="ctr">
+                      <a:solidFill>
+                        <a:schemeClr val="bg1"/>
+                      </a:solidFill>
+                      <a:prstDash val="solid"/>
+                      <a:round/>
+                      <a:headEnd type="none" w="med" len="med"/>
+                      <a:tailEnd type="none" w="med" len="med"/>
+                    </a:lnL>
+                    <a:lnR w="9525" cap="flat" cmpd="sng" algn="ctr">
+                      <a:solidFill>
+                        <a:schemeClr val="bg1"/>
+                      </a:solidFill>
+                      <a:prstDash val="solid"/>
+                      <a:round/>
+                      <a:headEnd type="none" w="med" len="med"/>
+                      <a:tailEnd type="none" w="med" len="med"/>
+                    </a:lnR>
+                    <a:lnT w="9525" cap="flat" cmpd="sng" algn="ctr">
+                      <a:solidFill>
+                        <a:schemeClr val="bg1"/>
+                      </a:solidFill>
+                      <a:prstDash val="solid"/>
+                      <a:round/>
+                      <a:headEnd type="none" w="med" len="med"/>
+                      <a:tailEnd type="none" w="med" len="med"/>
+                    </a:lnT>
+                    <a:lnB w="9525" cap="flat" cmpd="sng" algn="ctr">
+                      <a:solidFill>
+                        <a:schemeClr val="bg1"/>
+                      </a:solidFill>
+                      <a:prstDash val="solid"/>
+                      <a:round/>
+                      <a:headEnd type="none" w="med" len="med"/>
+                      <a:tailEnd type="none" w="med" len="med"/>
+                    </a:lnB>
+                    <a:solidFill>
+                      <a:schemeClr val="accent6">
+                        <a:lumMod val="20000"/>
+                        <a:lumOff val="80000"/>
+                      </a:schemeClr>
+                    </a:solidFill>
+                  </a:tcPr>
+                </a:tc>
+                <a:extLst>
+                  <a:ext uri="{0D108BD9-81ED-4DB2-BD59-A6C34878D82A}">
+                    <a16:rowId xmlns:a16="http://schemas.microsoft.com/office/drawing/2014/main" val="1685387875"/>
+                  </a:ext>
+                </a:extLst>
+              </a:tr>
+              <a:tr h="0">
+                <a:tc>
+                  <a:txBody>
+                    <a:bodyPr/>
+                    <a:lstStyle/>
+                    <a:p>
+                      <a:pPr>
+                        <a:buNone/>
+                      </a:pPr>
+                      <a:r>
+                        <a:rPr lang="cs-CZ" b="1">
+                          <a:effectLst/>
+                          <a:latin typeface="Google Sans Text"/>
+                        </a:rPr>
+                        <a:t>uint</a:t>
+                      </a:r>
+                      <a:endParaRPr lang="cs-CZ">
+                        <a:effectLst/>
+                        <a:latin typeface="Google Sans Text"/>
+                      </a:endParaRPr>
+                    </a:p>
+                  </a:txBody>
+                  <a:tcPr anchor="ctr">
+                    <a:lnL w="9525" cap="flat" cmpd="sng" algn="ctr">
+                      <a:solidFill>
+                        <a:schemeClr val="bg1"/>
+                      </a:solidFill>
+                      <a:prstDash val="solid"/>
+                      <a:round/>
+                      <a:headEnd type="none" w="med" len="med"/>
+                      <a:tailEnd type="none" w="med" len="med"/>
+                    </a:lnL>
+                    <a:lnR w="9525" cap="flat" cmpd="sng" algn="ctr">
+                      <a:solidFill>
+                        <a:schemeClr val="bg1"/>
+                      </a:solidFill>
+                      <a:prstDash val="solid"/>
+                      <a:round/>
+                      <a:headEnd type="none" w="med" len="med"/>
+                      <a:tailEnd type="none" w="med" len="med"/>
+                    </a:lnR>
+                    <a:lnT w="9525" cap="flat" cmpd="sng" algn="ctr">
+                      <a:solidFill>
+                        <a:schemeClr val="bg1"/>
+                      </a:solidFill>
+                      <a:prstDash val="solid"/>
+                      <a:round/>
+                      <a:headEnd type="none" w="med" len="med"/>
+                      <a:tailEnd type="none" w="med" len="med"/>
+                    </a:lnT>
+                    <a:lnB w="9525" cap="flat" cmpd="sng" algn="ctr">
+                      <a:solidFill>
+                        <a:schemeClr val="bg1"/>
+                      </a:solidFill>
+                      <a:prstDash val="solid"/>
+                      <a:round/>
+                      <a:headEnd type="none" w="med" len="med"/>
+                      <a:tailEnd type="none" w="med" len="med"/>
+                    </a:lnB>
+                    <a:noFill/>
+                  </a:tcPr>
+                </a:tc>
+                <a:tc>
+                  <a:txBody>
+                    <a:bodyPr/>
+                    <a:lstStyle/>
+                    <a:p>
+                      <a:pPr>
+                        <a:buNone/>
+                      </a:pPr>
+                      <a:r>
+                        <a:rPr lang="cs-CZ">
+                          <a:effectLst/>
+                          <a:latin typeface="Google Sans Text"/>
+                        </a:rPr>
+                        <a:t>UInt32</a:t>
+                      </a:r>
+                    </a:p>
+                  </a:txBody>
+                  <a:tcPr anchor="ctr">
+                    <a:lnL w="9525" cap="flat" cmpd="sng" algn="ctr">
+                      <a:solidFill>
+                        <a:schemeClr val="bg1"/>
+                      </a:solidFill>
+                      <a:prstDash val="solid"/>
+                      <a:round/>
+                      <a:headEnd type="none" w="med" len="med"/>
+                      <a:tailEnd type="none" w="med" len="med"/>
+                    </a:lnL>
+                    <a:lnR w="9525" cap="flat" cmpd="sng" algn="ctr">
+                      <a:solidFill>
+                        <a:schemeClr val="bg1"/>
+                      </a:solidFill>
+                      <a:prstDash val="solid"/>
+                      <a:round/>
+                      <a:headEnd type="none" w="med" len="med"/>
+                      <a:tailEnd type="none" w="med" len="med"/>
+                    </a:lnR>
+                    <a:lnT w="9525" cap="flat" cmpd="sng" algn="ctr">
+                      <a:solidFill>
+                        <a:schemeClr val="bg1"/>
+                      </a:solidFill>
+                      <a:prstDash val="solid"/>
+                      <a:round/>
+                      <a:headEnd type="none" w="med" len="med"/>
+                      <a:tailEnd type="none" w="med" len="med"/>
+                    </a:lnT>
+                    <a:lnB w="9525" cap="flat" cmpd="sng" algn="ctr">
+                      <a:solidFill>
+                        <a:schemeClr val="bg1"/>
+                      </a:solidFill>
+                      <a:prstDash val="solid"/>
+                      <a:round/>
+                      <a:headEnd type="none" w="med" len="med"/>
+                      <a:tailEnd type="none" w="med" len="med"/>
+                    </a:lnB>
+                    <a:noFill/>
+                  </a:tcPr>
+                </a:tc>
+                <a:tc>
+                  <a:txBody>
+                    <a:bodyPr/>
+                    <a:lstStyle/>
+                    <a:p>
+                      <a:pPr>
+                        <a:buNone/>
+                      </a:pPr>
+                      <a:r>
+                        <a:rPr lang="cs-CZ">
+                          <a:effectLst/>
+                          <a:latin typeface="Google Sans Text"/>
+                        </a:rPr>
+                        <a:t>4 B</a:t>
+                      </a:r>
+                    </a:p>
+                  </a:txBody>
+                  <a:tcPr anchor="ctr">
+                    <a:lnL w="9525" cap="flat" cmpd="sng" algn="ctr">
+                      <a:solidFill>
+                        <a:schemeClr val="bg1"/>
+                      </a:solidFill>
+                      <a:prstDash val="solid"/>
+                      <a:round/>
+                      <a:headEnd type="none" w="med" len="med"/>
+                      <a:tailEnd type="none" w="med" len="med"/>
+                    </a:lnL>
+                    <a:lnR w="9525" cap="flat" cmpd="sng" algn="ctr">
+                      <a:solidFill>
+                        <a:schemeClr val="bg1"/>
+                      </a:solidFill>
+                      <a:prstDash val="solid"/>
+                      <a:round/>
+                      <a:headEnd type="none" w="med" len="med"/>
+                      <a:tailEnd type="none" w="med" len="med"/>
+                    </a:lnR>
+                    <a:lnT w="9525" cap="flat" cmpd="sng" algn="ctr">
+                      <a:solidFill>
+                        <a:schemeClr val="bg1"/>
+                      </a:solidFill>
+                      <a:prstDash val="solid"/>
+                      <a:round/>
+                      <a:headEnd type="none" w="med" len="med"/>
+                      <a:tailEnd type="none" w="med" len="med"/>
+                    </a:lnT>
+                    <a:lnB w="9525" cap="flat" cmpd="sng" algn="ctr">
+                      <a:solidFill>
+                        <a:schemeClr val="bg1"/>
+                      </a:solidFill>
+                      <a:prstDash val="solid"/>
+                      <a:round/>
+                      <a:headEnd type="none" w="med" len="med"/>
+                      <a:tailEnd type="none" w="med" len="med"/>
+                    </a:lnB>
+                    <a:noFill/>
+                  </a:tcPr>
+                </a:tc>
+                <a:tc>
+                  <a:txBody>
+                    <a:bodyPr/>
+                    <a:lstStyle/>
+                    <a:p>
+                      <a:pPr>
+                        <a:buNone/>
+                      </a:pPr>
+                      <a:r>
+                        <a:rPr lang="cs-CZ" dirty="0">
+                          <a:effectLst/>
+                          <a:highlight>
+                            <a:srgbClr val="FFFF00"/>
+                          </a:highlight>
+                          <a:latin typeface="Google Sans Text"/>
+                        </a:rPr>
+                        <a:t>0 až 4,2 mld. </a:t>
+                      </a:r>
+                      <a:endParaRPr lang="cs-CZ" dirty="0">
+                        <a:effectLst/>
+                        <a:latin typeface="Google Sans Text"/>
+                      </a:endParaRPr>
+                    </a:p>
+                  </a:txBody>
+                  <a:tcPr anchor="ctr">
+                    <a:lnL w="9525" cap="flat" cmpd="sng" algn="ctr">
+                      <a:solidFill>
+                        <a:schemeClr val="bg1"/>
+                      </a:solidFill>
+                      <a:prstDash val="solid"/>
+                      <a:round/>
+                      <a:headEnd type="none" w="med" len="med"/>
+                      <a:tailEnd type="none" w="med" len="med"/>
+                    </a:lnL>
+                    <a:lnR w="9525" cap="flat" cmpd="sng" algn="ctr">
+                      <a:solidFill>
+                        <a:schemeClr val="bg1"/>
+                      </a:solidFill>
+                      <a:prstDash val="solid"/>
+                      <a:round/>
+                      <a:headEnd type="none" w="med" len="med"/>
+                      <a:tailEnd type="none" w="med" len="med"/>
+                    </a:lnR>
+                    <a:lnT w="9525" cap="flat" cmpd="sng" algn="ctr">
+                      <a:solidFill>
+                        <a:schemeClr val="bg1"/>
+                      </a:solidFill>
+                      <a:prstDash val="solid"/>
+                      <a:round/>
+                      <a:headEnd type="none" w="med" len="med"/>
+                      <a:tailEnd type="none" w="med" len="med"/>
+                    </a:lnT>
+                    <a:lnB w="9525" cap="flat" cmpd="sng" algn="ctr">
+                      <a:solidFill>
+                        <a:schemeClr val="bg1"/>
+                      </a:solidFill>
+                      <a:prstDash val="solid"/>
+                      <a:round/>
+                      <a:headEnd type="none" w="med" len="med"/>
+                      <a:tailEnd type="none" w="med" len="med"/>
+                    </a:lnB>
+                    <a:noFill/>
+                  </a:tcPr>
+                </a:tc>
+                <a:extLst>
+                  <a:ext uri="{0D108BD9-81ED-4DB2-BD59-A6C34878D82A}">
+                    <a16:rowId xmlns:a16="http://schemas.microsoft.com/office/drawing/2014/main" val="985762972"/>
+                  </a:ext>
+                </a:extLst>
+              </a:tr>
+              <a:tr h="0">
+                <a:tc>
+                  <a:txBody>
+                    <a:bodyPr/>
+                    <a:lstStyle/>
+                    <a:p>
+                      <a:pPr>
+                        <a:buNone/>
+                      </a:pPr>
+                      <a:r>
+                        <a:rPr lang="cs-CZ" b="1">
+                          <a:effectLst/>
+                          <a:latin typeface="Google Sans Text"/>
+                        </a:rPr>
+                        <a:t>ulong</a:t>
+                      </a:r>
+                      <a:endParaRPr lang="cs-CZ">
+                        <a:effectLst/>
+                        <a:latin typeface="Google Sans Text"/>
+                      </a:endParaRPr>
+                    </a:p>
+                  </a:txBody>
+                  <a:tcPr anchor="ctr">
+                    <a:lnL w="9525" cap="flat" cmpd="sng" algn="ctr">
+                      <a:solidFill>
+                        <a:schemeClr val="bg1"/>
+                      </a:solidFill>
+                      <a:prstDash val="solid"/>
+                      <a:round/>
+                      <a:headEnd type="none" w="med" len="med"/>
+                      <a:tailEnd type="none" w="med" len="med"/>
+                    </a:lnL>
+                    <a:lnR w="9525" cap="flat" cmpd="sng" algn="ctr">
+                      <a:solidFill>
+                        <a:schemeClr val="bg1"/>
+                      </a:solidFill>
+                      <a:prstDash val="solid"/>
+                      <a:round/>
+                      <a:headEnd type="none" w="med" len="med"/>
+                      <a:tailEnd type="none" w="med" len="med"/>
+                    </a:lnR>
+                    <a:lnT w="9525" cap="flat" cmpd="sng" algn="ctr">
+                      <a:solidFill>
+                        <a:schemeClr val="bg1"/>
+                      </a:solidFill>
+                      <a:prstDash val="solid"/>
+                      <a:round/>
+                      <a:headEnd type="none" w="med" len="med"/>
+                      <a:tailEnd type="none" w="med" len="med"/>
+                    </a:lnT>
+                    <a:lnB w="9525" cap="flat" cmpd="sng" algn="ctr">
+                      <a:solidFill>
+                        <a:schemeClr val="bg1"/>
+                      </a:solidFill>
+                      <a:prstDash val="solid"/>
+                      <a:round/>
+                      <a:headEnd type="none" w="med" len="med"/>
+                      <a:tailEnd type="none" w="med" len="med"/>
+                    </a:lnB>
+                    <a:solidFill>
+                      <a:schemeClr val="accent6">
+                        <a:lumMod val="20000"/>
+                        <a:lumOff val="80000"/>
+                      </a:schemeClr>
+                    </a:solidFill>
+                  </a:tcPr>
+                </a:tc>
+                <a:tc>
+                  <a:txBody>
+                    <a:bodyPr/>
+                    <a:lstStyle/>
+                    <a:p>
+                      <a:pPr>
+                        <a:buNone/>
+                      </a:pPr>
+                      <a:r>
+                        <a:rPr lang="cs-CZ">
+                          <a:effectLst/>
+                          <a:latin typeface="Google Sans Text"/>
+                        </a:rPr>
+                        <a:t>UInt64</a:t>
+                      </a:r>
+                    </a:p>
+                  </a:txBody>
+                  <a:tcPr anchor="ctr">
+                    <a:lnL w="9525" cap="flat" cmpd="sng" algn="ctr">
+                      <a:solidFill>
+                        <a:schemeClr val="bg1"/>
+                      </a:solidFill>
+                      <a:prstDash val="solid"/>
+                      <a:round/>
+                      <a:headEnd type="none" w="med" len="med"/>
+                      <a:tailEnd type="none" w="med" len="med"/>
+                    </a:lnL>
+                    <a:lnR w="9525" cap="flat" cmpd="sng" algn="ctr">
+                      <a:solidFill>
+                        <a:schemeClr val="bg1"/>
+                      </a:solidFill>
+                      <a:prstDash val="solid"/>
+                      <a:round/>
+                      <a:headEnd type="none" w="med" len="med"/>
+                      <a:tailEnd type="none" w="med" len="med"/>
+                    </a:lnR>
+                    <a:lnT w="9525" cap="flat" cmpd="sng" algn="ctr">
+                      <a:solidFill>
+                        <a:schemeClr val="bg1"/>
+                      </a:solidFill>
+                      <a:prstDash val="solid"/>
+                      <a:round/>
+                      <a:headEnd type="none" w="med" len="med"/>
+                      <a:tailEnd type="none" w="med" len="med"/>
+                    </a:lnT>
+                    <a:lnB w="9525" cap="flat" cmpd="sng" algn="ctr">
+                      <a:solidFill>
+                        <a:schemeClr val="bg1"/>
+                      </a:solidFill>
+                      <a:prstDash val="solid"/>
+                      <a:round/>
+                      <a:headEnd type="none" w="med" len="med"/>
+                      <a:tailEnd type="none" w="med" len="med"/>
+                    </a:lnB>
+                    <a:solidFill>
+                      <a:schemeClr val="accent6">
+                        <a:lumMod val="20000"/>
+                        <a:lumOff val="80000"/>
+                      </a:schemeClr>
+                    </a:solidFill>
+                  </a:tcPr>
+                </a:tc>
+                <a:tc>
+                  <a:txBody>
+                    <a:bodyPr/>
+                    <a:lstStyle/>
+                    <a:p>
+                      <a:pPr>
+                        <a:buNone/>
+                      </a:pPr>
+                      <a:r>
+                        <a:rPr lang="cs-CZ">
+                          <a:effectLst/>
+                          <a:latin typeface="Google Sans Text"/>
+                        </a:rPr>
+                        <a:t>8 B</a:t>
+                      </a:r>
+                    </a:p>
+                  </a:txBody>
+                  <a:tcPr anchor="ctr">
+                    <a:lnL w="9525" cap="flat" cmpd="sng" algn="ctr">
+                      <a:solidFill>
+                        <a:schemeClr val="bg1"/>
+                      </a:solidFill>
+                      <a:prstDash val="solid"/>
+                      <a:round/>
+                      <a:headEnd type="none" w="med" len="med"/>
+                      <a:tailEnd type="none" w="med" len="med"/>
+                    </a:lnL>
+                    <a:lnR w="9525" cap="flat" cmpd="sng" algn="ctr">
+                      <a:solidFill>
+                        <a:schemeClr val="bg1"/>
+                      </a:solidFill>
+                      <a:prstDash val="solid"/>
+                      <a:round/>
+                      <a:headEnd type="none" w="med" len="med"/>
+                      <a:tailEnd type="none" w="med" len="med"/>
+                    </a:lnR>
+                    <a:lnT w="9525" cap="flat" cmpd="sng" algn="ctr">
+                      <a:solidFill>
+                        <a:schemeClr val="bg1"/>
+                      </a:solidFill>
+                      <a:prstDash val="solid"/>
+                      <a:round/>
+                      <a:headEnd type="none" w="med" len="med"/>
+                      <a:tailEnd type="none" w="med" len="med"/>
+                    </a:lnT>
+                    <a:lnB w="9525" cap="flat" cmpd="sng" algn="ctr">
+                      <a:solidFill>
+                        <a:schemeClr val="bg1"/>
+                      </a:solidFill>
+                      <a:prstDash val="solid"/>
+                      <a:round/>
+                      <a:headEnd type="none" w="med" len="med"/>
+                      <a:tailEnd type="none" w="med" len="med"/>
+                    </a:lnB>
+                    <a:solidFill>
+                      <a:schemeClr val="accent6">
+                        <a:lumMod val="20000"/>
+                        <a:lumOff val="80000"/>
+                      </a:schemeClr>
+                    </a:solidFill>
+                  </a:tcPr>
+                </a:tc>
+                <a:tc>
+                  <a:txBody>
+                    <a:bodyPr/>
+                    <a:lstStyle/>
+                    <a:p>
+                      <a:pPr>
+                        <a:buNone/>
+                      </a:pPr>
+                      <a:r>
+                        <a:rPr lang="cs-CZ" dirty="0">
+                          <a:effectLst/>
+                          <a:latin typeface="Google Sans Text"/>
+                        </a:rPr>
+                        <a:t>0 až 18 triliónů</a:t>
+                      </a:r>
+                    </a:p>
+                  </a:txBody>
+                  <a:tcPr anchor="ctr">
+                    <a:lnL w="9525" cap="flat" cmpd="sng" algn="ctr">
+                      <a:solidFill>
+                        <a:schemeClr val="bg1"/>
+                      </a:solidFill>
+                      <a:prstDash val="solid"/>
+                      <a:round/>
+                      <a:headEnd type="none" w="med" len="med"/>
+                      <a:tailEnd type="none" w="med" len="med"/>
+                    </a:lnL>
+                    <a:lnR w="9525" cap="flat" cmpd="sng" algn="ctr">
+                      <a:solidFill>
+                        <a:schemeClr val="bg1"/>
+                      </a:solidFill>
+                      <a:prstDash val="solid"/>
+                      <a:round/>
+                      <a:headEnd type="none" w="med" len="med"/>
+                      <a:tailEnd type="none" w="med" len="med"/>
+                    </a:lnR>
+                    <a:lnT w="9525" cap="flat" cmpd="sng" algn="ctr">
+                      <a:solidFill>
+                        <a:schemeClr val="bg1"/>
+                      </a:solidFill>
+                      <a:prstDash val="solid"/>
+                      <a:round/>
+                      <a:headEnd type="none" w="med" len="med"/>
+                      <a:tailEnd type="none" w="med" len="med"/>
+                    </a:lnT>
+                    <a:lnB w="9525" cap="flat" cmpd="sng" algn="ctr">
+                      <a:solidFill>
+                        <a:schemeClr val="bg1"/>
+                      </a:solidFill>
+                      <a:prstDash val="solid"/>
+                      <a:round/>
+                      <a:headEnd type="none" w="med" len="med"/>
+                      <a:tailEnd type="none" w="med" len="med"/>
+                    </a:lnB>
+                    <a:solidFill>
+                      <a:schemeClr val="accent6">
+                        <a:lumMod val="20000"/>
+                        <a:lumOff val="80000"/>
+                      </a:schemeClr>
+                    </a:solidFill>
+                  </a:tcPr>
+                </a:tc>
+                <a:extLst>
+                  <a:ext uri="{0D108BD9-81ED-4DB2-BD59-A6C34878D82A}">
+                    <a16:rowId xmlns:a16="http://schemas.microsoft.com/office/drawing/2014/main" val="1357341850"/>
+                  </a:ext>
+                </a:extLst>
+              </a:tr>
+            </a:tbl>
+          </a:graphicData>
+        </a:graphic>
+      </p:graphicFrame>
+    </p:spTree>
+    <p:extLst>
+      <p:ext uri="{BB962C8B-B14F-4D97-AF65-F5344CB8AC3E}">
+        <p14:creationId xmlns:p14="http://schemas.microsoft.com/office/powerpoint/2010/main" val="3060432029"/>
+      </p:ext>
+    </p:extLst>
+  </p:cSld>
+  <p:clrMapOvr>
+    <a:masterClrMapping/>
+  </p:clrMapOvr>
+</p:sld>
+</file>
+
+<file path=ppt/slides/slide11.xml><?xml version="1.0" encoding="utf-8"?>
+<p:sld xmlns:a="http://schemas.openxmlformats.org/drawingml/2006/main" xmlns:r="http://schemas.openxmlformats.org/officeDocument/2006/relationships" xmlns:p="http://schemas.openxmlformats.org/presentationml/2006/main">
+  <p:cSld>
+    <p:spTree>
+      <p:nvGrpSpPr>
         <p:cNvPr id="1" name="">
           <a:extLst>
             <a:ext uri="{FF2B5EF4-FFF2-40B4-BE49-F238E27FC236}">
@@ -5619,7 +7038,7 @@
 </p:sld>
 </file>
 
-<file path=ppt/slides/slide11.xml><?xml version="1.0" encoding="utf-8"?>
+<file path=ppt/slides/slide12.xml><?xml version="1.0" encoding="utf-8"?>
 <p:sld xmlns:a="http://schemas.openxmlformats.org/drawingml/2006/main" xmlns:r="http://schemas.openxmlformats.org/officeDocument/2006/relationships" xmlns:p="http://schemas.openxmlformats.org/presentationml/2006/main">
   <p:cSld>
     <p:spTree>
@@ -5740,7 +7159,7 @@
 </p:sld>
 </file>
 
-<file path=ppt/slides/slide12.xml><?xml version="1.0" encoding="utf-8"?>
+<file path=ppt/slides/slide13.xml><?xml version="1.0" encoding="utf-8"?>
 <p:sld xmlns:a="http://schemas.openxmlformats.org/drawingml/2006/main" xmlns:r="http://schemas.openxmlformats.org/officeDocument/2006/relationships" xmlns:p="http://schemas.openxmlformats.org/presentationml/2006/main">
   <p:cSld>
     <p:spTree>
@@ -6074,7 +7493,7 @@
 </p:sld>
 </file>
 
-<file path=ppt/slides/slide13.xml><?xml version="1.0" encoding="utf-8"?>
+<file path=ppt/slides/slide14.xml><?xml version="1.0" encoding="utf-8"?>
 <p:sld xmlns:a="http://schemas.openxmlformats.org/drawingml/2006/main" xmlns:r="http://schemas.openxmlformats.org/officeDocument/2006/relationships" xmlns:p="http://schemas.openxmlformats.org/presentationml/2006/main">
   <p:cSld>
     <p:spTree>
@@ -6159,7 +7578,7 @@
 </p:sld>
 </file>
 
-<file path=ppt/slides/slide14.xml><?xml version="1.0" encoding="utf-8"?>
+<file path=ppt/slides/slide15.xml><?xml version="1.0" encoding="utf-8"?>
 <p:sld xmlns:a="http://schemas.openxmlformats.org/drawingml/2006/main" xmlns:r="http://schemas.openxmlformats.org/officeDocument/2006/relationships" xmlns:p="http://schemas.openxmlformats.org/presentationml/2006/main">
   <p:cSld>
     <p:spTree>
@@ -6316,10 +7735,128 @@
   <p:clrMapOvr>
     <a:masterClrMapping/>
   </p:clrMapOvr>
+  <p:timing>
+    <p:tnLst>
+      <p:par>
+        <p:cTn id="1" dur="indefinite" restart="never" nodeType="tmRoot">
+          <p:childTnLst>
+            <p:seq concurrent="1" nextAc="seek">
+              <p:cTn id="2" dur="indefinite" nodeType="mainSeq">
+                <p:childTnLst>
+                  <p:par>
+                    <p:cTn id="3" fill="hold">
+                      <p:stCondLst>
+                        <p:cond delay="indefinite"/>
+                      </p:stCondLst>
+                      <p:childTnLst>
+                        <p:par>
+                          <p:cTn id="4" fill="hold">
+                            <p:stCondLst>
+                              <p:cond delay="0"/>
+                            </p:stCondLst>
+                            <p:childTnLst>
+                              <p:par>
+                                <p:cTn id="5" presetID="10" presetClass="entr" presetSubtype="0" fill="hold" nodeType="clickEffect">
+                                  <p:stCondLst>
+                                    <p:cond delay="0"/>
+                                  </p:stCondLst>
+                                  <p:childTnLst>
+                                    <p:set>
+                                      <p:cBhvr>
+                                        <p:cTn id="6" dur="1" fill="hold">
+                                          <p:stCondLst>
+                                            <p:cond delay="0"/>
+                                          </p:stCondLst>
+                                        </p:cTn>
+                                        <p:tgtEl>
+                                          <p:spTgt spid="5"/>
+                                        </p:tgtEl>
+                                        <p:attrNameLst>
+                                          <p:attrName>style.visibility</p:attrName>
+                                        </p:attrNameLst>
+                                      </p:cBhvr>
+                                      <p:to>
+                                        <p:strVal val="visible"/>
+                                      </p:to>
+                                    </p:set>
+                                    <p:animEffect transition="in" filter="fade">
+                                      <p:cBhvr>
+                                        <p:cTn id="7" dur="500"/>
+                                        <p:tgtEl>
+                                          <p:spTgt spid="5"/>
+                                        </p:tgtEl>
+                                      </p:cBhvr>
+                                    </p:animEffect>
+                                  </p:childTnLst>
+                                </p:cTn>
+                              </p:par>
+                              <p:par>
+                                <p:cTn id="8" presetID="10" presetClass="entr" presetSubtype="0" fill="hold" nodeType="withEffect">
+                                  <p:stCondLst>
+                                    <p:cond delay="0"/>
+                                  </p:stCondLst>
+                                  <p:childTnLst>
+                                    <p:set>
+                                      <p:cBhvr>
+                                        <p:cTn id="9" dur="1" fill="hold">
+                                          <p:stCondLst>
+                                            <p:cond delay="0"/>
+                                          </p:stCondLst>
+                                        </p:cTn>
+                                        <p:tgtEl>
+                                          <p:spTgt spid="7"/>
+                                        </p:tgtEl>
+                                        <p:attrNameLst>
+                                          <p:attrName>style.visibility</p:attrName>
+                                        </p:attrNameLst>
+                                      </p:cBhvr>
+                                      <p:to>
+                                        <p:strVal val="visible"/>
+                                      </p:to>
+                                    </p:set>
+                                    <p:animEffect transition="in" filter="fade">
+                                      <p:cBhvr>
+                                        <p:cTn id="10" dur="500"/>
+                                        <p:tgtEl>
+                                          <p:spTgt spid="7"/>
+                                        </p:tgtEl>
+                                      </p:cBhvr>
+                                    </p:animEffect>
+                                  </p:childTnLst>
+                                </p:cTn>
+                              </p:par>
+                            </p:childTnLst>
+                          </p:cTn>
+                        </p:par>
+                      </p:childTnLst>
+                    </p:cTn>
+                  </p:par>
+                </p:childTnLst>
+              </p:cTn>
+              <p:prevCondLst>
+                <p:cond evt="onPrev" delay="0">
+                  <p:tgtEl>
+                    <p:sldTgt/>
+                  </p:tgtEl>
+                </p:cond>
+              </p:prevCondLst>
+              <p:nextCondLst>
+                <p:cond evt="onNext" delay="0">
+                  <p:tgtEl>
+                    <p:sldTgt/>
+                  </p:tgtEl>
+                </p:cond>
+              </p:nextCondLst>
+            </p:seq>
+          </p:childTnLst>
+        </p:cTn>
+      </p:par>
+    </p:tnLst>
+  </p:timing>
 </p:sld>
 </file>
 
-<file path=ppt/slides/slide15.xml><?xml version="1.0" encoding="utf-8"?>
+<file path=ppt/slides/slide16.xml><?xml version="1.0" encoding="utf-8"?>
 <p:sld xmlns:a="http://schemas.openxmlformats.org/drawingml/2006/main" xmlns:r="http://schemas.openxmlformats.org/officeDocument/2006/relationships" xmlns:p="http://schemas.openxmlformats.org/presentationml/2006/main">
   <p:cSld>
     <p:spTree>
@@ -6379,7 +7916,7 @@
 </p:sld>
 </file>
 
-<file path=ppt/slides/slide16.xml><?xml version="1.0" encoding="utf-8"?>
+<file path=ppt/slides/slide17.xml><?xml version="1.0" encoding="utf-8"?>
 <p:sld xmlns:a="http://schemas.openxmlformats.org/drawingml/2006/main" xmlns:r="http://schemas.openxmlformats.org/officeDocument/2006/relationships" xmlns:p="http://schemas.openxmlformats.org/presentationml/2006/main">
   <p:cSld>
     <p:spTree>
@@ -6674,7 +8211,7 @@
 </p:sld>
 </file>
 
-<file path=ppt/slides/slide17.xml><?xml version="1.0" encoding="utf-8"?>
+<file path=ppt/slides/slide18.xml><?xml version="1.0" encoding="utf-8"?>
 <p:sld xmlns:a="http://schemas.openxmlformats.org/drawingml/2006/main" xmlns:r="http://schemas.openxmlformats.org/officeDocument/2006/relationships" xmlns:p="http://schemas.openxmlformats.org/presentationml/2006/main">
   <p:cSld>
     <p:spTree>
@@ -6986,9 +8523,20 @@
 </p:sld>
 </file>
 
-<file path=ppt/slides/slide18.xml><?xml version="1.0" encoding="utf-8"?>
+<file path=ppt/slides/slide19.xml><?xml version="1.0" encoding="utf-8"?>
 <p:sld xmlns:a="http://schemas.openxmlformats.org/drawingml/2006/main" xmlns:r="http://schemas.openxmlformats.org/officeDocument/2006/relationships" xmlns:p="http://schemas.openxmlformats.org/presentationml/2006/main">
   <p:cSld>
+    <p:bg>
+      <p:bgPr>
+        <a:solidFill>
+          <a:schemeClr val="accent6">
+            <a:lumMod val="20000"/>
+            <a:lumOff val="80000"/>
+          </a:schemeClr>
+        </a:solidFill>
+        <a:effectLst/>
+      </p:bgPr>
+    </p:bg>
     <p:spTree>
       <p:nvGrpSpPr>
         <p:cNvPr id="1" name=""/>
@@ -7883,9 +9431,94 @@
 </p:sld>
 </file>
 
-<file path=ppt/slides/slide19.xml><?xml version="1.0" encoding="utf-8"?>
+<file path=ppt/slides/slide2.xml><?xml version="1.0" encoding="utf-8"?>
 <p:sld xmlns:a="http://schemas.openxmlformats.org/drawingml/2006/main" xmlns:r="http://schemas.openxmlformats.org/officeDocument/2006/relationships" xmlns:p="http://schemas.openxmlformats.org/presentationml/2006/main">
   <p:cSld>
+    <p:spTree>
+      <p:nvGrpSpPr>
+        <p:cNvPr id="1" name=""/>
+        <p:cNvGrpSpPr/>
+        <p:nvPr/>
+      </p:nvGrpSpPr>
+      <p:grpSpPr>
+        <a:xfrm>
+          <a:off x="0" y="0"/>
+          <a:ext cx="0" cy="0"/>
+          <a:chOff x="0" y="0"/>
+          <a:chExt cx="0" cy="0"/>
+        </a:xfrm>
+      </p:grpSpPr>
+      <p:sp>
+        <p:nvSpPr>
+          <p:cNvPr id="3" name="Zástupný obsah 2">
+            <a:extLst>
+              <a:ext uri="{FF2B5EF4-FFF2-40B4-BE49-F238E27FC236}">
+                <a16:creationId xmlns:a16="http://schemas.microsoft.com/office/drawing/2014/main" id="{7B8E1416-38FB-7FA7-C2B9-F18029269975}"/>
+              </a:ext>
+            </a:extLst>
+          </p:cNvPr>
+          <p:cNvSpPr>
+            <a:spLocks noGrp="1"/>
+          </p:cNvSpPr>
+          <p:nvPr>
+            <p:ph idx="1"/>
+          </p:nvPr>
+        </p:nvSpPr>
+        <p:spPr>
+          <a:xfrm>
+            <a:off x="838200" y="3200400"/>
+            <a:ext cx="10515600" cy="457200"/>
+          </a:xfrm>
+          <a:solidFill>
+            <a:schemeClr val="accent6">
+              <a:lumMod val="20000"/>
+              <a:lumOff val="80000"/>
+            </a:schemeClr>
+          </a:solidFill>
+        </p:spPr>
+        <p:txBody>
+          <a:bodyPr>
+            <a:normAutofit lnSpcReduction="10000"/>
+          </a:bodyPr>
+          <a:lstStyle/>
+          <a:p>
+            <a:pPr marL="0" indent="0" algn="ctr">
+              <a:buNone/>
+            </a:pPr>
+            <a:r>
+              <a:rPr lang="cs-CZ" dirty="0"/>
+              <a:t>Zeleně jsou označeny věci navíc (nepožadované u maturity).</a:t>
+            </a:r>
+          </a:p>
+        </p:txBody>
+      </p:sp>
+    </p:spTree>
+    <p:extLst>
+      <p:ext uri="{BB962C8B-B14F-4D97-AF65-F5344CB8AC3E}">
+        <p14:creationId xmlns:p14="http://schemas.microsoft.com/office/powerpoint/2010/main" val="944681515"/>
+      </p:ext>
+    </p:extLst>
+  </p:cSld>
+  <p:clrMapOvr>
+    <a:masterClrMapping/>
+  </p:clrMapOvr>
+</p:sld>
+</file>
+
+<file path=ppt/slides/slide20.xml><?xml version="1.0" encoding="utf-8"?>
+<p:sld xmlns:a="http://schemas.openxmlformats.org/drawingml/2006/main" xmlns:r="http://schemas.openxmlformats.org/officeDocument/2006/relationships" xmlns:p="http://schemas.openxmlformats.org/presentationml/2006/main">
+  <p:cSld>
+    <p:bg>
+      <p:bgPr>
+        <a:solidFill>
+          <a:schemeClr val="accent6">
+            <a:lumMod val="20000"/>
+            <a:lumOff val="80000"/>
+          </a:schemeClr>
+        </a:solidFill>
+        <a:effectLst/>
+      </p:bgPr>
+    </p:bg>
     <p:spTree>
       <p:nvGrpSpPr>
         <p:cNvPr id="1" name=""/>
@@ -8018,412 +9651,7 @@
 </p:sld>
 </file>
 
-<file path=ppt/slides/slide2.xml><?xml version="1.0" encoding="utf-8"?>
-<p:sld xmlns:a="http://schemas.openxmlformats.org/drawingml/2006/main" xmlns:r="http://schemas.openxmlformats.org/officeDocument/2006/relationships" xmlns:p="http://schemas.openxmlformats.org/presentationml/2006/main">
-  <p:cSld>
-    <p:spTree>
-      <p:nvGrpSpPr>
-        <p:cNvPr id="1" name=""/>
-        <p:cNvGrpSpPr/>
-        <p:nvPr/>
-      </p:nvGrpSpPr>
-      <p:grpSpPr>
-        <a:xfrm>
-          <a:off x="0" y="0"/>
-          <a:ext cx="0" cy="0"/>
-          <a:chOff x="0" y="0"/>
-          <a:chExt cx="0" cy="0"/>
-        </a:xfrm>
-      </p:grpSpPr>
-      <p:sp>
-        <p:nvSpPr>
-          <p:cNvPr id="3" name="Zástupný obsah 2">
-            <a:extLst>
-              <a:ext uri="{FF2B5EF4-FFF2-40B4-BE49-F238E27FC236}">
-                <a16:creationId xmlns:a16="http://schemas.microsoft.com/office/drawing/2014/main" id="{A00BCEF9-B5B7-A7B2-652C-EC88D0C24274}"/>
-              </a:ext>
-            </a:extLst>
-          </p:cNvPr>
-          <p:cNvSpPr>
-            <a:spLocks noGrp="1"/>
-          </p:cNvSpPr>
-          <p:nvPr>
-            <p:ph idx="1"/>
-          </p:nvPr>
-        </p:nvSpPr>
-        <p:spPr>
-          <a:xfrm>
-            <a:off x="838200" y="1825625"/>
-            <a:ext cx="10515600" cy="1152965"/>
-          </a:xfrm>
-        </p:spPr>
-        <p:txBody>
-          <a:bodyPr>
-            <a:normAutofit/>
-          </a:bodyPr>
-          <a:lstStyle/>
-          <a:p>
-            <a:pPr marL="0" indent="0" algn="ctr">
-              <a:buNone/>
-            </a:pPr>
-            <a:r>
-              <a:rPr lang="cs-CZ" sz="6600" dirty="0"/>
-              <a:t>Co je to </a:t>
-            </a:r>
-            <a:r>
-              <a:rPr lang="cs-CZ" sz="6600" b="1" dirty="0"/>
-              <a:t>proměnná</a:t>
-            </a:r>
-            <a:r>
-              <a:rPr lang="cs-CZ" sz="6600" dirty="0"/>
-              <a:t>?</a:t>
-            </a:r>
-          </a:p>
-        </p:txBody>
-      </p:sp>
-      <p:sp>
-        <p:nvSpPr>
-          <p:cNvPr id="6" name="Zástupný obsah 2">
-            <a:extLst>
-              <a:ext uri="{FF2B5EF4-FFF2-40B4-BE49-F238E27FC236}">
-                <a16:creationId xmlns:a16="http://schemas.microsoft.com/office/drawing/2014/main" id="{215216EB-B9F2-6454-B463-AFED31114BA9}"/>
-              </a:ext>
-            </a:extLst>
-          </p:cNvPr>
-          <p:cNvSpPr txBox="1">
-            <a:spLocks/>
-          </p:cNvSpPr>
-          <p:nvPr/>
-        </p:nvSpPr>
-        <p:spPr>
-          <a:xfrm>
-            <a:off x="838200" y="3091601"/>
-            <a:ext cx="10515600" cy="1498506"/>
-          </a:xfrm>
-          <a:prstGeom prst="rect">
-            <a:avLst/>
-          </a:prstGeom>
-        </p:spPr>
-        <p:txBody>
-          <a:bodyPr vert="horz" lIns="91440" tIns="45720" rIns="91440" bIns="45720" rtlCol="0">
-            <a:normAutofit fontScale="85000" lnSpcReduction="20000"/>
-          </a:bodyPr>
-          <a:lstStyle>
-            <a:lvl1pPr marL="228600" indent="-228600" algn="l" defTabSz="914400" rtl="0" eaLnBrk="1" latinLnBrk="0" hangingPunct="1">
-              <a:lnSpc>
-                <a:spcPct val="90000"/>
-              </a:lnSpc>
-              <a:spcBef>
-                <a:spcPts val="1000"/>
-              </a:spcBef>
-              <a:buFont typeface="Arial" panose="020B0604020202020204" pitchFamily="34" charset="0"/>
-              <a:buChar char="•"/>
-              <a:defRPr sz="2800" kern="1200">
-                <a:solidFill>
-                  <a:schemeClr val="tx1"/>
-                </a:solidFill>
-                <a:latin typeface="+mn-lt"/>
-                <a:ea typeface="+mn-ea"/>
-                <a:cs typeface="+mn-cs"/>
-              </a:defRPr>
-            </a:lvl1pPr>
-            <a:lvl2pPr marL="685800" indent="-228600" algn="l" defTabSz="914400" rtl="0" eaLnBrk="1" latinLnBrk="0" hangingPunct="1">
-              <a:lnSpc>
-                <a:spcPct val="90000"/>
-              </a:lnSpc>
-              <a:spcBef>
-                <a:spcPts val="500"/>
-              </a:spcBef>
-              <a:buFont typeface="Arial" panose="020B0604020202020204" pitchFamily="34" charset="0"/>
-              <a:buChar char="•"/>
-              <a:defRPr sz="2400" kern="1200">
-                <a:solidFill>
-                  <a:schemeClr val="tx1"/>
-                </a:solidFill>
-                <a:latin typeface="+mn-lt"/>
-                <a:ea typeface="+mn-ea"/>
-                <a:cs typeface="+mn-cs"/>
-              </a:defRPr>
-            </a:lvl2pPr>
-            <a:lvl3pPr marL="1143000" indent="-228600" algn="l" defTabSz="914400" rtl="0" eaLnBrk="1" latinLnBrk="0" hangingPunct="1">
-              <a:lnSpc>
-                <a:spcPct val="90000"/>
-              </a:lnSpc>
-              <a:spcBef>
-                <a:spcPts val="500"/>
-              </a:spcBef>
-              <a:buFont typeface="Arial" panose="020B0604020202020204" pitchFamily="34" charset="0"/>
-              <a:buChar char="•"/>
-              <a:defRPr sz="2000" kern="1200">
-                <a:solidFill>
-                  <a:schemeClr val="tx1"/>
-                </a:solidFill>
-                <a:latin typeface="+mn-lt"/>
-                <a:ea typeface="+mn-ea"/>
-                <a:cs typeface="+mn-cs"/>
-              </a:defRPr>
-            </a:lvl3pPr>
-            <a:lvl4pPr marL="1600200" indent="-228600" algn="l" defTabSz="914400" rtl="0" eaLnBrk="1" latinLnBrk="0" hangingPunct="1">
-              <a:lnSpc>
-                <a:spcPct val="90000"/>
-              </a:lnSpc>
-              <a:spcBef>
-                <a:spcPts val="500"/>
-              </a:spcBef>
-              <a:buFont typeface="Arial" panose="020B0604020202020204" pitchFamily="34" charset="0"/>
-              <a:buChar char="•"/>
-              <a:defRPr sz="1800" kern="1200">
-                <a:solidFill>
-                  <a:schemeClr val="tx1"/>
-                </a:solidFill>
-                <a:latin typeface="+mn-lt"/>
-                <a:ea typeface="+mn-ea"/>
-                <a:cs typeface="+mn-cs"/>
-              </a:defRPr>
-            </a:lvl4pPr>
-            <a:lvl5pPr marL="2057400" indent="-228600" algn="l" defTabSz="914400" rtl="0" eaLnBrk="1" latinLnBrk="0" hangingPunct="1">
-              <a:lnSpc>
-                <a:spcPct val="90000"/>
-              </a:lnSpc>
-              <a:spcBef>
-                <a:spcPts val="500"/>
-              </a:spcBef>
-              <a:buFont typeface="Arial" panose="020B0604020202020204" pitchFamily="34" charset="0"/>
-              <a:buChar char="•"/>
-              <a:defRPr sz="1800" kern="1200">
-                <a:solidFill>
-                  <a:schemeClr val="tx1"/>
-                </a:solidFill>
-                <a:latin typeface="+mn-lt"/>
-                <a:ea typeface="+mn-ea"/>
-                <a:cs typeface="+mn-cs"/>
-              </a:defRPr>
-            </a:lvl5pPr>
-            <a:lvl6pPr marL="2514600" indent="-228600" algn="l" defTabSz="914400" rtl="0" eaLnBrk="1" latinLnBrk="0" hangingPunct="1">
-              <a:lnSpc>
-                <a:spcPct val="90000"/>
-              </a:lnSpc>
-              <a:spcBef>
-                <a:spcPts val="500"/>
-              </a:spcBef>
-              <a:buFont typeface="Arial" panose="020B0604020202020204" pitchFamily="34" charset="0"/>
-              <a:buChar char="•"/>
-              <a:defRPr sz="1800" kern="1200">
-                <a:solidFill>
-                  <a:schemeClr val="tx1"/>
-                </a:solidFill>
-                <a:latin typeface="+mn-lt"/>
-                <a:ea typeface="+mn-ea"/>
-                <a:cs typeface="+mn-cs"/>
-              </a:defRPr>
-            </a:lvl6pPr>
-            <a:lvl7pPr marL="2971800" indent="-228600" algn="l" defTabSz="914400" rtl="0" eaLnBrk="1" latinLnBrk="0" hangingPunct="1">
-              <a:lnSpc>
-                <a:spcPct val="90000"/>
-              </a:lnSpc>
-              <a:spcBef>
-                <a:spcPts val="500"/>
-              </a:spcBef>
-              <a:buFont typeface="Arial" panose="020B0604020202020204" pitchFamily="34" charset="0"/>
-              <a:buChar char="•"/>
-              <a:defRPr sz="1800" kern="1200">
-                <a:solidFill>
-                  <a:schemeClr val="tx1"/>
-                </a:solidFill>
-                <a:latin typeface="+mn-lt"/>
-                <a:ea typeface="+mn-ea"/>
-                <a:cs typeface="+mn-cs"/>
-              </a:defRPr>
-            </a:lvl7pPr>
-            <a:lvl8pPr marL="3429000" indent="-228600" algn="l" defTabSz="914400" rtl="0" eaLnBrk="1" latinLnBrk="0" hangingPunct="1">
-              <a:lnSpc>
-                <a:spcPct val="90000"/>
-              </a:lnSpc>
-              <a:spcBef>
-                <a:spcPts val="500"/>
-              </a:spcBef>
-              <a:buFont typeface="Arial" panose="020B0604020202020204" pitchFamily="34" charset="0"/>
-              <a:buChar char="•"/>
-              <a:defRPr sz="1800" kern="1200">
-                <a:solidFill>
-                  <a:schemeClr val="tx1"/>
-                </a:solidFill>
-                <a:latin typeface="+mn-lt"/>
-                <a:ea typeface="+mn-ea"/>
-                <a:cs typeface="+mn-cs"/>
-              </a:defRPr>
-            </a:lvl8pPr>
-            <a:lvl9pPr marL="3886200" indent="-228600" algn="l" defTabSz="914400" rtl="0" eaLnBrk="1" latinLnBrk="0" hangingPunct="1">
-              <a:lnSpc>
-                <a:spcPct val="90000"/>
-              </a:lnSpc>
-              <a:spcBef>
-                <a:spcPts val="500"/>
-              </a:spcBef>
-              <a:buFont typeface="Arial" panose="020B0604020202020204" pitchFamily="34" charset="0"/>
-              <a:buChar char="•"/>
-              <a:defRPr sz="1800" kern="1200">
-                <a:solidFill>
-                  <a:schemeClr val="tx1"/>
-                </a:solidFill>
-                <a:latin typeface="+mn-lt"/>
-                <a:ea typeface="+mn-ea"/>
-                <a:cs typeface="+mn-cs"/>
-              </a:defRPr>
-            </a:lvl9pPr>
-          </a:lstStyle>
-          <a:p>
-            <a:pPr marL="0" indent="0" algn="ctr">
-              <a:buNone/>
-            </a:pPr>
-            <a:r>
-              <a:rPr lang="cs-CZ" sz="1800" dirty="0"/>
-              <a:t>= pojmenované místo v operační paměti</a:t>
-            </a:r>
-          </a:p>
-          <a:p>
-            <a:pPr marL="0" indent="0" algn="ctr">
-              <a:buNone/>
-            </a:pPr>
-            <a:r>
-              <a:rPr lang="cs-CZ" sz="1800" dirty="0"/>
-              <a:t>Má </a:t>
-            </a:r>
-            <a:r>
-              <a:rPr lang="cs-CZ" sz="1800" b="1" dirty="0"/>
-              <a:t>jméno, typ, obsah.</a:t>
-            </a:r>
-            <a:endParaRPr lang="cs-CZ" sz="1800" dirty="0"/>
-          </a:p>
-          <a:p>
-            <a:pPr marL="0" indent="0" algn="ctr">
-              <a:buNone/>
-            </a:pPr>
-            <a:r>
-              <a:rPr lang="cs-CZ" sz="1800" dirty="0"/>
-              <a:t>Obsah se může měnit -&gt; proměnná</a:t>
-            </a:r>
-          </a:p>
-          <a:p>
-            <a:pPr marL="0" indent="0" algn="ctr">
-              <a:buNone/>
-            </a:pPr>
-            <a:r>
-              <a:rPr lang="cs-CZ" sz="1800" dirty="0"/>
-              <a:t>V C# je její životnost omezena { … }</a:t>
-            </a:r>
-          </a:p>
-          <a:p>
-            <a:pPr marL="0" indent="0" algn="ctr">
-              <a:buNone/>
-            </a:pPr>
-            <a:r>
-              <a:rPr lang="cs-CZ" sz="1800" dirty="0"/>
-              <a:t>V C# je statické typování – typ každé proměnné musí být znám už za kompilace a pak se nemění</a:t>
-            </a:r>
-          </a:p>
-        </p:txBody>
-      </p:sp>
-    </p:spTree>
-    <p:extLst>
-      <p:ext uri="{BB962C8B-B14F-4D97-AF65-F5344CB8AC3E}">
-        <p14:creationId xmlns:p14="http://schemas.microsoft.com/office/powerpoint/2010/main" val="433613044"/>
-      </p:ext>
-    </p:extLst>
-  </p:cSld>
-  <p:clrMapOvr>
-    <a:masterClrMapping/>
-  </p:clrMapOvr>
-  <p:timing>
-    <p:tnLst>
-      <p:par>
-        <p:cTn id="1" dur="indefinite" restart="never" nodeType="tmRoot">
-          <p:childTnLst>
-            <p:seq concurrent="1" nextAc="seek">
-              <p:cTn id="2" dur="indefinite" nodeType="mainSeq">
-                <p:childTnLst>
-                  <p:par>
-                    <p:cTn id="3" fill="hold">
-                      <p:stCondLst>
-                        <p:cond delay="indefinite"/>
-                      </p:stCondLst>
-                      <p:childTnLst>
-                        <p:par>
-                          <p:cTn id="4" fill="hold">
-                            <p:stCondLst>
-                              <p:cond delay="0"/>
-                            </p:stCondLst>
-                            <p:childTnLst>
-                              <p:par>
-                                <p:cTn id="5" presetID="10" presetClass="entr" presetSubtype="0" fill="hold" grpId="0" nodeType="clickEffect">
-                                  <p:stCondLst>
-                                    <p:cond delay="0"/>
-                                  </p:stCondLst>
-                                  <p:childTnLst>
-                                    <p:set>
-                                      <p:cBhvr>
-                                        <p:cTn id="6" dur="1" fill="hold">
-                                          <p:stCondLst>
-                                            <p:cond delay="0"/>
-                                          </p:stCondLst>
-                                        </p:cTn>
-                                        <p:tgtEl>
-                                          <p:spTgt spid="6"/>
-                                        </p:tgtEl>
-                                        <p:attrNameLst>
-                                          <p:attrName>style.visibility</p:attrName>
-                                        </p:attrNameLst>
-                                      </p:cBhvr>
-                                      <p:to>
-                                        <p:strVal val="visible"/>
-                                      </p:to>
-                                    </p:set>
-                                    <p:animEffect transition="in" filter="fade">
-                                      <p:cBhvr>
-                                        <p:cTn id="7" dur="500"/>
-                                        <p:tgtEl>
-                                          <p:spTgt spid="6"/>
-                                        </p:tgtEl>
-                                      </p:cBhvr>
-                                    </p:animEffect>
-                                  </p:childTnLst>
-                                </p:cTn>
-                              </p:par>
-                            </p:childTnLst>
-                          </p:cTn>
-                        </p:par>
-                      </p:childTnLst>
-                    </p:cTn>
-                  </p:par>
-                </p:childTnLst>
-              </p:cTn>
-              <p:prevCondLst>
-                <p:cond evt="onPrev" delay="0">
-                  <p:tgtEl>
-                    <p:sldTgt/>
-                  </p:tgtEl>
-                </p:cond>
-              </p:prevCondLst>
-              <p:nextCondLst>
-                <p:cond evt="onNext" delay="0">
-                  <p:tgtEl>
-                    <p:sldTgt/>
-                  </p:tgtEl>
-                </p:cond>
-              </p:nextCondLst>
-            </p:seq>
-          </p:childTnLst>
-        </p:cTn>
-      </p:par>
-    </p:tnLst>
-    <p:bldLst>
-      <p:bldP spid="6" grpId="0"/>
-    </p:bldLst>
-  </p:timing>
-</p:sld>
-</file>
-
-<file path=ppt/slides/slide20.xml><?xml version="1.0" encoding="utf-8"?>
+<file path=ppt/slides/slide21.xml><?xml version="1.0" encoding="utf-8"?>
 <p:sld xmlns:a="http://schemas.openxmlformats.org/drawingml/2006/main" xmlns:r="http://schemas.openxmlformats.org/officeDocument/2006/relationships" xmlns:p="http://schemas.openxmlformats.org/presentationml/2006/main">
   <p:cSld>
     <p:spTree>
@@ -8699,9 +9927,20 @@
 </p:sld>
 </file>
 
-<file path=ppt/slides/slide21.xml><?xml version="1.0" encoding="utf-8"?>
+<file path=ppt/slides/slide22.xml><?xml version="1.0" encoding="utf-8"?>
 <p:sld xmlns:a="http://schemas.openxmlformats.org/drawingml/2006/main" xmlns:r="http://schemas.openxmlformats.org/officeDocument/2006/relationships" xmlns:p="http://schemas.openxmlformats.org/presentationml/2006/main">
   <p:cSld>
+    <p:bg>
+      <p:bgPr>
+        <a:solidFill>
+          <a:schemeClr val="accent6">
+            <a:lumMod val="20000"/>
+            <a:lumOff val="80000"/>
+          </a:schemeClr>
+        </a:solidFill>
+        <a:effectLst/>
+      </p:bgPr>
+    </p:bg>
     <p:spTree>
       <p:nvGrpSpPr>
         <p:cNvPr id="1" name=""/>
@@ -9292,6 +10531,110 @@
                       </p:childTnLst>
                     </p:cTn>
                   </p:par>
+                  <p:par>
+                    <p:cTn id="18" fill="hold">
+                      <p:stCondLst>
+                        <p:cond delay="indefinite"/>
+                      </p:stCondLst>
+                      <p:childTnLst>
+                        <p:par>
+                          <p:cTn id="19" fill="hold">
+                            <p:stCondLst>
+                              <p:cond delay="0"/>
+                            </p:stCondLst>
+                            <p:childTnLst>
+                              <p:par>
+                                <p:cTn id="20" presetID="10" presetClass="entr" presetSubtype="0" fill="hold" nodeType="clickEffect">
+                                  <p:stCondLst>
+                                    <p:cond delay="0"/>
+                                  </p:stCondLst>
+                                  <p:childTnLst>
+                                    <p:set>
+                                      <p:cBhvr>
+                                        <p:cTn id="21" dur="1" fill="hold">
+                                          <p:stCondLst>
+                                            <p:cond delay="0"/>
+                                          </p:stCondLst>
+                                        </p:cTn>
+                                        <p:tgtEl>
+                                          <p:spTgt spid="10">
+                                            <p:txEl>
+                                              <p:pRg st="0" end="0"/>
+                                            </p:txEl>
+                                          </p:spTgt>
+                                        </p:tgtEl>
+                                        <p:attrNameLst>
+                                          <p:attrName>style.visibility</p:attrName>
+                                        </p:attrNameLst>
+                                      </p:cBhvr>
+                                      <p:to>
+                                        <p:strVal val="visible"/>
+                                      </p:to>
+                                    </p:set>
+                                    <p:animEffect transition="in" filter="fade">
+                                      <p:cBhvr>
+                                        <p:cTn id="22" dur="500"/>
+                                        <p:tgtEl>
+                                          <p:spTgt spid="10">
+                                            <p:txEl>
+                                              <p:pRg st="0" end="0"/>
+                                            </p:txEl>
+                                          </p:spTgt>
+                                        </p:tgtEl>
+                                      </p:cBhvr>
+                                    </p:animEffect>
+                                  </p:childTnLst>
+                                </p:cTn>
+                              </p:par>
+                              <p:par>
+                                <p:cTn id="23" presetID="10" presetClass="entr" presetSubtype="0" fill="hold" nodeType="withEffect">
+                                  <p:stCondLst>
+                                    <p:cond delay="0"/>
+                                  </p:stCondLst>
+                                  <p:childTnLst>
+                                    <p:set>
+                                      <p:cBhvr>
+                                        <p:cTn id="24" dur="1" fill="hold">
+                                          <p:stCondLst>
+                                            <p:cond delay="0"/>
+                                          </p:stCondLst>
+                                        </p:cTn>
+                                        <p:tgtEl>
+                                          <p:spTgt spid="10">
+                                            <p:txEl>
+                                              <p:pRg st="1" end="1"/>
+                                            </p:txEl>
+                                          </p:spTgt>
+                                        </p:tgtEl>
+                                        <p:attrNameLst>
+                                          <p:attrName>style.visibility</p:attrName>
+                                        </p:attrNameLst>
+                                      </p:cBhvr>
+                                      <p:to>
+                                        <p:strVal val="visible"/>
+                                      </p:to>
+                                    </p:set>
+                                    <p:animEffect transition="in" filter="fade">
+                                      <p:cBhvr>
+                                        <p:cTn id="25" dur="500"/>
+                                        <p:tgtEl>
+                                          <p:spTgt spid="10">
+                                            <p:txEl>
+                                              <p:pRg st="1" end="1"/>
+                                            </p:txEl>
+                                          </p:spTgt>
+                                        </p:tgtEl>
+                                      </p:cBhvr>
+                                    </p:animEffect>
+                                  </p:childTnLst>
+                                </p:cTn>
+                              </p:par>
+                            </p:childTnLst>
+                          </p:cTn>
+                        </p:par>
+                      </p:childTnLst>
+                    </p:cTn>
+                  </p:par>
                 </p:childTnLst>
               </p:cTn>
               <p:prevCondLst>
@@ -9317,9 +10660,20 @@
 </p:sld>
 </file>
 
-<file path=ppt/slides/slide22.xml><?xml version="1.0" encoding="utf-8"?>
+<file path=ppt/slides/slide23.xml><?xml version="1.0" encoding="utf-8"?>
 <p:sld xmlns:a="http://schemas.openxmlformats.org/drawingml/2006/main" xmlns:r="http://schemas.openxmlformats.org/officeDocument/2006/relationships" xmlns:p="http://schemas.openxmlformats.org/presentationml/2006/main">
   <p:cSld>
+    <p:bg>
+      <p:bgPr>
+        <a:solidFill>
+          <a:schemeClr val="accent6">
+            <a:lumMod val="20000"/>
+            <a:lumOff val="80000"/>
+          </a:schemeClr>
+        </a:solidFill>
+        <a:effectLst/>
+      </p:bgPr>
+    </p:bg>
     <p:spTree>
       <p:nvGrpSpPr>
         <p:cNvPr id="1" name=""/>
@@ -9591,7 +10945,7 @@
 </p:sld>
 </file>
 
-<file path=ppt/slides/slide23.xml><?xml version="1.0" encoding="utf-8"?>
+<file path=ppt/slides/slide24.xml><?xml version="1.0" encoding="utf-8"?>
 <p:sld xmlns:a="http://schemas.openxmlformats.org/drawingml/2006/main" xmlns:r="http://schemas.openxmlformats.org/officeDocument/2006/relationships" xmlns:p="http://schemas.openxmlformats.org/presentationml/2006/main">
   <p:cSld>
     <p:spTree>
@@ -10074,7 +11428,12 @@
           <a:prstGeom prst="rect">
             <a:avLst/>
           </a:prstGeom>
-          <a:noFill/>
+          <a:solidFill>
+            <a:schemeClr val="accent6">
+              <a:lumMod val="20000"/>
+              <a:lumOff val="80000"/>
+            </a:schemeClr>
+          </a:solidFill>
         </p:spPr>
         <p:txBody>
           <a:bodyPr wrap="square">
@@ -10303,11 +11662,7 @@
                                           </p:stCondLst>
                                         </p:cTn>
                                         <p:tgtEl>
-                                          <p:spTgt spid="3">
-                                            <p:txEl>
-                                              <p:pRg st="3" end="3"/>
-                                            </p:txEl>
-                                          </p:spTgt>
+                                          <p:spTgt spid="4"/>
                                         </p:tgtEl>
                                         <p:attrNameLst>
                                           <p:attrName>style.visibility</p:attrName>
@@ -10321,11 +11676,7 @@
                                       <p:cBhvr>
                                         <p:cTn id="12" dur="500"/>
                                         <p:tgtEl>
-                                          <p:spTgt spid="3">
-                                            <p:txEl>
-                                              <p:pRg st="3" end="3"/>
-                                            </p:txEl>
-                                          </p:spTgt>
+                                          <p:spTgt spid="4"/>
                                         </p:tgtEl>
                                       </p:cBhvr>
                                     </p:animEffect>
@@ -10351,7 +11702,7 @@
                             </p:stCondLst>
                             <p:childTnLst>
                               <p:par>
-                                <p:cTn id="15" presetID="10" presetClass="entr" presetSubtype="0" fill="hold" grpId="0" nodeType="clickEffect">
+                                <p:cTn id="15" presetID="10" presetClass="entr" presetSubtype="0" fill="hold" nodeType="clickEffect">
                                   <p:stCondLst>
                                     <p:cond delay="0"/>
                                   </p:stCondLst>
@@ -10359,6 +11710,67 @@
                                     <p:set>
                                       <p:cBhvr>
                                         <p:cTn id="16" dur="1" fill="hold">
+                                          <p:stCondLst>
+                                            <p:cond delay="0"/>
+                                          </p:stCondLst>
+                                        </p:cTn>
+                                        <p:tgtEl>
+                                          <p:spTgt spid="3">
+                                            <p:txEl>
+                                              <p:pRg st="3" end="3"/>
+                                            </p:txEl>
+                                          </p:spTgt>
+                                        </p:tgtEl>
+                                        <p:attrNameLst>
+                                          <p:attrName>style.visibility</p:attrName>
+                                        </p:attrNameLst>
+                                      </p:cBhvr>
+                                      <p:to>
+                                        <p:strVal val="visible"/>
+                                      </p:to>
+                                    </p:set>
+                                    <p:animEffect transition="in" filter="fade">
+                                      <p:cBhvr>
+                                        <p:cTn id="17" dur="500"/>
+                                        <p:tgtEl>
+                                          <p:spTgt spid="3">
+                                            <p:txEl>
+                                              <p:pRg st="3" end="3"/>
+                                            </p:txEl>
+                                          </p:spTgt>
+                                        </p:tgtEl>
+                                      </p:cBhvr>
+                                    </p:animEffect>
+                                  </p:childTnLst>
+                                </p:cTn>
+                              </p:par>
+                            </p:childTnLst>
+                          </p:cTn>
+                        </p:par>
+                      </p:childTnLst>
+                    </p:cTn>
+                  </p:par>
+                  <p:par>
+                    <p:cTn id="18" fill="hold">
+                      <p:stCondLst>
+                        <p:cond delay="indefinite"/>
+                      </p:stCondLst>
+                      <p:childTnLst>
+                        <p:par>
+                          <p:cTn id="19" fill="hold">
+                            <p:stCondLst>
+                              <p:cond delay="0"/>
+                            </p:stCondLst>
+                            <p:childTnLst>
+                              <p:par>
+                                <p:cTn id="20" presetID="10" presetClass="entr" presetSubtype="0" fill="hold" grpId="0" nodeType="clickEffect">
+                                  <p:stCondLst>
+                                    <p:cond delay="0"/>
+                                  </p:stCondLst>
+                                  <p:childTnLst>
+                                    <p:set>
+                                      <p:cBhvr>
+                                        <p:cTn id="21" dur="1" fill="hold">
                                           <p:stCondLst>
                                             <p:cond delay="0"/>
                                           </p:stCondLst>
@@ -10376,7 +11788,7 @@
                                     </p:set>
                                     <p:animEffect transition="in" filter="fade">
                                       <p:cBhvr>
-                                        <p:cTn id="17" dur="500"/>
+                                        <p:cTn id="22" dur="500"/>
                                         <p:tgtEl>
                                           <p:spTgt spid="6"/>
                                         </p:tgtEl>
@@ -10438,6 +11850,411 @@
       </p:grpSpPr>
       <p:sp>
         <p:nvSpPr>
+          <p:cNvPr id="3" name="Zástupný obsah 2">
+            <a:extLst>
+              <a:ext uri="{FF2B5EF4-FFF2-40B4-BE49-F238E27FC236}">
+                <a16:creationId xmlns:a16="http://schemas.microsoft.com/office/drawing/2014/main" id="{A00BCEF9-B5B7-A7B2-652C-EC88D0C24274}"/>
+              </a:ext>
+            </a:extLst>
+          </p:cNvPr>
+          <p:cNvSpPr>
+            <a:spLocks noGrp="1"/>
+          </p:cNvSpPr>
+          <p:nvPr>
+            <p:ph idx="1"/>
+          </p:nvPr>
+        </p:nvSpPr>
+        <p:spPr>
+          <a:xfrm>
+            <a:off x="838200" y="1825625"/>
+            <a:ext cx="10515600" cy="1152965"/>
+          </a:xfrm>
+        </p:spPr>
+        <p:txBody>
+          <a:bodyPr>
+            <a:normAutofit/>
+          </a:bodyPr>
+          <a:lstStyle/>
+          <a:p>
+            <a:pPr marL="0" indent="0" algn="ctr">
+              <a:buNone/>
+            </a:pPr>
+            <a:r>
+              <a:rPr lang="cs-CZ" sz="6600" dirty="0"/>
+              <a:t>Co je to </a:t>
+            </a:r>
+            <a:r>
+              <a:rPr lang="cs-CZ" sz="6600" b="1" dirty="0"/>
+              <a:t>proměnná</a:t>
+            </a:r>
+            <a:r>
+              <a:rPr lang="cs-CZ" sz="6600" dirty="0"/>
+              <a:t>?</a:t>
+            </a:r>
+          </a:p>
+        </p:txBody>
+      </p:sp>
+      <p:sp>
+        <p:nvSpPr>
+          <p:cNvPr id="6" name="Zástupný obsah 2">
+            <a:extLst>
+              <a:ext uri="{FF2B5EF4-FFF2-40B4-BE49-F238E27FC236}">
+                <a16:creationId xmlns:a16="http://schemas.microsoft.com/office/drawing/2014/main" id="{215216EB-B9F2-6454-B463-AFED31114BA9}"/>
+              </a:ext>
+            </a:extLst>
+          </p:cNvPr>
+          <p:cNvSpPr txBox="1">
+            <a:spLocks/>
+          </p:cNvSpPr>
+          <p:nvPr/>
+        </p:nvSpPr>
+        <p:spPr>
+          <a:xfrm>
+            <a:off x="838200" y="3091601"/>
+            <a:ext cx="10515600" cy="1498506"/>
+          </a:xfrm>
+          <a:prstGeom prst="rect">
+            <a:avLst/>
+          </a:prstGeom>
+        </p:spPr>
+        <p:txBody>
+          <a:bodyPr vert="horz" lIns="91440" tIns="45720" rIns="91440" bIns="45720" rtlCol="0">
+            <a:normAutofit fontScale="85000" lnSpcReduction="20000"/>
+          </a:bodyPr>
+          <a:lstStyle>
+            <a:lvl1pPr marL="228600" indent="-228600" algn="l" defTabSz="914400" rtl="0" eaLnBrk="1" latinLnBrk="0" hangingPunct="1">
+              <a:lnSpc>
+                <a:spcPct val="90000"/>
+              </a:lnSpc>
+              <a:spcBef>
+                <a:spcPts val="1000"/>
+              </a:spcBef>
+              <a:buFont typeface="Arial" panose="020B0604020202020204" pitchFamily="34" charset="0"/>
+              <a:buChar char="•"/>
+              <a:defRPr sz="2800" kern="1200">
+                <a:solidFill>
+                  <a:schemeClr val="tx1"/>
+                </a:solidFill>
+                <a:latin typeface="+mn-lt"/>
+                <a:ea typeface="+mn-ea"/>
+                <a:cs typeface="+mn-cs"/>
+              </a:defRPr>
+            </a:lvl1pPr>
+            <a:lvl2pPr marL="685800" indent="-228600" algn="l" defTabSz="914400" rtl="0" eaLnBrk="1" latinLnBrk="0" hangingPunct="1">
+              <a:lnSpc>
+                <a:spcPct val="90000"/>
+              </a:lnSpc>
+              <a:spcBef>
+                <a:spcPts val="500"/>
+              </a:spcBef>
+              <a:buFont typeface="Arial" panose="020B0604020202020204" pitchFamily="34" charset="0"/>
+              <a:buChar char="•"/>
+              <a:defRPr sz="2400" kern="1200">
+                <a:solidFill>
+                  <a:schemeClr val="tx1"/>
+                </a:solidFill>
+                <a:latin typeface="+mn-lt"/>
+                <a:ea typeface="+mn-ea"/>
+                <a:cs typeface="+mn-cs"/>
+              </a:defRPr>
+            </a:lvl2pPr>
+            <a:lvl3pPr marL="1143000" indent="-228600" algn="l" defTabSz="914400" rtl="0" eaLnBrk="1" latinLnBrk="0" hangingPunct="1">
+              <a:lnSpc>
+                <a:spcPct val="90000"/>
+              </a:lnSpc>
+              <a:spcBef>
+                <a:spcPts val="500"/>
+              </a:spcBef>
+              <a:buFont typeface="Arial" panose="020B0604020202020204" pitchFamily="34" charset="0"/>
+              <a:buChar char="•"/>
+              <a:defRPr sz="2000" kern="1200">
+                <a:solidFill>
+                  <a:schemeClr val="tx1"/>
+                </a:solidFill>
+                <a:latin typeface="+mn-lt"/>
+                <a:ea typeface="+mn-ea"/>
+                <a:cs typeface="+mn-cs"/>
+              </a:defRPr>
+            </a:lvl3pPr>
+            <a:lvl4pPr marL="1600200" indent="-228600" algn="l" defTabSz="914400" rtl="0" eaLnBrk="1" latinLnBrk="0" hangingPunct="1">
+              <a:lnSpc>
+                <a:spcPct val="90000"/>
+              </a:lnSpc>
+              <a:spcBef>
+                <a:spcPts val="500"/>
+              </a:spcBef>
+              <a:buFont typeface="Arial" panose="020B0604020202020204" pitchFamily="34" charset="0"/>
+              <a:buChar char="•"/>
+              <a:defRPr sz="1800" kern="1200">
+                <a:solidFill>
+                  <a:schemeClr val="tx1"/>
+                </a:solidFill>
+                <a:latin typeface="+mn-lt"/>
+                <a:ea typeface="+mn-ea"/>
+                <a:cs typeface="+mn-cs"/>
+              </a:defRPr>
+            </a:lvl4pPr>
+            <a:lvl5pPr marL="2057400" indent="-228600" algn="l" defTabSz="914400" rtl="0" eaLnBrk="1" latinLnBrk="0" hangingPunct="1">
+              <a:lnSpc>
+                <a:spcPct val="90000"/>
+              </a:lnSpc>
+              <a:spcBef>
+                <a:spcPts val="500"/>
+              </a:spcBef>
+              <a:buFont typeface="Arial" panose="020B0604020202020204" pitchFamily="34" charset="0"/>
+              <a:buChar char="•"/>
+              <a:defRPr sz="1800" kern="1200">
+                <a:solidFill>
+                  <a:schemeClr val="tx1"/>
+                </a:solidFill>
+                <a:latin typeface="+mn-lt"/>
+                <a:ea typeface="+mn-ea"/>
+                <a:cs typeface="+mn-cs"/>
+              </a:defRPr>
+            </a:lvl5pPr>
+            <a:lvl6pPr marL="2514600" indent="-228600" algn="l" defTabSz="914400" rtl="0" eaLnBrk="1" latinLnBrk="0" hangingPunct="1">
+              <a:lnSpc>
+                <a:spcPct val="90000"/>
+              </a:lnSpc>
+              <a:spcBef>
+                <a:spcPts val="500"/>
+              </a:spcBef>
+              <a:buFont typeface="Arial" panose="020B0604020202020204" pitchFamily="34" charset="0"/>
+              <a:buChar char="•"/>
+              <a:defRPr sz="1800" kern="1200">
+                <a:solidFill>
+                  <a:schemeClr val="tx1"/>
+                </a:solidFill>
+                <a:latin typeface="+mn-lt"/>
+                <a:ea typeface="+mn-ea"/>
+                <a:cs typeface="+mn-cs"/>
+              </a:defRPr>
+            </a:lvl6pPr>
+            <a:lvl7pPr marL="2971800" indent="-228600" algn="l" defTabSz="914400" rtl="0" eaLnBrk="1" latinLnBrk="0" hangingPunct="1">
+              <a:lnSpc>
+                <a:spcPct val="90000"/>
+              </a:lnSpc>
+              <a:spcBef>
+                <a:spcPts val="500"/>
+              </a:spcBef>
+              <a:buFont typeface="Arial" panose="020B0604020202020204" pitchFamily="34" charset="0"/>
+              <a:buChar char="•"/>
+              <a:defRPr sz="1800" kern="1200">
+                <a:solidFill>
+                  <a:schemeClr val="tx1"/>
+                </a:solidFill>
+                <a:latin typeface="+mn-lt"/>
+                <a:ea typeface="+mn-ea"/>
+                <a:cs typeface="+mn-cs"/>
+              </a:defRPr>
+            </a:lvl7pPr>
+            <a:lvl8pPr marL="3429000" indent="-228600" algn="l" defTabSz="914400" rtl="0" eaLnBrk="1" latinLnBrk="0" hangingPunct="1">
+              <a:lnSpc>
+                <a:spcPct val="90000"/>
+              </a:lnSpc>
+              <a:spcBef>
+                <a:spcPts val="500"/>
+              </a:spcBef>
+              <a:buFont typeface="Arial" panose="020B0604020202020204" pitchFamily="34" charset="0"/>
+              <a:buChar char="•"/>
+              <a:defRPr sz="1800" kern="1200">
+                <a:solidFill>
+                  <a:schemeClr val="tx1"/>
+                </a:solidFill>
+                <a:latin typeface="+mn-lt"/>
+                <a:ea typeface="+mn-ea"/>
+                <a:cs typeface="+mn-cs"/>
+              </a:defRPr>
+            </a:lvl8pPr>
+            <a:lvl9pPr marL="3886200" indent="-228600" algn="l" defTabSz="914400" rtl="0" eaLnBrk="1" latinLnBrk="0" hangingPunct="1">
+              <a:lnSpc>
+                <a:spcPct val="90000"/>
+              </a:lnSpc>
+              <a:spcBef>
+                <a:spcPts val="500"/>
+              </a:spcBef>
+              <a:buFont typeface="Arial" panose="020B0604020202020204" pitchFamily="34" charset="0"/>
+              <a:buChar char="•"/>
+              <a:defRPr sz="1800" kern="1200">
+                <a:solidFill>
+                  <a:schemeClr val="tx1"/>
+                </a:solidFill>
+                <a:latin typeface="+mn-lt"/>
+                <a:ea typeface="+mn-ea"/>
+                <a:cs typeface="+mn-cs"/>
+              </a:defRPr>
+            </a:lvl9pPr>
+          </a:lstStyle>
+          <a:p>
+            <a:pPr marL="0" indent="0" algn="ctr">
+              <a:buNone/>
+            </a:pPr>
+            <a:r>
+              <a:rPr lang="cs-CZ" sz="1800" dirty="0"/>
+              <a:t>= pojmenované místo v operační paměti</a:t>
+            </a:r>
+          </a:p>
+          <a:p>
+            <a:pPr marL="0" indent="0" algn="ctr">
+              <a:buNone/>
+            </a:pPr>
+            <a:r>
+              <a:rPr lang="cs-CZ" sz="1800" dirty="0"/>
+              <a:t>Má </a:t>
+            </a:r>
+            <a:r>
+              <a:rPr lang="cs-CZ" sz="1800" b="1" dirty="0"/>
+              <a:t>jméno, typ, obsah.</a:t>
+            </a:r>
+            <a:endParaRPr lang="cs-CZ" sz="1800" dirty="0"/>
+          </a:p>
+          <a:p>
+            <a:pPr marL="0" indent="0" algn="ctr">
+              <a:buNone/>
+            </a:pPr>
+            <a:r>
+              <a:rPr lang="cs-CZ" sz="1800" dirty="0"/>
+              <a:t>Obsah se může měnit -&gt; proměnná</a:t>
+            </a:r>
+          </a:p>
+          <a:p>
+            <a:pPr marL="0" indent="0" algn="ctr">
+              <a:buNone/>
+            </a:pPr>
+            <a:r>
+              <a:rPr lang="cs-CZ" sz="1800" dirty="0"/>
+              <a:t>V C# je její životnost omezena { … }</a:t>
+            </a:r>
+          </a:p>
+          <a:p>
+            <a:pPr marL="0" indent="0" algn="ctr">
+              <a:buNone/>
+            </a:pPr>
+            <a:r>
+              <a:rPr lang="cs-CZ" sz="1800" dirty="0"/>
+              <a:t>V C# je statické typování – typ každé proměnné musí být znám už za kompilace a pak se nemění</a:t>
+            </a:r>
+          </a:p>
+        </p:txBody>
+      </p:sp>
+    </p:spTree>
+    <p:extLst>
+      <p:ext uri="{BB962C8B-B14F-4D97-AF65-F5344CB8AC3E}">
+        <p14:creationId xmlns:p14="http://schemas.microsoft.com/office/powerpoint/2010/main" val="433613044"/>
+      </p:ext>
+    </p:extLst>
+  </p:cSld>
+  <p:clrMapOvr>
+    <a:masterClrMapping/>
+  </p:clrMapOvr>
+  <p:timing>
+    <p:tnLst>
+      <p:par>
+        <p:cTn id="1" dur="indefinite" restart="never" nodeType="tmRoot">
+          <p:childTnLst>
+            <p:seq concurrent="1" nextAc="seek">
+              <p:cTn id="2" dur="indefinite" nodeType="mainSeq">
+                <p:childTnLst>
+                  <p:par>
+                    <p:cTn id="3" fill="hold">
+                      <p:stCondLst>
+                        <p:cond delay="indefinite"/>
+                      </p:stCondLst>
+                      <p:childTnLst>
+                        <p:par>
+                          <p:cTn id="4" fill="hold">
+                            <p:stCondLst>
+                              <p:cond delay="0"/>
+                            </p:stCondLst>
+                            <p:childTnLst>
+                              <p:par>
+                                <p:cTn id="5" presetID="10" presetClass="entr" presetSubtype="0" fill="hold" grpId="0" nodeType="clickEffect">
+                                  <p:stCondLst>
+                                    <p:cond delay="0"/>
+                                  </p:stCondLst>
+                                  <p:childTnLst>
+                                    <p:set>
+                                      <p:cBhvr>
+                                        <p:cTn id="6" dur="1" fill="hold">
+                                          <p:stCondLst>
+                                            <p:cond delay="0"/>
+                                          </p:stCondLst>
+                                        </p:cTn>
+                                        <p:tgtEl>
+                                          <p:spTgt spid="6"/>
+                                        </p:tgtEl>
+                                        <p:attrNameLst>
+                                          <p:attrName>style.visibility</p:attrName>
+                                        </p:attrNameLst>
+                                      </p:cBhvr>
+                                      <p:to>
+                                        <p:strVal val="visible"/>
+                                      </p:to>
+                                    </p:set>
+                                    <p:animEffect transition="in" filter="fade">
+                                      <p:cBhvr>
+                                        <p:cTn id="7" dur="500"/>
+                                        <p:tgtEl>
+                                          <p:spTgt spid="6"/>
+                                        </p:tgtEl>
+                                      </p:cBhvr>
+                                    </p:animEffect>
+                                  </p:childTnLst>
+                                </p:cTn>
+                              </p:par>
+                            </p:childTnLst>
+                          </p:cTn>
+                        </p:par>
+                      </p:childTnLst>
+                    </p:cTn>
+                  </p:par>
+                </p:childTnLst>
+              </p:cTn>
+              <p:prevCondLst>
+                <p:cond evt="onPrev" delay="0">
+                  <p:tgtEl>
+                    <p:sldTgt/>
+                  </p:tgtEl>
+                </p:cond>
+              </p:prevCondLst>
+              <p:nextCondLst>
+                <p:cond evt="onNext" delay="0">
+                  <p:tgtEl>
+                    <p:sldTgt/>
+                  </p:tgtEl>
+                </p:cond>
+              </p:nextCondLst>
+            </p:seq>
+          </p:childTnLst>
+        </p:cTn>
+      </p:par>
+    </p:tnLst>
+    <p:bldLst>
+      <p:bldP spid="6" grpId="0"/>
+    </p:bldLst>
+  </p:timing>
+</p:sld>
+</file>
+
+<file path=ppt/slides/slide4.xml><?xml version="1.0" encoding="utf-8"?>
+<p:sld xmlns:a="http://schemas.openxmlformats.org/drawingml/2006/main" xmlns:r="http://schemas.openxmlformats.org/officeDocument/2006/relationships" xmlns:p="http://schemas.openxmlformats.org/presentationml/2006/main">
+  <p:cSld>
+    <p:spTree>
+      <p:nvGrpSpPr>
+        <p:cNvPr id="1" name=""/>
+        <p:cNvGrpSpPr/>
+        <p:nvPr/>
+      </p:nvGrpSpPr>
+      <p:grpSpPr>
+        <a:xfrm>
+          <a:off x="0" y="0"/>
+          <a:ext cx="0" cy="0"/>
+          <a:chOff x="0" y="0"/>
+          <a:chExt cx="0" cy="0"/>
+        </a:xfrm>
+      </p:grpSpPr>
+      <p:sp>
+        <p:nvSpPr>
           <p:cNvPr id="2" name="Nadpis 1">
             <a:extLst>
               <a:ext uri="{FF2B5EF4-FFF2-40B4-BE49-F238E27FC236}">
@@ -10570,7 +12387,7 @@
           <p:nvPr>
             <p:extLst>
               <p:ext uri="{D42A27DB-BD31-4B8C-83A1-F6EECF244321}">
-                <p14:modId xmlns:p14="http://schemas.microsoft.com/office/powerpoint/2010/main" val="1460079839"/>
+                <p14:modId xmlns:p14="http://schemas.microsoft.com/office/powerpoint/2010/main" val="431529217"/>
               </p:ext>
             </p:extLst>
           </p:nvPr>
@@ -11172,7 +12989,12 @@
                       <a:headEnd type="none" w="med" len="med"/>
                       <a:tailEnd type="none" w="med" len="med"/>
                     </a:lnB>
-                    <a:noFill/>
+                    <a:solidFill>
+                      <a:schemeClr val="accent6">
+                        <a:lumMod val="20000"/>
+                        <a:lumOff val="80000"/>
+                      </a:schemeClr>
+                    </a:solidFill>
                   </a:tcPr>
                 </a:tc>
                 <a:tc>
@@ -11229,7 +13051,12 @@
                       <a:headEnd type="none" w="med" len="med"/>
                       <a:tailEnd type="none" w="med" len="med"/>
                     </a:lnB>
-                    <a:noFill/>
+                    <a:solidFill>
+                      <a:schemeClr val="accent6">
+                        <a:lumMod val="20000"/>
+                        <a:lumOff val="80000"/>
+                      </a:schemeClr>
+                    </a:solidFill>
                   </a:tcPr>
                 </a:tc>
                 <a:tc>
@@ -11286,7 +13113,12 @@
                       <a:headEnd type="none" w="med" len="med"/>
                       <a:tailEnd type="none" w="med" len="med"/>
                     </a:lnB>
-                    <a:noFill/>
+                    <a:solidFill>
+                      <a:schemeClr val="accent6">
+                        <a:lumMod val="20000"/>
+                        <a:lumOff val="80000"/>
+                      </a:schemeClr>
+                    </a:solidFill>
                   </a:tcPr>
                 </a:tc>
                 <a:tc>
@@ -11343,7 +13175,12 @@
                       <a:headEnd type="none" w="med" len="med"/>
                       <a:tailEnd type="none" w="med" len="med"/>
                     </a:lnB>
-                    <a:noFill/>
+                    <a:solidFill>
+                      <a:schemeClr val="accent6">
+                        <a:lumMod val="20000"/>
+                        <a:lumOff val="80000"/>
+                      </a:schemeClr>
+                    </a:solidFill>
                   </a:tcPr>
                 </a:tc>
                 <a:extLst>
@@ -11671,9 +13508,20 @@
 </p:sld>
 </file>
 
-<file path=ppt/slides/slide4.xml><?xml version="1.0" encoding="utf-8"?>
+<file path=ppt/slides/slide5.xml><?xml version="1.0" encoding="utf-8"?>
 <p:sld xmlns:a="http://schemas.openxmlformats.org/drawingml/2006/main" xmlns:r="http://schemas.openxmlformats.org/officeDocument/2006/relationships" xmlns:p="http://schemas.openxmlformats.org/presentationml/2006/main">
   <p:cSld>
+    <p:bg>
+      <p:bgPr>
+        <a:solidFill>
+          <a:schemeClr val="accent6">
+            <a:lumMod val="20000"/>
+            <a:lumOff val="80000"/>
+          </a:schemeClr>
+        </a:solidFill>
+        <a:effectLst/>
+      </p:bgPr>
+    </p:bg>
     <p:spTree>
       <p:nvGrpSpPr>
         <p:cNvPr id="1" name=""/>
@@ -11781,7 +13629,7 @@
 </p:sld>
 </file>
 
-<file path=ppt/slides/slide5.xml><?xml version="1.0" encoding="utf-8"?>
+<file path=ppt/slides/slide6.xml><?xml version="1.0" encoding="utf-8"?>
 <p:sld xmlns:a="http://schemas.openxmlformats.org/drawingml/2006/main" xmlns:r="http://schemas.openxmlformats.org/officeDocument/2006/relationships" xmlns:p="http://schemas.openxmlformats.org/presentationml/2006/main">
   <p:cSld>
     <p:spTree>
@@ -12901,7 +14749,7 @@
 </p:sld>
 </file>
 
-<file path=ppt/slides/slide6.xml><?xml version="1.0" encoding="utf-8"?>
+<file path=ppt/slides/slide7.xml><?xml version="1.0" encoding="utf-8"?>
 <p:sld xmlns:a="http://schemas.openxmlformats.org/drawingml/2006/main" xmlns:r="http://schemas.openxmlformats.org/officeDocument/2006/relationships" xmlns:p="http://schemas.openxmlformats.org/presentationml/2006/main">
   <p:cSld>
     <p:spTree>
@@ -13000,9 +14848,20 @@
 </p:sld>
 </file>
 
-<file path=ppt/slides/slide7.xml><?xml version="1.0" encoding="utf-8"?>
+<file path=ppt/slides/slide8.xml><?xml version="1.0" encoding="utf-8"?>
 <p:sld xmlns:a="http://schemas.openxmlformats.org/drawingml/2006/main" xmlns:r="http://schemas.openxmlformats.org/officeDocument/2006/relationships" xmlns:p="http://schemas.openxmlformats.org/presentationml/2006/main">
   <p:cSld>
+    <p:bg>
+      <p:bgPr>
+        <a:solidFill>
+          <a:schemeClr val="accent6">
+            <a:lumMod val="20000"/>
+            <a:lumOff val="80000"/>
+          </a:schemeClr>
+        </a:solidFill>
+        <a:effectLst/>
+      </p:bgPr>
+    </p:bg>
     <p:spTree>
       <p:nvGrpSpPr>
         <p:cNvPr id="1" name=""/>
@@ -13412,6 +15271,59 @@
                       </p:childTnLst>
                     </p:cTn>
                   </p:par>
+                  <p:par>
+                    <p:cTn id="18" fill="hold">
+                      <p:stCondLst>
+                        <p:cond delay="indefinite"/>
+                      </p:stCondLst>
+                      <p:childTnLst>
+                        <p:par>
+                          <p:cTn id="19" fill="hold">
+                            <p:stCondLst>
+                              <p:cond delay="0"/>
+                            </p:stCondLst>
+                            <p:childTnLst>
+                              <p:par>
+                                <p:cTn id="20" presetID="10" presetClass="entr" presetSubtype="0" fill="hold" grpId="0" nodeType="clickEffect">
+                                  <p:stCondLst>
+                                    <p:cond delay="0"/>
+                                  </p:stCondLst>
+                                  <p:childTnLst>
+                                    <p:set>
+                                      <p:cBhvr>
+                                        <p:cTn id="21" dur="1" fill="hold">
+                                          <p:stCondLst>
+                                            <p:cond delay="0"/>
+                                          </p:stCondLst>
+                                        </p:cTn>
+                                        <p:tgtEl>
+                                          <p:spTgt spid="10"/>
+                                        </p:tgtEl>
+                                        <p:attrNameLst>
+                                          <p:attrName>style.visibility</p:attrName>
+                                        </p:attrNameLst>
+                                      </p:cBhvr>
+                                      <p:to>
+                                        <p:strVal val="visible"/>
+                                      </p:to>
+                                    </p:set>
+                                    <p:animEffect transition="in" filter="fade">
+                                      <p:cBhvr>
+                                        <p:cTn id="22" dur="500"/>
+                                        <p:tgtEl>
+                                          <p:spTgt spid="10"/>
+                                        </p:tgtEl>
+                                      </p:cBhvr>
+                                    </p:animEffect>
+                                  </p:childTnLst>
+                                </p:cTn>
+                              </p:par>
+                            </p:childTnLst>
+                          </p:cTn>
+                        </p:par>
+                      </p:childTnLst>
+                    </p:cTn>
+                  </p:par>
                 </p:childTnLst>
               </p:cTn>
               <p:prevCondLst>
@@ -13433,11 +15345,14 @@
         </p:cTn>
       </p:par>
     </p:tnLst>
+    <p:bldLst>
+      <p:bldP spid="10" grpId="0"/>
+    </p:bldLst>
   </p:timing>
 </p:sld>
 </file>
 
-<file path=ppt/slides/slide8.xml><?xml version="1.0" encoding="utf-8"?>
+<file path=ppt/slides/slide9.xml><?xml version="1.0" encoding="utf-8"?>
 <p:sld xmlns:a="http://schemas.openxmlformats.org/drawingml/2006/main" xmlns:r="http://schemas.openxmlformats.org/officeDocument/2006/relationships" xmlns:p="http://schemas.openxmlformats.org/presentationml/2006/main">
   <p:cSld>
     <p:spTree>
@@ -13538,7 +15453,7 @@
           <p:nvPr>
             <p:extLst>
               <p:ext uri="{D42A27DB-BD31-4B8C-83A1-F6EECF244321}">
-                <p14:modId xmlns:p14="http://schemas.microsoft.com/office/powerpoint/2010/main" val="785928885"/>
+                <p14:modId xmlns:p14="http://schemas.microsoft.com/office/powerpoint/2010/main" val="2476371086"/>
               </p:ext>
             </p:extLst>
           </p:nvPr>
@@ -13891,7 +15806,12 @@
                       <a:headEnd type="none" w="med" len="med"/>
                       <a:tailEnd type="none" w="med" len="med"/>
                     </a:lnB>
-                    <a:noFill/>
+                    <a:solidFill>
+                      <a:schemeClr val="accent6">
+                        <a:lumMod val="20000"/>
+                        <a:lumOff val="80000"/>
+                      </a:schemeClr>
+                    </a:solidFill>
                   </a:tcPr>
                 </a:tc>
                 <a:tc>
@@ -13948,7 +15868,12 @@
                       <a:headEnd type="none" w="med" len="med"/>
                       <a:tailEnd type="none" w="med" len="med"/>
                     </a:lnB>
-                    <a:noFill/>
+                    <a:solidFill>
+                      <a:schemeClr val="accent6">
+                        <a:lumMod val="20000"/>
+                        <a:lumOff val="80000"/>
+                      </a:schemeClr>
+                    </a:solidFill>
                   </a:tcPr>
                 </a:tc>
                 <a:tc>
@@ -14005,7 +15930,12 @@
                       <a:headEnd type="none" w="med" len="med"/>
                       <a:tailEnd type="none" w="med" len="med"/>
                     </a:lnB>
-                    <a:noFill/>
+                    <a:solidFill>
+                      <a:schemeClr val="accent6">
+                        <a:lumMod val="20000"/>
+                        <a:lumOff val="80000"/>
+                      </a:schemeClr>
+                    </a:solidFill>
                   </a:tcPr>
                 </a:tc>
                 <a:tc>
@@ -14017,7 +15947,7 @@
                         <a:buNone/>
                       </a:pPr>
                       <a:r>
-                        <a:rPr lang="cs-CZ">
+                        <a:rPr lang="cs-CZ" dirty="0">
                           <a:effectLst/>
                           <a:latin typeface="Google Sans Text"/>
                         </a:rPr>
@@ -14062,7 +15992,12 @@
                       <a:headEnd type="none" w="med" len="med"/>
                       <a:tailEnd type="none" w="med" len="med"/>
                     </a:lnB>
-                    <a:noFill/>
+                    <a:solidFill>
+                      <a:schemeClr val="accent6">
+                        <a:lumMod val="20000"/>
+                        <a:lumOff val="80000"/>
+                      </a:schemeClr>
+                    </a:solidFill>
                   </a:tcPr>
                 </a:tc>
                 <a:extLst>
@@ -14807,1384 +16742,6 @@
     <p:extLst>
       <p:ext uri="{BB962C8B-B14F-4D97-AF65-F5344CB8AC3E}">
         <p14:creationId xmlns:p14="http://schemas.microsoft.com/office/powerpoint/2010/main" val="606161950"/>
-      </p:ext>
-    </p:extLst>
-  </p:cSld>
-  <p:clrMapOvr>
-    <a:masterClrMapping/>
-  </p:clrMapOvr>
-</p:sld>
-</file>
-
-<file path=ppt/slides/slide9.xml><?xml version="1.0" encoding="utf-8"?>
-<p:sld xmlns:a="http://schemas.openxmlformats.org/drawingml/2006/main" xmlns:r="http://schemas.openxmlformats.org/officeDocument/2006/relationships" xmlns:p="http://schemas.openxmlformats.org/presentationml/2006/main">
-  <p:cSld>
-    <p:spTree>
-      <p:nvGrpSpPr>
-        <p:cNvPr id="1" name=""/>
-        <p:cNvGrpSpPr/>
-        <p:nvPr/>
-      </p:nvGrpSpPr>
-      <p:grpSpPr>
-        <a:xfrm>
-          <a:off x="0" y="0"/>
-          <a:ext cx="0" cy="0"/>
-          <a:chOff x="0" y="0"/>
-          <a:chExt cx="0" cy="0"/>
-        </a:xfrm>
-      </p:grpSpPr>
-      <p:sp>
-        <p:nvSpPr>
-          <p:cNvPr id="2" name="Nadpis 1">
-            <a:extLst>
-              <a:ext uri="{FF2B5EF4-FFF2-40B4-BE49-F238E27FC236}">
-                <a16:creationId xmlns:a16="http://schemas.microsoft.com/office/drawing/2014/main" id="{F7D93DF5-4BC0-2B15-3889-75B6505A408B}"/>
-              </a:ext>
-            </a:extLst>
-          </p:cNvPr>
-          <p:cNvSpPr>
-            <a:spLocks noGrp="1"/>
-          </p:cNvSpPr>
-          <p:nvPr>
-            <p:ph type="title"/>
-          </p:nvPr>
-        </p:nvSpPr>
-        <p:spPr/>
-        <p:txBody>
-          <a:bodyPr/>
-          <a:lstStyle/>
-          <a:p>
-            <a:r>
-              <a:rPr lang="cs-CZ" dirty="0"/>
-              <a:t>Základní jednoduché datové typy</a:t>
-            </a:r>
-          </a:p>
-        </p:txBody>
-      </p:sp>
-      <p:sp>
-        <p:nvSpPr>
-          <p:cNvPr id="3" name="Zástupný obsah 2">
-            <a:extLst>
-              <a:ext uri="{FF2B5EF4-FFF2-40B4-BE49-F238E27FC236}">
-                <a16:creationId xmlns:a16="http://schemas.microsoft.com/office/drawing/2014/main" id="{B1046E1E-20A0-2EA3-F4F9-878093D89111}"/>
-              </a:ext>
-            </a:extLst>
-          </p:cNvPr>
-          <p:cNvSpPr>
-            <a:spLocks noGrp="1"/>
-          </p:cNvSpPr>
-          <p:nvPr>
-            <p:ph idx="1"/>
-          </p:nvPr>
-        </p:nvSpPr>
-        <p:spPr>
-          <a:xfrm>
-            <a:off x="838200" y="1825625"/>
-            <a:ext cx="10515600" cy="718399"/>
-          </a:xfrm>
-        </p:spPr>
-        <p:txBody>
-          <a:bodyPr/>
-          <a:lstStyle/>
-          <a:p>
-            <a:r>
-              <a:rPr lang="cs-CZ" dirty="0"/>
-              <a:t>Celočíselné neznaménkové (</a:t>
-            </a:r>
-            <a:r>
-              <a:rPr lang="cs-CZ" dirty="0" err="1"/>
-              <a:t>unsigned</a:t>
-            </a:r>
-            <a:r>
-              <a:rPr lang="cs-CZ" dirty="0"/>
-              <a:t>) typy</a:t>
-            </a:r>
-          </a:p>
-          <a:p>
-            <a:endParaRPr lang="cs-CZ" dirty="0"/>
-          </a:p>
-        </p:txBody>
-      </p:sp>
-      <p:graphicFrame>
-        <p:nvGraphicFramePr>
-          <p:cNvPr id="4" name="Tabulka 3">
-            <a:extLst>
-              <a:ext uri="{FF2B5EF4-FFF2-40B4-BE49-F238E27FC236}">
-                <a16:creationId xmlns:a16="http://schemas.microsoft.com/office/drawing/2014/main" id="{8653E899-3479-1EB1-172B-323EDCC90B0C}"/>
-              </a:ext>
-            </a:extLst>
-          </p:cNvPr>
-          <p:cNvGraphicFramePr>
-            <a:graphicFrameLocks noGrp="1"/>
-          </p:cNvGraphicFramePr>
-          <p:nvPr>
-            <p:extLst>
-              <p:ext uri="{D42A27DB-BD31-4B8C-83A1-F6EECF244321}">
-                <p14:modId xmlns:p14="http://schemas.microsoft.com/office/powerpoint/2010/main" val="2458809360"/>
-              </p:ext>
-            </p:extLst>
-          </p:nvPr>
-        </p:nvGraphicFramePr>
-        <p:xfrm>
-          <a:off x="838200" y="3086894"/>
-          <a:ext cx="10515600" cy="1828800"/>
-        </p:xfrm>
-        <a:graphic>
-          <a:graphicData uri="http://schemas.openxmlformats.org/drawingml/2006/table">
-            <a:tbl>
-              <a:tblPr/>
-              <a:tblGrid>
-                <a:gridCol w="2628900">
-                  <a:extLst>
-                    <a:ext uri="{9D8B030D-6E8A-4147-A177-3AD203B41FA5}">
-                      <a16:colId xmlns:a16="http://schemas.microsoft.com/office/drawing/2014/main" val="1018705036"/>
-                    </a:ext>
-                  </a:extLst>
-                </a:gridCol>
-                <a:gridCol w="2628900">
-                  <a:extLst>
-                    <a:ext uri="{9D8B030D-6E8A-4147-A177-3AD203B41FA5}">
-                      <a16:colId xmlns:a16="http://schemas.microsoft.com/office/drawing/2014/main" val="2030810957"/>
-                    </a:ext>
-                  </a:extLst>
-                </a:gridCol>
-                <a:gridCol w="2628900">
-                  <a:extLst>
-                    <a:ext uri="{9D8B030D-6E8A-4147-A177-3AD203B41FA5}">
-                      <a16:colId xmlns:a16="http://schemas.microsoft.com/office/drawing/2014/main" val="220766276"/>
-                    </a:ext>
-                  </a:extLst>
-                </a:gridCol>
-                <a:gridCol w="2628900">
-                  <a:extLst>
-                    <a:ext uri="{9D8B030D-6E8A-4147-A177-3AD203B41FA5}">
-                      <a16:colId xmlns:a16="http://schemas.microsoft.com/office/drawing/2014/main" val="12375235"/>
-                    </a:ext>
-                  </a:extLst>
-                </a:gridCol>
-              </a:tblGrid>
-              <a:tr h="0">
-                <a:tc>
-                  <a:txBody>
-                    <a:bodyPr/>
-                    <a:lstStyle/>
-                    <a:p>
-                      <a:pPr>
-                        <a:buNone/>
-                      </a:pPr>
-                      <a:r>
-                        <a:rPr lang="cs-CZ" b="1">
-                          <a:effectLst/>
-                          <a:latin typeface="Google Sans Text"/>
-                        </a:rPr>
-                        <a:t>C# Typ</a:t>
-                      </a:r>
-                      <a:endParaRPr lang="cs-CZ">
-                        <a:effectLst/>
-                        <a:latin typeface="Google Sans Text"/>
-                      </a:endParaRPr>
-                    </a:p>
-                  </a:txBody>
-                  <a:tcPr anchor="ctr">
-                    <a:lnL w="9525" cap="flat" cmpd="sng" algn="ctr">
-                      <a:solidFill>
-                        <a:schemeClr val="bg1"/>
-                      </a:solidFill>
-                      <a:prstDash val="solid"/>
-                      <a:round/>
-                      <a:headEnd type="none" w="med" len="med"/>
-                      <a:tailEnd type="none" w="med" len="med"/>
-                    </a:lnL>
-                    <a:lnR w="9525" cap="flat" cmpd="sng" algn="ctr">
-                      <a:solidFill>
-                        <a:schemeClr val="bg1"/>
-                      </a:solidFill>
-                      <a:prstDash val="solid"/>
-                      <a:round/>
-                      <a:headEnd type="none" w="med" len="med"/>
-                      <a:tailEnd type="none" w="med" len="med"/>
-                    </a:lnR>
-                    <a:lnT w="9525" cap="flat" cmpd="sng" algn="ctr">
-                      <a:solidFill>
-                        <a:schemeClr val="bg1"/>
-                      </a:solidFill>
-                      <a:prstDash val="solid"/>
-                      <a:round/>
-                      <a:headEnd type="none" w="med" len="med"/>
-                      <a:tailEnd type="none" w="med" len="med"/>
-                    </a:lnT>
-                    <a:lnB w="9525" cap="flat" cmpd="sng" algn="ctr">
-                      <a:solidFill>
-                        <a:schemeClr val="bg1"/>
-                      </a:solidFill>
-                      <a:prstDash val="solid"/>
-                      <a:round/>
-                      <a:headEnd type="none" w="med" len="med"/>
-                      <a:tailEnd type="none" w="med" len="med"/>
-                    </a:lnB>
-                    <a:noFill/>
-                  </a:tcPr>
-                </a:tc>
-                <a:tc>
-                  <a:txBody>
-                    <a:bodyPr/>
-                    <a:lstStyle/>
-                    <a:p>
-                      <a:pPr>
-                        <a:buNone/>
-                      </a:pPr>
-                      <a:r>
-                        <a:rPr lang="cs-CZ" b="1">
-                          <a:effectLst/>
-                          <a:latin typeface="Google Sans Text"/>
-                        </a:rPr>
-                        <a:t>.NET Typ</a:t>
-                      </a:r>
-                      <a:endParaRPr lang="cs-CZ">
-                        <a:effectLst/>
-                        <a:latin typeface="Google Sans Text"/>
-                      </a:endParaRPr>
-                    </a:p>
-                  </a:txBody>
-                  <a:tcPr anchor="ctr">
-                    <a:lnL w="9525" cap="flat" cmpd="sng" algn="ctr">
-                      <a:solidFill>
-                        <a:schemeClr val="bg1"/>
-                      </a:solidFill>
-                      <a:prstDash val="solid"/>
-                      <a:round/>
-                      <a:headEnd type="none" w="med" len="med"/>
-                      <a:tailEnd type="none" w="med" len="med"/>
-                    </a:lnL>
-                    <a:lnR w="9525" cap="flat" cmpd="sng" algn="ctr">
-                      <a:solidFill>
-                        <a:schemeClr val="bg1"/>
-                      </a:solidFill>
-                      <a:prstDash val="solid"/>
-                      <a:round/>
-                      <a:headEnd type="none" w="med" len="med"/>
-                      <a:tailEnd type="none" w="med" len="med"/>
-                    </a:lnR>
-                    <a:lnT w="9525" cap="flat" cmpd="sng" algn="ctr">
-                      <a:solidFill>
-                        <a:schemeClr val="bg1"/>
-                      </a:solidFill>
-                      <a:prstDash val="solid"/>
-                      <a:round/>
-                      <a:headEnd type="none" w="med" len="med"/>
-                      <a:tailEnd type="none" w="med" len="med"/>
-                    </a:lnT>
-                    <a:lnB w="9525" cap="flat" cmpd="sng" algn="ctr">
-                      <a:solidFill>
-                        <a:schemeClr val="bg1"/>
-                      </a:solidFill>
-                      <a:prstDash val="solid"/>
-                      <a:round/>
-                      <a:headEnd type="none" w="med" len="med"/>
-                      <a:tailEnd type="none" w="med" len="med"/>
-                    </a:lnB>
-                    <a:noFill/>
-                  </a:tcPr>
-                </a:tc>
-                <a:tc>
-                  <a:txBody>
-                    <a:bodyPr/>
-                    <a:lstStyle/>
-                    <a:p>
-                      <a:pPr>
-                        <a:buNone/>
-                      </a:pPr>
-                      <a:r>
-                        <a:rPr lang="cs-CZ" b="1">
-                          <a:effectLst/>
-                          <a:latin typeface="Google Sans Text"/>
-                        </a:rPr>
-                        <a:t>Velikost (Byty)</a:t>
-                      </a:r>
-                      <a:endParaRPr lang="cs-CZ">
-                        <a:effectLst/>
-                        <a:latin typeface="Google Sans Text"/>
-                      </a:endParaRPr>
-                    </a:p>
-                  </a:txBody>
-                  <a:tcPr anchor="ctr">
-                    <a:lnL w="9525" cap="flat" cmpd="sng" algn="ctr">
-                      <a:solidFill>
-                        <a:schemeClr val="bg1"/>
-                      </a:solidFill>
-                      <a:prstDash val="solid"/>
-                      <a:round/>
-                      <a:headEnd type="none" w="med" len="med"/>
-                      <a:tailEnd type="none" w="med" len="med"/>
-                    </a:lnL>
-                    <a:lnR w="9525" cap="flat" cmpd="sng" algn="ctr">
-                      <a:solidFill>
-                        <a:schemeClr val="bg1"/>
-                      </a:solidFill>
-                      <a:prstDash val="solid"/>
-                      <a:round/>
-                      <a:headEnd type="none" w="med" len="med"/>
-                      <a:tailEnd type="none" w="med" len="med"/>
-                    </a:lnR>
-                    <a:lnT w="9525" cap="flat" cmpd="sng" algn="ctr">
-                      <a:solidFill>
-                        <a:schemeClr val="bg1"/>
-                      </a:solidFill>
-                      <a:prstDash val="solid"/>
-                      <a:round/>
-                      <a:headEnd type="none" w="med" len="med"/>
-                      <a:tailEnd type="none" w="med" len="med"/>
-                    </a:lnT>
-                    <a:lnB w="9525" cap="flat" cmpd="sng" algn="ctr">
-                      <a:solidFill>
-                        <a:schemeClr val="bg1"/>
-                      </a:solidFill>
-                      <a:prstDash val="solid"/>
-                      <a:round/>
-                      <a:headEnd type="none" w="med" len="med"/>
-                      <a:tailEnd type="none" w="med" len="med"/>
-                    </a:lnB>
-                    <a:noFill/>
-                  </a:tcPr>
-                </a:tc>
-                <a:tc>
-                  <a:txBody>
-                    <a:bodyPr/>
-                    <a:lstStyle/>
-                    <a:p>
-                      <a:pPr>
-                        <a:buNone/>
-                      </a:pPr>
-                      <a:r>
-                        <a:rPr lang="cs-CZ" b="1">
-                          <a:effectLst/>
-                          <a:latin typeface="Google Sans Text"/>
-                        </a:rPr>
-                        <a:t>Rozsah</a:t>
-                      </a:r>
-                      <a:endParaRPr lang="cs-CZ">
-                        <a:effectLst/>
-                        <a:latin typeface="Google Sans Text"/>
-                      </a:endParaRPr>
-                    </a:p>
-                  </a:txBody>
-                  <a:tcPr anchor="ctr">
-                    <a:lnL w="9525" cap="flat" cmpd="sng" algn="ctr">
-                      <a:solidFill>
-                        <a:schemeClr val="bg1"/>
-                      </a:solidFill>
-                      <a:prstDash val="solid"/>
-                      <a:round/>
-                      <a:headEnd type="none" w="med" len="med"/>
-                      <a:tailEnd type="none" w="med" len="med"/>
-                    </a:lnL>
-                    <a:lnR w="9525" cap="flat" cmpd="sng" algn="ctr">
-                      <a:solidFill>
-                        <a:schemeClr val="bg1"/>
-                      </a:solidFill>
-                      <a:prstDash val="solid"/>
-                      <a:round/>
-                      <a:headEnd type="none" w="med" len="med"/>
-                      <a:tailEnd type="none" w="med" len="med"/>
-                    </a:lnR>
-                    <a:lnT w="9525" cap="flat" cmpd="sng" algn="ctr">
-                      <a:solidFill>
-                        <a:schemeClr val="bg1"/>
-                      </a:solidFill>
-                      <a:prstDash val="solid"/>
-                      <a:round/>
-                      <a:headEnd type="none" w="med" len="med"/>
-                      <a:tailEnd type="none" w="med" len="med"/>
-                    </a:lnT>
-                    <a:lnB w="9525" cap="flat" cmpd="sng" algn="ctr">
-                      <a:solidFill>
-                        <a:schemeClr val="bg1"/>
-                      </a:solidFill>
-                      <a:prstDash val="solid"/>
-                      <a:round/>
-                      <a:headEnd type="none" w="med" len="med"/>
-                      <a:tailEnd type="none" w="med" len="med"/>
-                    </a:lnB>
-                    <a:noFill/>
-                  </a:tcPr>
-                </a:tc>
-                <a:extLst>
-                  <a:ext uri="{0D108BD9-81ED-4DB2-BD59-A6C34878D82A}">
-                    <a16:rowId xmlns:a16="http://schemas.microsoft.com/office/drawing/2014/main" val="1365557383"/>
-                  </a:ext>
-                </a:extLst>
-              </a:tr>
-              <a:tr h="0">
-                <a:tc>
-                  <a:txBody>
-                    <a:bodyPr/>
-                    <a:lstStyle/>
-                    <a:p>
-                      <a:pPr>
-                        <a:buNone/>
-                      </a:pPr>
-                      <a:r>
-                        <a:rPr lang="cs-CZ" b="1">
-                          <a:effectLst/>
-                          <a:latin typeface="Google Sans Text"/>
-                        </a:rPr>
-                        <a:t>byte</a:t>
-                      </a:r>
-                      <a:endParaRPr lang="cs-CZ">
-                        <a:effectLst/>
-                        <a:latin typeface="Google Sans Text"/>
-                      </a:endParaRPr>
-                    </a:p>
-                  </a:txBody>
-                  <a:tcPr anchor="ctr">
-                    <a:lnL w="9525" cap="flat" cmpd="sng" algn="ctr">
-                      <a:solidFill>
-                        <a:schemeClr val="bg1"/>
-                      </a:solidFill>
-                      <a:prstDash val="solid"/>
-                      <a:round/>
-                      <a:headEnd type="none" w="med" len="med"/>
-                      <a:tailEnd type="none" w="med" len="med"/>
-                    </a:lnL>
-                    <a:lnR w="9525" cap="flat" cmpd="sng" algn="ctr">
-                      <a:solidFill>
-                        <a:schemeClr val="bg1"/>
-                      </a:solidFill>
-                      <a:prstDash val="solid"/>
-                      <a:round/>
-                      <a:headEnd type="none" w="med" len="med"/>
-                      <a:tailEnd type="none" w="med" len="med"/>
-                    </a:lnR>
-                    <a:lnT w="9525" cap="flat" cmpd="sng" algn="ctr">
-                      <a:solidFill>
-                        <a:schemeClr val="bg1"/>
-                      </a:solidFill>
-                      <a:prstDash val="solid"/>
-                      <a:round/>
-                      <a:headEnd type="none" w="med" len="med"/>
-                      <a:tailEnd type="none" w="med" len="med"/>
-                    </a:lnT>
-                    <a:lnB w="9525" cap="flat" cmpd="sng" algn="ctr">
-                      <a:solidFill>
-                        <a:schemeClr val="bg1"/>
-                      </a:solidFill>
-                      <a:prstDash val="solid"/>
-                      <a:round/>
-                      <a:headEnd type="none" w="med" len="med"/>
-                      <a:tailEnd type="none" w="med" len="med"/>
-                    </a:lnB>
-                    <a:noFill/>
-                  </a:tcPr>
-                </a:tc>
-                <a:tc>
-                  <a:txBody>
-                    <a:bodyPr/>
-                    <a:lstStyle/>
-                    <a:p>
-                      <a:pPr>
-                        <a:buNone/>
-                      </a:pPr>
-                      <a:r>
-                        <a:rPr lang="cs-CZ">
-                          <a:effectLst/>
-                          <a:latin typeface="Google Sans Text"/>
-                        </a:rPr>
-                        <a:t>Byte</a:t>
-                      </a:r>
-                    </a:p>
-                  </a:txBody>
-                  <a:tcPr anchor="ctr">
-                    <a:lnL w="9525" cap="flat" cmpd="sng" algn="ctr">
-                      <a:solidFill>
-                        <a:schemeClr val="bg1"/>
-                      </a:solidFill>
-                      <a:prstDash val="solid"/>
-                      <a:round/>
-                      <a:headEnd type="none" w="med" len="med"/>
-                      <a:tailEnd type="none" w="med" len="med"/>
-                    </a:lnL>
-                    <a:lnR w="9525" cap="flat" cmpd="sng" algn="ctr">
-                      <a:solidFill>
-                        <a:schemeClr val="bg1"/>
-                      </a:solidFill>
-                      <a:prstDash val="solid"/>
-                      <a:round/>
-                      <a:headEnd type="none" w="med" len="med"/>
-                      <a:tailEnd type="none" w="med" len="med"/>
-                    </a:lnR>
-                    <a:lnT w="9525" cap="flat" cmpd="sng" algn="ctr">
-                      <a:solidFill>
-                        <a:schemeClr val="bg1"/>
-                      </a:solidFill>
-                      <a:prstDash val="solid"/>
-                      <a:round/>
-                      <a:headEnd type="none" w="med" len="med"/>
-                      <a:tailEnd type="none" w="med" len="med"/>
-                    </a:lnT>
-                    <a:lnB w="9525" cap="flat" cmpd="sng" algn="ctr">
-                      <a:solidFill>
-                        <a:schemeClr val="bg1"/>
-                      </a:solidFill>
-                      <a:prstDash val="solid"/>
-                      <a:round/>
-                      <a:headEnd type="none" w="med" len="med"/>
-                      <a:tailEnd type="none" w="med" len="med"/>
-                    </a:lnB>
-                    <a:noFill/>
-                  </a:tcPr>
-                </a:tc>
-                <a:tc>
-                  <a:txBody>
-                    <a:bodyPr/>
-                    <a:lstStyle/>
-                    <a:p>
-                      <a:pPr>
-                        <a:buNone/>
-                      </a:pPr>
-                      <a:r>
-                        <a:rPr lang="cs-CZ">
-                          <a:effectLst/>
-                          <a:latin typeface="Google Sans Text"/>
-                        </a:rPr>
-                        <a:t>1 B</a:t>
-                      </a:r>
-                    </a:p>
-                  </a:txBody>
-                  <a:tcPr anchor="ctr">
-                    <a:lnL w="9525" cap="flat" cmpd="sng" algn="ctr">
-                      <a:solidFill>
-                        <a:schemeClr val="bg1"/>
-                      </a:solidFill>
-                      <a:prstDash val="solid"/>
-                      <a:round/>
-                      <a:headEnd type="none" w="med" len="med"/>
-                      <a:tailEnd type="none" w="med" len="med"/>
-                    </a:lnL>
-                    <a:lnR w="9525" cap="flat" cmpd="sng" algn="ctr">
-                      <a:solidFill>
-                        <a:schemeClr val="bg1"/>
-                      </a:solidFill>
-                      <a:prstDash val="solid"/>
-                      <a:round/>
-                      <a:headEnd type="none" w="med" len="med"/>
-                      <a:tailEnd type="none" w="med" len="med"/>
-                    </a:lnR>
-                    <a:lnT w="9525" cap="flat" cmpd="sng" algn="ctr">
-                      <a:solidFill>
-                        <a:schemeClr val="bg1"/>
-                      </a:solidFill>
-                      <a:prstDash val="solid"/>
-                      <a:round/>
-                      <a:headEnd type="none" w="med" len="med"/>
-                      <a:tailEnd type="none" w="med" len="med"/>
-                    </a:lnT>
-                    <a:lnB w="9525" cap="flat" cmpd="sng" algn="ctr">
-                      <a:solidFill>
-                        <a:schemeClr val="bg1"/>
-                      </a:solidFill>
-                      <a:prstDash val="solid"/>
-                      <a:round/>
-                      <a:headEnd type="none" w="med" len="med"/>
-                      <a:tailEnd type="none" w="med" len="med"/>
-                    </a:lnB>
-                    <a:noFill/>
-                  </a:tcPr>
-                </a:tc>
-                <a:tc>
-                  <a:txBody>
-                    <a:bodyPr/>
-                    <a:lstStyle/>
-                    <a:p>
-                      <a:pPr>
-                        <a:buNone/>
-                      </a:pPr>
-                      <a:r>
-                        <a:rPr lang="cs-CZ">
-                          <a:effectLst/>
-                          <a:latin typeface="Google Sans Text"/>
-                        </a:rPr>
-                        <a:t>0 až 255</a:t>
-                      </a:r>
-                    </a:p>
-                  </a:txBody>
-                  <a:tcPr anchor="ctr">
-                    <a:lnL w="9525" cap="flat" cmpd="sng" algn="ctr">
-                      <a:solidFill>
-                        <a:schemeClr val="bg1"/>
-                      </a:solidFill>
-                      <a:prstDash val="solid"/>
-                      <a:round/>
-                      <a:headEnd type="none" w="med" len="med"/>
-                      <a:tailEnd type="none" w="med" len="med"/>
-                    </a:lnL>
-                    <a:lnR w="9525" cap="flat" cmpd="sng" algn="ctr">
-                      <a:solidFill>
-                        <a:schemeClr val="bg1"/>
-                      </a:solidFill>
-                      <a:prstDash val="solid"/>
-                      <a:round/>
-                      <a:headEnd type="none" w="med" len="med"/>
-                      <a:tailEnd type="none" w="med" len="med"/>
-                    </a:lnR>
-                    <a:lnT w="9525" cap="flat" cmpd="sng" algn="ctr">
-                      <a:solidFill>
-                        <a:schemeClr val="bg1"/>
-                      </a:solidFill>
-                      <a:prstDash val="solid"/>
-                      <a:round/>
-                      <a:headEnd type="none" w="med" len="med"/>
-                      <a:tailEnd type="none" w="med" len="med"/>
-                    </a:lnT>
-                    <a:lnB w="9525" cap="flat" cmpd="sng" algn="ctr">
-                      <a:solidFill>
-                        <a:schemeClr val="bg1"/>
-                      </a:solidFill>
-                      <a:prstDash val="solid"/>
-                      <a:round/>
-                      <a:headEnd type="none" w="med" len="med"/>
-                      <a:tailEnd type="none" w="med" len="med"/>
-                    </a:lnB>
-                    <a:noFill/>
-                  </a:tcPr>
-                </a:tc>
-                <a:extLst>
-                  <a:ext uri="{0D108BD9-81ED-4DB2-BD59-A6C34878D82A}">
-                    <a16:rowId xmlns:a16="http://schemas.microsoft.com/office/drawing/2014/main" val="3477171418"/>
-                  </a:ext>
-                </a:extLst>
-              </a:tr>
-              <a:tr h="0">
-                <a:tc>
-                  <a:txBody>
-                    <a:bodyPr/>
-                    <a:lstStyle/>
-                    <a:p>
-                      <a:pPr>
-                        <a:buNone/>
-                      </a:pPr>
-                      <a:r>
-                        <a:rPr lang="cs-CZ" b="1">
-                          <a:effectLst/>
-                          <a:latin typeface="Google Sans Text"/>
-                        </a:rPr>
-                        <a:t>ushort</a:t>
-                      </a:r>
-                      <a:endParaRPr lang="cs-CZ">
-                        <a:effectLst/>
-                        <a:latin typeface="Google Sans Text"/>
-                      </a:endParaRPr>
-                    </a:p>
-                  </a:txBody>
-                  <a:tcPr anchor="ctr">
-                    <a:lnL w="9525" cap="flat" cmpd="sng" algn="ctr">
-                      <a:solidFill>
-                        <a:schemeClr val="bg1"/>
-                      </a:solidFill>
-                      <a:prstDash val="solid"/>
-                      <a:round/>
-                      <a:headEnd type="none" w="med" len="med"/>
-                      <a:tailEnd type="none" w="med" len="med"/>
-                    </a:lnL>
-                    <a:lnR w="9525" cap="flat" cmpd="sng" algn="ctr">
-                      <a:solidFill>
-                        <a:schemeClr val="bg1"/>
-                      </a:solidFill>
-                      <a:prstDash val="solid"/>
-                      <a:round/>
-                      <a:headEnd type="none" w="med" len="med"/>
-                      <a:tailEnd type="none" w="med" len="med"/>
-                    </a:lnR>
-                    <a:lnT w="9525" cap="flat" cmpd="sng" algn="ctr">
-                      <a:solidFill>
-                        <a:schemeClr val="bg1"/>
-                      </a:solidFill>
-                      <a:prstDash val="solid"/>
-                      <a:round/>
-                      <a:headEnd type="none" w="med" len="med"/>
-                      <a:tailEnd type="none" w="med" len="med"/>
-                    </a:lnT>
-                    <a:lnB w="9525" cap="flat" cmpd="sng" algn="ctr">
-                      <a:solidFill>
-                        <a:schemeClr val="bg1"/>
-                      </a:solidFill>
-                      <a:prstDash val="solid"/>
-                      <a:round/>
-                      <a:headEnd type="none" w="med" len="med"/>
-                      <a:tailEnd type="none" w="med" len="med"/>
-                    </a:lnB>
-                    <a:noFill/>
-                  </a:tcPr>
-                </a:tc>
-                <a:tc>
-                  <a:txBody>
-                    <a:bodyPr/>
-                    <a:lstStyle/>
-                    <a:p>
-                      <a:pPr>
-                        <a:buNone/>
-                      </a:pPr>
-                      <a:r>
-                        <a:rPr lang="cs-CZ">
-                          <a:effectLst/>
-                          <a:latin typeface="Google Sans Text"/>
-                        </a:rPr>
-                        <a:t>UInt16</a:t>
-                      </a:r>
-                    </a:p>
-                  </a:txBody>
-                  <a:tcPr anchor="ctr">
-                    <a:lnL w="9525" cap="flat" cmpd="sng" algn="ctr">
-                      <a:solidFill>
-                        <a:schemeClr val="bg1"/>
-                      </a:solidFill>
-                      <a:prstDash val="solid"/>
-                      <a:round/>
-                      <a:headEnd type="none" w="med" len="med"/>
-                      <a:tailEnd type="none" w="med" len="med"/>
-                    </a:lnL>
-                    <a:lnR w="9525" cap="flat" cmpd="sng" algn="ctr">
-                      <a:solidFill>
-                        <a:schemeClr val="bg1"/>
-                      </a:solidFill>
-                      <a:prstDash val="solid"/>
-                      <a:round/>
-                      <a:headEnd type="none" w="med" len="med"/>
-                      <a:tailEnd type="none" w="med" len="med"/>
-                    </a:lnR>
-                    <a:lnT w="9525" cap="flat" cmpd="sng" algn="ctr">
-                      <a:solidFill>
-                        <a:schemeClr val="bg1"/>
-                      </a:solidFill>
-                      <a:prstDash val="solid"/>
-                      <a:round/>
-                      <a:headEnd type="none" w="med" len="med"/>
-                      <a:tailEnd type="none" w="med" len="med"/>
-                    </a:lnT>
-                    <a:lnB w="9525" cap="flat" cmpd="sng" algn="ctr">
-                      <a:solidFill>
-                        <a:schemeClr val="bg1"/>
-                      </a:solidFill>
-                      <a:prstDash val="solid"/>
-                      <a:round/>
-                      <a:headEnd type="none" w="med" len="med"/>
-                      <a:tailEnd type="none" w="med" len="med"/>
-                    </a:lnB>
-                    <a:noFill/>
-                  </a:tcPr>
-                </a:tc>
-                <a:tc>
-                  <a:txBody>
-                    <a:bodyPr/>
-                    <a:lstStyle/>
-                    <a:p>
-                      <a:pPr>
-                        <a:buNone/>
-                      </a:pPr>
-                      <a:r>
-                        <a:rPr lang="cs-CZ">
-                          <a:effectLst/>
-                          <a:latin typeface="Google Sans Text"/>
-                        </a:rPr>
-                        <a:t>2 B</a:t>
-                      </a:r>
-                    </a:p>
-                  </a:txBody>
-                  <a:tcPr anchor="ctr">
-                    <a:lnL w="9525" cap="flat" cmpd="sng" algn="ctr">
-                      <a:solidFill>
-                        <a:schemeClr val="bg1"/>
-                      </a:solidFill>
-                      <a:prstDash val="solid"/>
-                      <a:round/>
-                      <a:headEnd type="none" w="med" len="med"/>
-                      <a:tailEnd type="none" w="med" len="med"/>
-                    </a:lnL>
-                    <a:lnR w="9525" cap="flat" cmpd="sng" algn="ctr">
-                      <a:solidFill>
-                        <a:schemeClr val="bg1"/>
-                      </a:solidFill>
-                      <a:prstDash val="solid"/>
-                      <a:round/>
-                      <a:headEnd type="none" w="med" len="med"/>
-                      <a:tailEnd type="none" w="med" len="med"/>
-                    </a:lnR>
-                    <a:lnT w="9525" cap="flat" cmpd="sng" algn="ctr">
-                      <a:solidFill>
-                        <a:schemeClr val="bg1"/>
-                      </a:solidFill>
-                      <a:prstDash val="solid"/>
-                      <a:round/>
-                      <a:headEnd type="none" w="med" len="med"/>
-                      <a:tailEnd type="none" w="med" len="med"/>
-                    </a:lnT>
-                    <a:lnB w="9525" cap="flat" cmpd="sng" algn="ctr">
-                      <a:solidFill>
-                        <a:schemeClr val="bg1"/>
-                      </a:solidFill>
-                      <a:prstDash val="solid"/>
-                      <a:round/>
-                      <a:headEnd type="none" w="med" len="med"/>
-                      <a:tailEnd type="none" w="med" len="med"/>
-                    </a:lnB>
-                    <a:noFill/>
-                  </a:tcPr>
-                </a:tc>
-                <a:tc>
-                  <a:txBody>
-                    <a:bodyPr/>
-                    <a:lstStyle/>
-                    <a:p>
-                      <a:pPr>
-                        <a:buNone/>
-                      </a:pPr>
-                      <a:r>
-                        <a:rPr lang="cs-CZ">
-                          <a:effectLst/>
-                          <a:latin typeface="Google Sans Text"/>
-                        </a:rPr>
-                        <a:t>0 až 65 535</a:t>
-                      </a:r>
-                    </a:p>
-                  </a:txBody>
-                  <a:tcPr anchor="ctr">
-                    <a:lnL w="9525" cap="flat" cmpd="sng" algn="ctr">
-                      <a:solidFill>
-                        <a:schemeClr val="bg1"/>
-                      </a:solidFill>
-                      <a:prstDash val="solid"/>
-                      <a:round/>
-                      <a:headEnd type="none" w="med" len="med"/>
-                      <a:tailEnd type="none" w="med" len="med"/>
-                    </a:lnL>
-                    <a:lnR w="9525" cap="flat" cmpd="sng" algn="ctr">
-                      <a:solidFill>
-                        <a:schemeClr val="bg1"/>
-                      </a:solidFill>
-                      <a:prstDash val="solid"/>
-                      <a:round/>
-                      <a:headEnd type="none" w="med" len="med"/>
-                      <a:tailEnd type="none" w="med" len="med"/>
-                    </a:lnR>
-                    <a:lnT w="9525" cap="flat" cmpd="sng" algn="ctr">
-                      <a:solidFill>
-                        <a:schemeClr val="bg1"/>
-                      </a:solidFill>
-                      <a:prstDash val="solid"/>
-                      <a:round/>
-                      <a:headEnd type="none" w="med" len="med"/>
-                      <a:tailEnd type="none" w="med" len="med"/>
-                    </a:lnT>
-                    <a:lnB w="9525" cap="flat" cmpd="sng" algn="ctr">
-                      <a:solidFill>
-                        <a:schemeClr val="bg1"/>
-                      </a:solidFill>
-                      <a:prstDash val="solid"/>
-                      <a:round/>
-                      <a:headEnd type="none" w="med" len="med"/>
-                      <a:tailEnd type="none" w="med" len="med"/>
-                    </a:lnB>
-                    <a:noFill/>
-                  </a:tcPr>
-                </a:tc>
-                <a:extLst>
-                  <a:ext uri="{0D108BD9-81ED-4DB2-BD59-A6C34878D82A}">
-                    <a16:rowId xmlns:a16="http://schemas.microsoft.com/office/drawing/2014/main" val="1685387875"/>
-                  </a:ext>
-                </a:extLst>
-              </a:tr>
-              <a:tr h="0">
-                <a:tc>
-                  <a:txBody>
-                    <a:bodyPr/>
-                    <a:lstStyle/>
-                    <a:p>
-                      <a:pPr>
-                        <a:buNone/>
-                      </a:pPr>
-                      <a:r>
-                        <a:rPr lang="cs-CZ" b="1">
-                          <a:effectLst/>
-                          <a:latin typeface="Google Sans Text"/>
-                        </a:rPr>
-                        <a:t>uint</a:t>
-                      </a:r>
-                      <a:endParaRPr lang="cs-CZ">
-                        <a:effectLst/>
-                        <a:latin typeface="Google Sans Text"/>
-                      </a:endParaRPr>
-                    </a:p>
-                  </a:txBody>
-                  <a:tcPr anchor="ctr">
-                    <a:lnL w="9525" cap="flat" cmpd="sng" algn="ctr">
-                      <a:solidFill>
-                        <a:schemeClr val="bg1"/>
-                      </a:solidFill>
-                      <a:prstDash val="solid"/>
-                      <a:round/>
-                      <a:headEnd type="none" w="med" len="med"/>
-                      <a:tailEnd type="none" w="med" len="med"/>
-                    </a:lnL>
-                    <a:lnR w="9525" cap="flat" cmpd="sng" algn="ctr">
-                      <a:solidFill>
-                        <a:schemeClr val="bg1"/>
-                      </a:solidFill>
-                      <a:prstDash val="solid"/>
-                      <a:round/>
-                      <a:headEnd type="none" w="med" len="med"/>
-                      <a:tailEnd type="none" w="med" len="med"/>
-                    </a:lnR>
-                    <a:lnT w="9525" cap="flat" cmpd="sng" algn="ctr">
-                      <a:solidFill>
-                        <a:schemeClr val="bg1"/>
-                      </a:solidFill>
-                      <a:prstDash val="solid"/>
-                      <a:round/>
-                      <a:headEnd type="none" w="med" len="med"/>
-                      <a:tailEnd type="none" w="med" len="med"/>
-                    </a:lnT>
-                    <a:lnB w="9525" cap="flat" cmpd="sng" algn="ctr">
-                      <a:solidFill>
-                        <a:schemeClr val="bg1"/>
-                      </a:solidFill>
-                      <a:prstDash val="solid"/>
-                      <a:round/>
-                      <a:headEnd type="none" w="med" len="med"/>
-                      <a:tailEnd type="none" w="med" len="med"/>
-                    </a:lnB>
-                    <a:noFill/>
-                  </a:tcPr>
-                </a:tc>
-                <a:tc>
-                  <a:txBody>
-                    <a:bodyPr/>
-                    <a:lstStyle/>
-                    <a:p>
-                      <a:pPr>
-                        <a:buNone/>
-                      </a:pPr>
-                      <a:r>
-                        <a:rPr lang="cs-CZ">
-                          <a:effectLst/>
-                          <a:latin typeface="Google Sans Text"/>
-                        </a:rPr>
-                        <a:t>UInt32</a:t>
-                      </a:r>
-                    </a:p>
-                  </a:txBody>
-                  <a:tcPr anchor="ctr">
-                    <a:lnL w="9525" cap="flat" cmpd="sng" algn="ctr">
-                      <a:solidFill>
-                        <a:schemeClr val="bg1"/>
-                      </a:solidFill>
-                      <a:prstDash val="solid"/>
-                      <a:round/>
-                      <a:headEnd type="none" w="med" len="med"/>
-                      <a:tailEnd type="none" w="med" len="med"/>
-                    </a:lnL>
-                    <a:lnR w="9525" cap="flat" cmpd="sng" algn="ctr">
-                      <a:solidFill>
-                        <a:schemeClr val="bg1"/>
-                      </a:solidFill>
-                      <a:prstDash val="solid"/>
-                      <a:round/>
-                      <a:headEnd type="none" w="med" len="med"/>
-                      <a:tailEnd type="none" w="med" len="med"/>
-                    </a:lnR>
-                    <a:lnT w="9525" cap="flat" cmpd="sng" algn="ctr">
-                      <a:solidFill>
-                        <a:schemeClr val="bg1"/>
-                      </a:solidFill>
-                      <a:prstDash val="solid"/>
-                      <a:round/>
-                      <a:headEnd type="none" w="med" len="med"/>
-                      <a:tailEnd type="none" w="med" len="med"/>
-                    </a:lnT>
-                    <a:lnB w="9525" cap="flat" cmpd="sng" algn="ctr">
-                      <a:solidFill>
-                        <a:schemeClr val="bg1"/>
-                      </a:solidFill>
-                      <a:prstDash val="solid"/>
-                      <a:round/>
-                      <a:headEnd type="none" w="med" len="med"/>
-                      <a:tailEnd type="none" w="med" len="med"/>
-                    </a:lnB>
-                    <a:noFill/>
-                  </a:tcPr>
-                </a:tc>
-                <a:tc>
-                  <a:txBody>
-                    <a:bodyPr/>
-                    <a:lstStyle/>
-                    <a:p>
-                      <a:pPr>
-                        <a:buNone/>
-                      </a:pPr>
-                      <a:r>
-                        <a:rPr lang="cs-CZ">
-                          <a:effectLst/>
-                          <a:latin typeface="Google Sans Text"/>
-                        </a:rPr>
-                        <a:t>4 B</a:t>
-                      </a:r>
-                    </a:p>
-                  </a:txBody>
-                  <a:tcPr anchor="ctr">
-                    <a:lnL w="9525" cap="flat" cmpd="sng" algn="ctr">
-                      <a:solidFill>
-                        <a:schemeClr val="bg1"/>
-                      </a:solidFill>
-                      <a:prstDash val="solid"/>
-                      <a:round/>
-                      <a:headEnd type="none" w="med" len="med"/>
-                      <a:tailEnd type="none" w="med" len="med"/>
-                    </a:lnL>
-                    <a:lnR w="9525" cap="flat" cmpd="sng" algn="ctr">
-                      <a:solidFill>
-                        <a:schemeClr val="bg1"/>
-                      </a:solidFill>
-                      <a:prstDash val="solid"/>
-                      <a:round/>
-                      <a:headEnd type="none" w="med" len="med"/>
-                      <a:tailEnd type="none" w="med" len="med"/>
-                    </a:lnR>
-                    <a:lnT w="9525" cap="flat" cmpd="sng" algn="ctr">
-                      <a:solidFill>
-                        <a:schemeClr val="bg1"/>
-                      </a:solidFill>
-                      <a:prstDash val="solid"/>
-                      <a:round/>
-                      <a:headEnd type="none" w="med" len="med"/>
-                      <a:tailEnd type="none" w="med" len="med"/>
-                    </a:lnT>
-                    <a:lnB w="9525" cap="flat" cmpd="sng" algn="ctr">
-                      <a:solidFill>
-                        <a:schemeClr val="bg1"/>
-                      </a:solidFill>
-                      <a:prstDash val="solid"/>
-                      <a:round/>
-                      <a:headEnd type="none" w="med" len="med"/>
-                      <a:tailEnd type="none" w="med" len="med"/>
-                    </a:lnB>
-                    <a:noFill/>
-                  </a:tcPr>
-                </a:tc>
-                <a:tc>
-                  <a:txBody>
-                    <a:bodyPr/>
-                    <a:lstStyle/>
-                    <a:p>
-                      <a:pPr>
-                        <a:buNone/>
-                      </a:pPr>
-                      <a:r>
-                        <a:rPr lang="cs-CZ" dirty="0">
-                          <a:effectLst/>
-                          <a:highlight>
-                            <a:srgbClr val="FFFF00"/>
-                          </a:highlight>
-                          <a:latin typeface="Google Sans Text"/>
-                        </a:rPr>
-                        <a:t>0 až 4,2 mld. </a:t>
-                      </a:r>
-                      <a:endParaRPr lang="cs-CZ" dirty="0">
-                        <a:effectLst/>
-                        <a:latin typeface="Google Sans Text"/>
-                      </a:endParaRPr>
-                    </a:p>
-                  </a:txBody>
-                  <a:tcPr anchor="ctr">
-                    <a:lnL w="9525" cap="flat" cmpd="sng" algn="ctr">
-                      <a:solidFill>
-                        <a:schemeClr val="bg1"/>
-                      </a:solidFill>
-                      <a:prstDash val="solid"/>
-                      <a:round/>
-                      <a:headEnd type="none" w="med" len="med"/>
-                      <a:tailEnd type="none" w="med" len="med"/>
-                    </a:lnL>
-                    <a:lnR w="9525" cap="flat" cmpd="sng" algn="ctr">
-                      <a:solidFill>
-                        <a:schemeClr val="bg1"/>
-                      </a:solidFill>
-                      <a:prstDash val="solid"/>
-                      <a:round/>
-                      <a:headEnd type="none" w="med" len="med"/>
-                      <a:tailEnd type="none" w="med" len="med"/>
-                    </a:lnR>
-                    <a:lnT w="9525" cap="flat" cmpd="sng" algn="ctr">
-                      <a:solidFill>
-                        <a:schemeClr val="bg1"/>
-                      </a:solidFill>
-                      <a:prstDash val="solid"/>
-                      <a:round/>
-                      <a:headEnd type="none" w="med" len="med"/>
-                      <a:tailEnd type="none" w="med" len="med"/>
-                    </a:lnT>
-                    <a:lnB w="9525" cap="flat" cmpd="sng" algn="ctr">
-                      <a:solidFill>
-                        <a:schemeClr val="bg1"/>
-                      </a:solidFill>
-                      <a:prstDash val="solid"/>
-                      <a:round/>
-                      <a:headEnd type="none" w="med" len="med"/>
-                      <a:tailEnd type="none" w="med" len="med"/>
-                    </a:lnB>
-                    <a:noFill/>
-                  </a:tcPr>
-                </a:tc>
-                <a:extLst>
-                  <a:ext uri="{0D108BD9-81ED-4DB2-BD59-A6C34878D82A}">
-                    <a16:rowId xmlns:a16="http://schemas.microsoft.com/office/drawing/2014/main" val="985762972"/>
-                  </a:ext>
-                </a:extLst>
-              </a:tr>
-              <a:tr h="0">
-                <a:tc>
-                  <a:txBody>
-                    <a:bodyPr/>
-                    <a:lstStyle/>
-                    <a:p>
-                      <a:pPr>
-                        <a:buNone/>
-                      </a:pPr>
-                      <a:r>
-                        <a:rPr lang="cs-CZ" b="1">
-                          <a:effectLst/>
-                          <a:latin typeface="Google Sans Text"/>
-                        </a:rPr>
-                        <a:t>ulong</a:t>
-                      </a:r>
-                      <a:endParaRPr lang="cs-CZ">
-                        <a:effectLst/>
-                        <a:latin typeface="Google Sans Text"/>
-                      </a:endParaRPr>
-                    </a:p>
-                  </a:txBody>
-                  <a:tcPr anchor="ctr">
-                    <a:lnL w="9525" cap="flat" cmpd="sng" algn="ctr">
-                      <a:solidFill>
-                        <a:schemeClr val="bg1"/>
-                      </a:solidFill>
-                      <a:prstDash val="solid"/>
-                      <a:round/>
-                      <a:headEnd type="none" w="med" len="med"/>
-                      <a:tailEnd type="none" w="med" len="med"/>
-                    </a:lnL>
-                    <a:lnR w="9525" cap="flat" cmpd="sng" algn="ctr">
-                      <a:solidFill>
-                        <a:schemeClr val="bg1"/>
-                      </a:solidFill>
-                      <a:prstDash val="solid"/>
-                      <a:round/>
-                      <a:headEnd type="none" w="med" len="med"/>
-                      <a:tailEnd type="none" w="med" len="med"/>
-                    </a:lnR>
-                    <a:lnT w="9525" cap="flat" cmpd="sng" algn="ctr">
-                      <a:solidFill>
-                        <a:schemeClr val="bg1"/>
-                      </a:solidFill>
-                      <a:prstDash val="solid"/>
-                      <a:round/>
-                      <a:headEnd type="none" w="med" len="med"/>
-                      <a:tailEnd type="none" w="med" len="med"/>
-                    </a:lnT>
-                    <a:lnB w="9525" cap="flat" cmpd="sng" algn="ctr">
-                      <a:solidFill>
-                        <a:schemeClr val="bg1"/>
-                      </a:solidFill>
-                      <a:prstDash val="solid"/>
-                      <a:round/>
-                      <a:headEnd type="none" w="med" len="med"/>
-                      <a:tailEnd type="none" w="med" len="med"/>
-                    </a:lnB>
-                    <a:noFill/>
-                  </a:tcPr>
-                </a:tc>
-                <a:tc>
-                  <a:txBody>
-                    <a:bodyPr/>
-                    <a:lstStyle/>
-                    <a:p>
-                      <a:pPr>
-                        <a:buNone/>
-                      </a:pPr>
-                      <a:r>
-                        <a:rPr lang="cs-CZ">
-                          <a:effectLst/>
-                          <a:latin typeface="Google Sans Text"/>
-                        </a:rPr>
-                        <a:t>UInt64</a:t>
-                      </a:r>
-                    </a:p>
-                  </a:txBody>
-                  <a:tcPr anchor="ctr">
-                    <a:lnL w="9525" cap="flat" cmpd="sng" algn="ctr">
-                      <a:solidFill>
-                        <a:schemeClr val="bg1"/>
-                      </a:solidFill>
-                      <a:prstDash val="solid"/>
-                      <a:round/>
-                      <a:headEnd type="none" w="med" len="med"/>
-                      <a:tailEnd type="none" w="med" len="med"/>
-                    </a:lnL>
-                    <a:lnR w="9525" cap="flat" cmpd="sng" algn="ctr">
-                      <a:solidFill>
-                        <a:schemeClr val="bg1"/>
-                      </a:solidFill>
-                      <a:prstDash val="solid"/>
-                      <a:round/>
-                      <a:headEnd type="none" w="med" len="med"/>
-                      <a:tailEnd type="none" w="med" len="med"/>
-                    </a:lnR>
-                    <a:lnT w="9525" cap="flat" cmpd="sng" algn="ctr">
-                      <a:solidFill>
-                        <a:schemeClr val="bg1"/>
-                      </a:solidFill>
-                      <a:prstDash val="solid"/>
-                      <a:round/>
-                      <a:headEnd type="none" w="med" len="med"/>
-                      <a:tailEnd type="none" w="med" len="med"/>
-                    </a:lnT>
-                    <a:lnB w="9525" cap="flat" cmpd="sng" algn="ctr">
-                      <a:solidFill>
-                        <a:schemeClr val="bg1"/>
-                      </a:solidFill>
-                      <a:prstDash val="solid"/>
-                      <a:round/>
-                      <a:headEnd type="none" w="med" len="med"/>
-                      <a:tailEnd type="none" w="med" len="med"/>
-                    </a:lnB>
-                    <a:noFill/>
-                  </a:tcPr>
-                </a:tc>
-                <a:tc>
-                  <a:txBody>
-                    <a:bodyPr/>
-                    <a:lstStyle/>
-                    <a:p>
-                      <a:pPr>
-                        <a:buNone/>
-                      </a:pPr>
-                      <a:r>
-                        <a:rPr lang="cs-CZ">
-                          <a:effectLst/>
-                          <a:latin typeface="Google Sans Text"/>
-                        </a:rPr>
-                        <a:t>8 B</a:t>
-                      </a:r>
-                    </a:p>
-                  </a:txBody>
-                  <a:tcPr anchor="ctr">
-                    <a:lnL w="9525" cap="flat" cmpd="sng" algn="ctr">
-                      <a:solidFill>
-                        <a:schemeClr val="bg1"/>
-                      </a:solidFill>
-                      <a:prstDash val="solid"/>
-                      <a:round/>
-                      <a:headEnd type="none" w="med" len="med"/>
-                      <a:tailEnd type="none" w="med" len="med"/>
-                    </a:lnL>
-                    <a:lnR w="9525" cap="flat" cmpd="sng" algn="ctr">
-                      <a:solidFill>
-                        <a:schemeClr val="bg1"/>
-                      </a:solidFill>
-                      <a:prstDash val="solid"/>
-                      <a:round/>
-                      <a:headEnd type="none" w="med" len="med"/>
-                      <a:tailEnd type="none" w="med" len="med"/>
-                    </a:lnR>
-                    <a:lnT w="9525" cap="flat" cmpd="sng" algn="ctr">
-                      <a:solidFill>
-                        <a:schemeClr val="bg1"/>
-                      </a:solidFill>
-                      <a:prstDash val="solid"/>
-                      <a:round/>
-                      <a:headEnd type="none" w="med" len="med"/>
-                      <a:tailEnd type="none" w="med" len="med"/>
-                    </a:lnT>
-                    <a:lnB w="9525" cap="flat" cmpd="sng" algn="ctr">
-                      <a:solidFill>
-                        <a:schemeClr val="bg1"/>
-                      </a:solidFill>
-                      <a:prstDash val="solid"/>
-                      <a:round/>
-                      <a:headEnd type="none" w="med" len="med"/>
-                      <a:tailEnd type="none" w="med" len="med"/>
-                    </a:lnB>
-                    <a:noFill/>
-                  </a:tcPr>
-                </a:tc>
-                <a:tc>
-                  <a:txBody>
-                    <a:bodyPr/>
-                    <a:lstStyle/>
-                    <a:p>
-                      <a:pPr>
-                        <a:buNone/>
-                      </a:pPr>
-                      <a:r>
-                        <a:rPr lang="cs-CZ" dirty="0">
-                          <a:effectLst/>
-                          <a:latin typeface="Google Sans Text"/>
-                        </a:rPr>
-                        <a:t>0 až 18 triliónů</a:t>
-                      </a:r>
-                    </a:p>
-                  </a:txBody>
-                  <a:tcPr anchor="ctr">
-                    <a:lnL w="9525" cap="flat" cmpd="sng" algn="ctr">
-                      <a:solidFill>
-                        <a:schemeClr val="bg1"/>
-                      </a:solidFill>
-                      <a:prstDash val="solid"/>
-                      <a:round/>
-                      <a:headEnd type="none" w="med" len="med"/>
-                      <a:tailEnd type="none" w="med" len="med"/>
-                    </a:lnL>
-                    <a:lnR w="9525" cap="flat" cmpd="sng" algn="ctr">
-                      <a:solidFill>
-                        <a:schemeClr val="bg1"/>
-                      </a:solidFill>
-                      <a:prstDash val="solid"/>
-                      <a:round/>
-                      <a:headEnd type="none" w="med" len="med"/>
-                      <a:tailEnd type="none" w="med" len="med"/>
-                    </a:lnR>
-                    <a:lnT w="9525" cap="flat" cmpd="sng" algn="ctr">
-                      <a:solidFill>
-                        <a:schemeClr val="bg1"/>
-                      </a:solidFill>
-                      <a:prstDash val="solid"/>
-                      <a:round/>
-                      <a:headEnd type="none" w="med" len="med"/>
-                      <a:tailEnd type="none" w="med" len="med"/>
-                    </a:lnT>
-                    <a:lnB w="9525" cap="flat" cmpd="sng" algn="ctr">
-                      <a:solidFill>
-                        <a:schemeClr val="bg1"/>
-                      </a:solidFill>
-                      <a:prstDash val="solid"/>
-                      <a:round/>
-                      <a:headEnd type="none" w="med" len="med"/>
-                      <a:tailEnd type="none" w="med" len="med"/>
-                    </a:lnB>
-                    <a:noFill/>
-                  </a:tcPr>
-                </a:tc>
-                <a:extLst>
-                  <a:ext uri="{0D108BD9-81ED-4DB2-BD59-A6C34878D82A}">
-                    <a16:rowId xmlns:a16="http://schemas.microsoft.com/office/drawing/2014/main" val="1357341850"/>
-                  </a:ext>
-                </a:extLst>
-              </a:tr>
-            </a:tbl>
-          </a:graphicData>
-        </a:graphic>
-      </p:graphicFrame>
-    </p:spTree>
-    <p:extLst>
-      <p:ext uri="{BB962C8B-B14F-4D97-AF65-F5344CB8AC3E}">
-        <p14:creationId xmlns:p14="http://schemas.microsoft.com/office/powerpoint/2010/main" val="3060432029"/>
       </p:ext>
     </p:extLst>
   </p:cSld>

</xml_diff>

<commit_message>
Prezentace obohacena o zásobník a haldu
</commit_message>
<xml_diff>
--- a/03_MATURITA/01_Jednoduche_a_slozene_typy/StandardniDatoveTypy.pptx
+++ b/03_MATURITA/01_Jednoduche_a_slozene_typy/StandardniDatoveTypy.pptx
@@ -5,7 +5,7 @@
     <p:sldMasterId id="2147483648" r:id="rId1"/>
   </p:sldMasterIdLst>
   <p:notesMasterIdLst>
-    <p:notesMasterId r:id="rId26"/>
+    <p:notesMasterId r:id="rId27"/>
   </p:notesMasterIdLst>
   <p:sldIdLst>
     <p:sldId id="256" r:id="rId2"/>
@@ -14,24 +14,25 @@
     <p:sldId id="273" r:id="rId5"/>
     <p:sldId id="276" r:id="rId6"/>
     <p:sldId id="257" r:id="rId7"/>
-    <p:sldId id="258" r:id="rId8"/>
-    <p:sldId id="263" r:id="rId9"/>
-    <p:sldId id="259" r:id="rId10"/>
-    <p:sldId id="260" r:id="rId11"/>
-    <p:sldId id="261" r:id="rId12"/>
-    <p:sldId id="264" r:id="rId13"/>
-    <p:sldId id="265" r:id="rId14"/>
-    <p:sldId id="267" r:id="rId15"/>
-    <p:sldId id="266" r:id="rId16"/>
-    <p:sldId id="268" r:id="rId17"/>
-    <p:sldId id="269" r:id="rId18"/>
-    <p:sldId id="270" r:id="rId19"/>
-    <p:sldId id="272" r:id="rId20"/>
-    <p:sldId id="277" r:id="rId21"/>
-    <p:sldId id="271" r:id="rId22"/>
-    <p:sldId id="275" r:id="rId23"/>
-    <p:sldId id="278" r:id="rId24"/>
-    <p:sldId id="274" r:id="rId25"/>
+    <p:sldId id="280" r:id="rId8"/>
+    <p:sldId id="258" r:id="rId9"/>
+    <p:sldId id="263" r:id="rId10"/>
+    <p:sldId id="259" r:id="rId11"/>
+    <p:sldId id="260" r:id="rId12"/>
+    <p:sldId id="261" r:id="rId13"/>
+    <p:sldId id="264" r:id="rId14"/>
+    <p:sldId id="265" r:id="rId15"/>
+    <p:sldId id="267" r:id="rId16"/>
+    <p:sldId id="266" r:id="rId17"/>
+    <p:sldId id="268" r:id="rId18"/>
+    <p:sldId id="269" r:id="rId19"/>
+    <p:sldId id="270" r:id="rId20"/>
+    <p:sldId id="272" r:id="rId21"/>
+    <p:sldId id="277" r:id="rId22"/>
+    <p:sldId id="271" r:id="rId23"/>
+    <p:sldId id="275" r:id="rId24"/>
+    <p:sldId id="278" r:id="rId25"/>
+    <p:sldId id="274" r:id="rId26"/>
   </p:sldIdLst>
   <p:sldSz cx="12192000" cy="6858000"/>
   <p:notesSz cx="6858000" cy="9144000"/>
@@ -636,7 +637,7 @@
           <a:p>
             <a:fld id="{4514EFDE-C67E-4B46-B5A2-5FE0F82A80D0}" type="slidenum">
               <a:rPr lang="cs-CZ" smtClean="0"/>
-              <a:t>12</a:t>
+              <a:t>13</a:t>
             </a:fld>
             <a:endParaRPr lang="cs-CZ"/>
           </a:p>
@@ -720,7 +721,7 @@
           <a:p>
             <a:fld id="{4514EFDE-C67E-4B46-B5A2-5FE0F82A80D0}" type="slidenum">
               <a:rPr lang="cs-CZ" smtClean="0"/>
-              <a:t>13</a:t>
+              <a:t>14</a:t>
             </a:fld>
             <a:endParaRPr lang="cs-CZ"/>
           </a:p>
@@ -4023,6 +4024,1405 @@
           <p:cNvPr id="2" name="Nadpis 1">
             <a:extLst>
               <a:ext uri="{FF2B5EF4-FFF2-40B4-BE49-F238E27FC236}">
+                <a16:creationId xmlns:a16="http://schemas.microsoft.com/office/drawing/2014/main" id="{2F34CF01-C529-6756-F7BA-5430555FB20D}"/>
+              </a:ext>
+            </a:extLst>
+          </p:cNvPr>
+          <p:cNvSpPr>
+            <a:spLocks noGrp="1"/>
+          </p:cNvSpPr>
+          <p:nvPr>
+            <p:ph type="title"/>
+          </p:nvPr>
+        </p:nvSpPr>
+        <p:spPr/>
+        <p:txBody>
+          <a:bodyPr/>
+          <a:lstStyle/>
+          <a:p>
+            <a:r>
+              <a:rPr lang="cs-CZ" dirty="0"/>
+              <a:t>Základní datové typy</a:t>
+            </a:r>
+          </a:p>
+        </p:txBody>
+      </p:sp>
+      <p:sp>
+        <p:nvSpPr>
+          <p:cNvPr id="3" name="Zástupný obsah 2">
+            <a:extLst>
+              <a:ext uri="{FF2B5EF4-FFF2-40B4-BE49-F238E27FC236}">
+                <a16:creationId xmlns:a16="http://schemas.microsoft.com/office/drawing/2014/main" id="{1EC3BA78-5767-BC77-13AC-A90FA58CE7EA}"/>
+              </a:ext>
+            </a:extLst>
+          </p:cNvPr>
+          <p:cNvSpPr>
+            <a:spLocks noGrp="1"/>
+          </p:cNvSpPr>
+          <p:nvPr>
+            <p:ph idx="1"/>
+          </p:nvPr>
+        </p:nvSpPr>
+        <p:spPr>
+          <a:xfrm>
+            <a:off x="838200" y="1825625"/>
+            <a:ext cx="10515600" cy="501116"/>
+          </a:xfrm>
+        </p:spPr>
+        <p:txBody>
+          <a:bodyPr/>
+          <a:lstStyle/>
+          <a:p>
+            <a:r>
+              <a:rPr lang="cs-CZ" dirty="0"/>
+              <a:t>Celočíselné znaménkové (</a:t>
+            </a:r>
+            <a:r>
+              <a:rPr lang="cs-CZ" dirty="0" err="1"/>
+              <a:t>signed</a:t>
+            </a:r>
+            <a:r>
+              <a:rPr lang="cs-CZ" dirty="0"/>
+              <a:t>) typy</a:t>
+            </a:r>
+          </a:p>
+        </p:txBody>
+      </p:sp>
+      <p:graphicFrame>
+        <p:nvGraphicFramePr>
+          <p:cNvPr id="4" name="Tabulka 3">
+            <a:extLst>
+              <a:ext uri="{FF2B5EF4-FFF2-40B4-BE49-F238E27FC236}">
+                <a16:creationId xmlns:a16="http://schemas.microsoft.com/office/drawing/2014/main" id="{33AF6546-55ED-5892-E75F-D46259D01255}"/>
+              </a:ext>
+            </a:extLst>
+          </p:cNvPr>
+          <p:cNvGraphicFramePr>
+            <a:graphicFrameLocks noGrp="1"/>
+          </p:cNvGraphicFramePr>
+          <p:nvPr>
+            <p:extLst>
+              <p:ext uri="{D42A27DB-BD31-4B8C-83A1-F6EECF244321}">
+                <p14:modId xmlns:p14="http://schemas.microsoft.com/office/powerpoint/2010/main" val="2476371086"/>
+              </p:ext>
+            </p:extLst>
+          </p:nvPr>
+        </p:nvGraphicFramePr>
+        <p:xfrm>
+          <a:off x="838200" y="3086894"/>
+          <a:ext cx="10515600" cy="1828800"/>
+        </p:xfrm>
+        <a:graphic>
+          <a:graphicData uri="http://schemas.openxmlformats.org/drawingml/2006/table">
+            <a:tbl>
+              <a:tblPr/>
+              <a:tblGrid>
+                <a:gridCol w="2628900">
+                  <a:extLst>
+                    <a:ext uri="{9D8B030D-6E8A-4147-A177-3AD203B41FA5}">
+                      <a16:colId xmlns:a16="http://schemas.microsoft.com/office/drawing/2014/main" val="3592932743"/>
+                    </a:ext>
+                  </a:extLst>
+                </a:gridCol>
+                <a:gridCol w="2628900">
+                  <a:extLst>
+                    <a:ext uri="{9D8B030D-6E8A-4147-A177-3AD203B41FA5}">
+                      <a16:colId xmlns:a16="http://schemas.microsoft.com/office/drawing/2014/main" val="3704334404"/>
+                    </a:ext>
+                  </a:extLst>
+                </a:gridCol>
+                <a:gridCol w="2628900">
+                  <a:extLst>
+                    <a:ext uri="{9D8B030D-6E8A-4147-A177-3AD203B41FA5}">
+                      <a16:colId xmlns:a16="http://schemas.microsoft.com/office/drawing/2014/main" val="1214681106"/>
+                    </a:ext>
+                  </a:extLst>
+                </a:gridCol>
+                <a:gridCol w="2628900">
+                  <a:extLst>
+                    <a:ext uri="{9D8B030D-6E8A-4147-A177-3AD203B41FA5}">
+                      <a16:colId xmlns:a16="http://schemas.microsoft.com/office/drawing/2014/main" val="4186449202"/>
+                    </a:ext>
+                  </a:extLst>
+                </a:gridCol>
+              </a:tblGrid>
+              <a:tr h="0">
+                <a:tc>
+                  <a:txBody>
+                    <a:bodyPr/>
+                    <a:lstStyle/>
+                    <a:p>
+                      <a:pPr>
+                        <a:buNone/>
+                      </a:pPr>
+                      <a:r>
+                        <a:rPr lang="cs-CZ" b="1">
+                          <a:effectLst/>
+                          <a:latin typeface="Google Sans Text"/>
+                        </a:rPr>
+                        <a:t>C# Typ</a:t>
+                      </a:r>
+                      <a:endParaRPr lang="cs-CZ">
+                        <a:effectLst/>
+                        <a:latin typeface="Google Sans Text"/>
+                      </a:endParaRPr>
+                    </a:p>
+                  </a:txBody>
+                  <a:tcPr anchor="ctr">
+                    <a:lnL w="9525" cap="flat" cmpd="sng" algn="ctr">
+                      <a:solidFill>
+                        <a:schemeClr val="bg1"/>
+                      </a:solidFill>
+                      <a:prstDash val="solid"/>
+                      <a:round/>
+                      <a:headEnd type="none" w="med" len="med"/>
+                      <a:tailEnd type="none" w="med" len="med"/>
+                    </a:lnL>
+                    <a:lnR w="9525" cap="flat" cmpd="sng" algn="ctr">
+                      <a:solidFill>
+                        <a:schemeClr val="bg1"/>
+                      </a:solidFill>
+                      <a:prstDash val="solid"/>
+                      <a:round/>
+                      <a:headEnd type="none" w="med" len="med"/>
+                      <a:tailEnd type="none" w="med" len="med"/>
+                    </a:lnR>
+                    <a:lnT w="9525" cap="flat" cmpd="sng" algn="ctr">
+                      <a:solidFill>
+                        <a:schemeClr val="bg1"/>
+                      </a:solidFill>
+                      <a:prstDash val="solid"/>
+                      <a:round/>
+                      <a:headEnd type="none" w="med" len="med"/>
+                      <a:tailEnd type="none" w="med" len="med"/>
+                    </a:lnT>
+                    <a:lnB w="9525" cap="flat" cmpd="sng" algn="ctr">
+                      <a:solidFill>
+                        <a:schemeClr val="bg1"/>
+                      </a:solidFill>
+                      <a:prstDash val="solid"/>
+                      <a:round/>
+                      <a:headEnd type="none" w="med" len="med"/>
+                      <a:tailEnd type="none" w="med" len="med"/>
+                    </a:lnB>
+                    <a:noFill/>
+                  </a:tcPr>
+                </a:tc>
+                <a:tc>
+                  <a:txBody>
+                    <a:bodyPr/>
+                    <a:lstStyle/>
+                    <a:p>
+                      <a:pPr>
+                        <a:buNone/>
+                      </a:pPr>
+                      <a:r>
+                        <a:rPr lang="cs-CZ" b="1">
+                          <a:effectLst/>
+                          <a:latin typeface="Google Sans Text"/>
+                        </a:rPr>
+                        <a:t>.NET Typ</a:t>
+                      </a:r>
+                      <a:endParaRPr lang="cs-CZ">
+                        <a:effectLst/>
+                        <a:latin typeface="Google Sans Text"/>
+                      </a:endParaRPr>
+                    </a:p>
+                  </a:txBody>
+                  <a:tcPr anchor="ctr">
+                    <a:lnL w="9525" cap="flat" cmpd="sng" algn="ctr">
+                      <a:solidFill>
+                        <a:schemeClr val="bg1"/>
+                      </a:solidFill>
+                      <a:prstDash val="solid"/>
+                      <a:round/>
+                      <a:headEnd type="none" w="med" len="med"/>
+                      <a:tailEnd type="none" w="med" len="med"/>
+                    </a:lnL>
+                    <a:lnR w="9525" cap="flat" cmpd="sng" algn="ctr">
+                      <a:solidFill>
+                        <a:schemeClr val="bg1"/>
+                      </a:solidFill>
+                      <a:prstDash val="solid"/>
+                      <a:round/>
+                      <a:headEnd type="none" w="med" len="med"/>
+                      <a:tailEnd type="none" w="med" len="med"/>
+                    </a:lnR>
+                    <a:lnT w="9525" cap="flat" cmpd="sng" algn="ctr">
+                      <a:solidFill>
+                        <a:schemeClr val="bg1"/>
+                      </a:solidFill>
+                      <a:prstDash val="solid"/>
+                      <a:round/>
+                      <a:headEnd type="none" w="med" len="med"/>
+                      <a:tailEnd type="none" w="med" len="med"/>
+                    </a:lnT>
+                    <a:lnB w="9525" cap="flat" cmpd="sng" algn="ctr">
+                      <a:solidFill>
+                        <a:schemeClr val="bg1"/>
+                      </a:solidFill>
+                      <a:prstDash val="solid"/>
+                      <a:round/>
+                      <a:headEnd type="none" w="med" len="med"/>
+                      <a:tailEnd type="none" w="med" len="med"/>
+                    </a:lnB>
+                    <a:noFill/>
+                  </a:tcPr>
+                </a:tc>
+                <a:tc>
+                  <a:txBody>
+                    <a:bodyPr/>
+                    <a:lstStyle/>
+                    <a:p>
+                      <a:pPr>
+                        <a:buNone/>
+                      </a:pPr>
+                      <a:r>
+                        <a:rPr lang="cs-CZ" b="1" dirty="0">
+                          <a:effectLst/>
+                          <a:latin typeface="Google Sans Text"/>
+                        </a:rPr>
+                        <a:t>Velikost (Byty)</a:t>
+                      </a:r>
+                      <a:endParaRPr lang="cs-CZ" dirty="0">
+                        <a:effectLst/>
+                        <a:latin typeface="Google Sans Text"/>
+                      </a:endParaRPr>
+                    </a:p>
+                  </a:txBody>
+                  <a:tcPr anchor="ctr">
+                    <a:lnL w="9525" cap="flat" cmpd="sng" algn="ctr">
+                      <a:solidFill>
+                        <a:schemeClr val="bg1"/>
+                      </a:solidFill>
+                      <a:prstDash val="solid"/>
+                      <a:round/>
+                      <a:headEnd type="none" w="med" len="med"/>
+                      <a:tailEnd type="none" w="med" len="med"/>
+                    </a:lnL>
+                    <a:lnR w="9525" cap="flat" cmpd="sng" algn="ctr">
+                      <a:solidFill>
+                        <a:schemeClr val="bg1"/>
+                      </a:solidFill>
+                      <a:prstDash val="solid"/>
+                      <a:round/>
+                      <a:headEnd type="none" w="med" len="med"/>
+                      <a:tailEnd type="none" w="med" len="med"/>
+                    </a:lnR>
+                    <a:lnT w="9525" cap="flat" cmpd="sng" algn="ctr">
+                      <a:solidFill>
+                        <a:schemeClr val="bg1"/>
+                      </a:solidFill>
+                      <a:prstDash val="solid"/>
+                      <a:round/>
+                      <a:headEnd type="none" w="med" len="med"/>
+                      <a:tailEnd type="none" w="med" len="med"/>
+                    </a:lnT>
+                    <a:lnB w="9525" cap="flat" cmpd="sng" algn="ctr">
+                      <a:solidFill>
+                        <a:schemeClr val="bg1"/>
+                      </a:solidFill>
+                      <a:prstDash val="solid"/>
+                      <a:round/>
+                      <a:headEnd type="none" w="med" len="med"/>
+                      <a:tailEnd type="none" w="med" len="med"/>
+                    </a:lnB>
+                    <a:noFill/>
+                  </a:tcPr>
+                </a:tc>
+                <a:tc>
+                  <a:txBody>
+                    <a:bodyPr/>
+                    <a:lstStyle/>
+                    <a:p>
+                      <a:pPr>
+                        <a:buNone/>
+                      </a:pPr>
+                      <a:r>
+                        <a:rPr lang="cs-CZ" b="1">
+                          <a:effectLst/>
+                          <a:latin typeface="Google Sans Text"/>
+                        </a:rPr>
+                        <a:t>Rozsah (přibližně)</a:t>
+                      </a:r>
+                      <a:endParaRPr lang="cs-CZ">
+                        <a:effectLst/>
+                        <a:latin typeface="Google Sans Text"/>
+                      </a:endParaRPr>
+                    </a:p>
+                  </a:txBody>
+                  <a:tcPr anchor="ctr">
+                    <a:lnL w="9525" cap="flat" cmpd="sng" algn="ctr">
+                      <a:solidFill>
+                        <a:schemeClr val="bg1"/>
+                      </a:solidFill>
+                      <a:prstDash val="solid"/>
+                      <a:round/>
+                      <a:headEnd type="none" w="med" len="med"/>
+                      <a:tailEnd type="none" w="med" len="med"/>
+                    </a:lnL>
+                    <a:lnR w="9525" cap="flat" cmpd="sng" algn="ctr">
+                      <a:solidFill>
+                        <a:schemeClr val="bg1"/>
+                      </a:solidFill>
+                      <a:prstDash val="solid"/>
+                      <a:round/>
+                      <a:headEnd type="none" w="med" len="med"/>
+                      <a:tailEnd type="none" w="med" len="med"/>
+                    </a:lnR>
+                    <a:lnT w="9525" cap="flat" cmpd="sng" algn="ctr">
+                      <a:solidFill>
+                        <a:schemeClr val="bg1"/>
+                      </a:solidFill>
+                      <a:prstDash val="solid"/>
+                      <a:round/>
+                      <a:headEnd type="none" w="med" len="med"/>
+                      <a:tailEnd type="none" w="med" len="med"/>
+                    </a:lnT>
+                    <a:lnB w="9525" cap="flat" cmpd="sng" algn="ctr">
+                      <a:solidFill>
+                        <a:schemeClr val="bg1"/>
+                      </a:solidFill>
+                      <a:prstDash val="solid"/>
+                      <a:round/>
+                      <a:headEnd type="none" w="med" len="med"/>
+                      <a:tailEnd type="none" w="med" len="med"/>
+                    </a:lnB>
+                    <a:noFill/>
+                  </a:tcPr>
+                </a:tc>
+                <a:extLst>
+                  <a:ext uri="{0D108BD9-81ED-4DB2-BD59-A6C34878D82A}">
+                    <a16:rowId xmlns:a16="http://schemas.microsoft.com/office/drawing/2014/main" val="217901554"/>
+                  </a:ext>
+                </a:extLst>
+              </a:tr>
+              <a:tr h="0">
+                <a:tc>
+                  <a:txBody>
+                    <a:bodyPr/>
+                    <a:lstStyle/>
+                    <a:p>
+                      <a:pPr>
+                        <a:buNone/>
+                      </a:pPr>
+                      <a:r>
+                        <a:rPr lang="cs-CZ" b="1">
+                          <a:effectLst/>
+                          <a:latin typeface="Google Sans Text"/>
+                        </a:rPr>
+                        <a:t>sbyte</a:t>
+                      </a:r>
+                      <a:endParaRPr lang="cs-CZ">
+                        <a:effectLst/>
+                        <a:latin typeface="Google Sans Text"/>
+                      </a:endParaRPr>
+                    </a:p>
+                  </a:txBody>
+                  <a:tcPr anchor="ctr">
+                    <a:lnL w="9525" cap="flat" cmpd="sng" algn="ctr">
+                      <a:solidFill>
+                        <a:schemeClr val="bg1"/>
+                      </a:solidFill>
+                      <a:prstDash val="solid"/>
+                      <a:round/>
+                      <a:headEnd type="none" w="med" len="med"/>
+                      <a:tailEnd type="none" w="med" len="med"/>
+                    </a:lnL>
+                    <a:lnR w="9525" cap="flat" cmpd="sng" algn="ctr">
+                      <a:solidFill>
+                        <a:schemeClr val="bg1"/>
+                      </a:solidFill>
+                      <a:prstDash val="solid"/>
+                      <a:round/>
+                      <a:headEnd type="none" w="med" len="med"/>
+                      <a:tailEnd type="none" w="med" len="med"/>
+                    </a:lnR>
+                    <a:lnT w="9525" cap="flat" cmpd="sng" algn="ctr">
+                      <a:solidFill>
+                        <a:schemeClr val="bg1"/>
+                      </a:solidFill>
+                      <a:prstDash val="solid"/>
+                      <a:round/>
+                      <a:headEnd type="none" w="med" len="med"/>
+                      <a:tailEnd type="none" w="med" len="med"/>
+                    </a:lnT>
+                    <a:lnB w="9525" cap="flat" cmpd="sng" algn="ctr">
+                      <a:solidFill>
+                        <a:schemeClr val="bg1"/>
+                      </a:solidFill>
+                      <a:prstDash val="solid"/>
+                      <a:round/>
+                      <a:headEnd type="none" w="med" len="med"/>
+                      <a:tailEnd type="none" w="med" len="med"/>
+                    </a:lnB>
+                    <a:solidFill>
+                      <a:schemeClr val="accent6">
+                        <a:lumMod val="20000"/>
+                        <a:lumOff val="80000"/>
+                      </a:schemeClr>
+                    </a:solidFill>
+                  </a:tcPr>
+                </a:tc>
+                <a:tc>
+                  <a:txBody>
+                    <a:bodyPr/>
+                    <a:lstStyle/>
+                    <a:p>
+                      <a:pPr>
+                        <a:buNone/>
+                      </a:pPr>
+                      <a:r>
+                        <a:rPr lang="cs-CZ">
+                          <a:effectLst/>
+                          <a:latin typeface="Google Sans Text"/>
+                        </a:rPr>
+                        <a:t>SByte</a:t>
+                      </a:r>
+                    </a:p>
+                  </a:txBody>
+                  <a:tcPr anchor="ctr">
+                    <a:lnL w="9525" cap="flat" cmpd="sng" algn="ctr">
+                      <a:solidFill>
+                        <a:schemeClr val="bg1"/>
+                      </a:solidFill>
+                      <a:prstDash val="solid"/>
+                      <a:round/>
+                      <a:headEnd type="none" w="med" len="med"/>
+                      <a:tailEnd type="none" w="med" len="med"/>
+                    </a:lnL>
+                    <a:lnR w="9525" cap="flat" cmpd="sng" algn="ctr">
+                      <a:solidFill>
+                        <a:schemeClr val="bg1"/>
+                      </a:solidFill>
+                      <a:prstDash val="solid"/>
+                      <a:round/>
+                      <a:headEnd type="none" w="med" len="med"/>
+                      <a:tailEnd type="none" w="med" len="med"/>
+                    </a:lnR>
+                    <a:lnT w="9525" cap="flat" cmpd="sng" algn="ctr">
+                      <a:solidFill>
+                        <a:schemeClr val="bg1"/>
+                      </a:solidFill>
+                      <a:prstDash val="solid"/>
+                      <a:round/>
+                      <a:headEnd type="none" w="med" len="med"/>
+                      <a:tailEnd type="none" w="med" len="med"/>
+                    </a:lnT>
+                    <a:lnB w="9525" cap="flat" cmpd="sng" algn="ctr">
+                      <a:solidFill>
+                        <a:schemeClr val="bg1"/>
+                      </a:solidFill>
+                      <a:prstDash val="solid"/>
+                      <a:round/>
+                      <a:headEnd type="none" w="med" len="med"/>
+                      <a:tailEnd type="none" w="med" len="med"/>
+                    </a:lnB>
+                    <a:solidFill>
+                      <a:schemeClr val="accent6">
+                        <a:lumMod val="20000"/>
+                        <a:lumOff val="80000"/>
+                      </a:schemeClr>
+                    </a:solidFill>
+                  </a:tcPr>
+                </a:tc>
+                <a:tc>
+                  <a:txBody>
+                    <a:bodyPr/>
+                    <a:lstStyle/>
+                    <a:p>
+                      <a:pPr>
+                        <a:buNone/>
+                      </a:pPr>
+                      <a:r>
+                        <a:rPr lang="cs-CZ">
+                          <a:effectLst/>
+                          <a:latin typeface="Google Sans Text"/>
+                        </a:rPr>
+                        <a:t>1 B</a:t>
+                      </a:r>
+                    </a:p>
+                  </a:txBody>
+                  <a:tcPr anchor="ctr">
+                    <a:lnL w="9525" cap="flat" cmpd="sng" algn="ctr">
+                      <a:solidFill>
+                        <a:schemeClr val="bg1"/>
+                      </a:solidFill>
+                      <a:prstDash val="solid"/>
+                      <a:round/>
+                      <a:headEnd type="none" w="med" len="med"/>
+                      <a:tailEnd type="none" w="med" len="med"/>
+                    </a:lnL>
+                    <a:lnR w="9525" cap="flat" cmpd="sng" algn="ctr">
+                      <a:solidFill>
+                        <a:schemeClr val="bg1"/>
+                      </a:solidFill>
+                      <a:prstDash val="solid"/>
+                      <a:round/>
+                      <a:headEnd type="none" w="med" len="med"/>
+                      <a:tailEnd type="none" w="med" len="med"/>
+                    </a:lnR>
+                    <a:lnT w="9525" cap="flat" cmpd="sng" algn="ctr">
+                      <a:solidFill>
+                        <a:schemeClr val="bg1"/>
+                      </a:solidFill>
+                      <a:prstDash val="solid"/>
+                      <a:round/>
+                      <a:headEnd type="none" w="med" len="med"/>
+                      <a:tailEnd type="none" w="med" len="med"/>
+                    </a:lnT>
+                    <a:lnB w="9525" cap="flat" cmpd="sng" algn="ctr">
+                      <a:solidFill>
+                        <a:schemeClr val="bg1"/>
+                      </a:solidFill>
+                      <a:prstDash val="solid"/>
+                      <a:round/>
+                      <a:headEnd type="none" w="med" len="med"/>
+                      <a:tailEnd type="none" w="med" len="med"/>
+                    </a:lnB>
+                    <a:solidFill>
+                      <a:schemeClr val="accent6">
+                        <a:lumMod val="20000"/>
+                        <a:lumOff val="80000"/>
+                      </a:schemeClr>
+                    </a:solidFill>
+                  </a:tcPr>
+                </a:tc>
+                <a:tc>
+                  <a:txBody>
+                    <a:bodyPr/>
+                    <a:lstStyle/>
+                    <a:p>
+                      <a:pPr>
+                        <a:buNone/>
+                      </a:pPr>
+                      <a:r>
+                        <a:rPr lang="cs-CZ" dirty="0">
+                          <a:effectLst/>
+                          <a:latin typeface="Google Sans Text"/>
+                        </a:rPr>
+                        <a:t>-128 až 127</a:t>
+                      </a:r>
+                    </a:p>
+                  </a:txBody>
+                  <a:tcPr anchor="ctr">
+                    <a:lnL w="9525" cap="flat" cmpd="sng" algn="ctr">
+                      <a:solidFill>
+                        <a:schemeClr val="bg1"/>
+                      </a:solidFill>
+                      <a:prstDash val="solid"/>
+                      <a:round/>
+                      <a:headEnd type="none" w="med" len="med"/>
+                      <a:tailEnd type="none" w="med" len="med"/>
+                    </a:lnL>
+                    <a:lnR w="9525" cap="flat" cmpd="sng" algn="ctr">
+                      <a:solidFill>
+                        <a:schemeClr val="bg1"/>
+                      </a:solidFill>
+                      <a:prstDash val="solid"/>
+                      <a:round/>
+                      <a:headEnd type="none" w="med" len="med"/>
+                      <a:tailEnd type="none" w="med" len="med"/>
+                    </a:lnR>
+                    <a:lnT w="9525" cap="flat" cmpd="sng" algn="ctr">
+                      <a:solidFill>
+                        <a:schemeClr val="bg1"/>
+                      </a:solidFill>
+                      <a:prstDash val="solid"/>
+                      <a:round/>
+                      <a:headEnd type="none" w="med" len="med"/>
+                      <a:tailEnd type="none" w="med" len="med"/>
+                    </a:lnT>
+                    <a:lnB w="9525" cap="flat" cmpd="sng" algn="ctr">
+                      <a:solidFill>
+                        <a:schemeClr val="bg1"/>
+                      </a:solidFill>
+                      <a:prstDash val="solid"/>
+                      <a:round/>
+                      <a:headEnd type="none" w="med" len="med"/>
+                      <a:tailEnd type="none" w="med" len="med"/>
+                    </a:lnB>
+                    <a:solidFill>
+                      <a:schemeClr val="accent6">
+                        <a:lumMod val="20000"/>
+                        <a:lumOff val="80000"/>
+                      </a:schemeClr>
+                    </a:solidFill>
+                  </a:tcPr>
+                </a:tc>
+                <a:extLst>
+                  <a:ext uri="{0D108BD9-81ED-4DB2-BD59-A6C34878D82A}">
+                    <a16:rowId xmlns:a16="http://schemas.microsoft.com/office/drawing/2014/main" val="2378009523"/>
+                  </a:ext>
+                </a:extLst>
+              </a:tr>
+              <a:tr h="0">
+                <a:tc>
+                  <a:txBody>
+                    <a:bodyPr/>
+                    <a:lstStyle/>
+                    <a:p>
+                      <a:pPr>
+                        <a:buNone/>
+                      </a:pPr>
+                      <a:r>
+                        <a:rPr lang="cs-CZ" b="1">
+                          <a:effectLst/>
+                          <a:latin typeface="Google Sans Text"/>
+                        </a:rPr>
+                        <a:t>short</a:t>
+                      </a:r>
+                      <a:endParaRPr lang="cs-CZ">
+                        <a:effectLst/>
+                        <a:latin typeface="Google Sans Text"/>
+                      </a:endParaRPr>
+                    </a:p>
+                  </a:txBody>
+                  <a:tcPr anchor="ctr">
+                    <a:lnL w="9525" cap="flat" cmpd="sng" algn="ctr">
+                      <a:solidFill>
+                        <a:schemeClr val="bg1"/>
+                      </a:solidFill>
+                      <a:prstDash val="solid"/>
+                      <a:round/>
+                      <a:headEnd type="none" w="med" len="med"/>
+                      <a:tailEnd type="none" w="med" len="med"/>
+                    </a:lnL>
+                    <a:lnR w="9525" cap="flat" cmpd="sng" algn="ctr">
+                      <a:solidFill>
+                        <a:schemeClr val="bg1"/>
+                      </a:solidFill>
+                      <a:prstDash val="solid"/>
+                      <a:round/>
+                      <a:headEnd type="none" w="med" len="med"/>
+                      <a:tailEnd type="none" w="med" len="med"/>
+                    </a:lnR>
+                    <a:lnT w="9525" cap="flat" cmpd="sng" algn="ctr">
+                      <a:solidFill>
+                        <a:schemeClr val="bg1"/>
+                      </a:solidFill>
+                      <a:prstDash val="solid"/>
+                      <a:round/>
+                      <a:headEnd type="none" w="med" len="med"/>
+                      <a:tailEnd type="none" w="med" len="med"/>
+                    </a:lnT>
+                    <a:lnB w="9525" cap="flat" cmpd="sng" algn="ctr">
+                      <a:solidFill>
+                        <a:schemeClr val="bg1"/>
+                      </a:solidFill>
+                      <a:prstDash val="solid"/>
+                      <a:round/>
+                      <a:headEnd type="none" w="med" len="med"/>
+                      <a:tailEnd type="none" w="med" len="med"/>
+                    </a:lnB>
+                    <a:noFill/>
+                  </a:tcPr>
+                </a:tc>
+                <a:tc>
+                  <a:txBody>
+                    <a:bodyPr/>
+                    <a:lstStyle/>
+                    <a:p>
+                      <a:pPr>
+                        <a:buNone/>
+                      </a:pPr>
+                      <a:r>
+                        <a:rPr lang="cs-CZ">
+                          <a:effectLst/>
+                          <a:latin typeface="Google Sans Text"/>
+                        </a:rPr>
+                        <a:t>Int16</a:t>
+                      </a:r>
+                    </a:p>
+                  </a:txBody>
+                  <a:tcPr anchor="ctr">
+                    <a:lnL w="9525" cap="flat" cmpd="sng" algn="ctr">
+                      <a:solidFill>
+                        <a:schemeClr val="bg1"/>
+                      </a:solidFill>
+                      <a:prstDash val="solid"/>
+                      <a:round/>
+                      <a:headEnd type="none" w="med" len="med"/>
+                      <a:tailEnd type="none" w="med" len="med"/>
+                    </a:lnL>
+                    <a:lnR w="9525" cap="flat" cmpd="sng" algn="ctr">
+                      <a:solidFill>
+                        <a:schemeClr val="bg1"/>
+                      </a:solidFill>
+                      <a:prstDash val="solid"/>
+                      <a:round/>
+                      <a:headEnd type="none" w="med" len="med"/>
+                      <a:tailEnd type="none" w="med" len="med"/>
+                    </a:lnR>
+                    <a:lnT w="9525" cap="flat" cmpd="sng" algn="ctr">
+                      <a:solidFill>
+                        <a:schemeClr val="bg1"/>
+                      </a:solidFill>
+                      <a:prstDash val="solid"/>
+                      <a:round/>
+                      <a:headEnd type="none" w="med" len="med"/>
+                      <a:tailEnd type="none" w="med" len="med"/>
+                    </a:lnT>
+                    <a:lnB w="9525" cap="flat" cmpd="sng" algn="ctr">
+                      <a:solidFill>
+                        <a:schemeClr val="bg1"/>
+                      </a:solidFill>
+                      <a:prstDash val="solid"/>
+                      <a:round/>
+                      <a:headEnd type="none" w="med" len="med"/>
+                      <a:tailEnd type="none" w="med" len="med"/>
+                    </a:lnB>
+                    <a:noFill/>
+                  </a:tcPr>
+                </a:tc>
+                <a:tc>
+                  <a:txBody>
+                    <a:bodyPr/>
+                    <a:lstStyle/>
+                    <a:p>
+                      <a:pPr>
+                        <a:buNone/>
+                      </a:pPr>
+                      <a:r>
+                        <a:rPr lang="cs-CZ" dirty="0">
+                          <a:effectLst/>
+                          <a:latin typeface="Google Sans Text"/>
+                        </a:rPr>
+                        <a:t>2 B</a:t>
+                      </a:r>
+                    </a:p>
+                  </a:txBody>
+                  <a:tcPr anchor="ctr">
+                    <a:lnL w="9525" cap="flat" cmpd="sng" algn="ctr">
+                      <a:solidFill>
+                        <a:schemeClr val="bg1"/>
+                      </a:solidFill>
+                      <a:prstDash val="solid"/>
+                      <a:round/>
+                      <a:headEnd type="none" w="med" len="med"/>
+                      <a:tailEnd type="none" w="med" len="med"/>
+                    </a:lnL>
+                    <a:lnR w="9525" cap="flat" cmpd="sng" algn="ctr">
+                      <a:solidFill>
+                        <a:schemeClr val="bg1"/>
+                      </a:solidFill>
+                      <a:prstDash val="solid"/>
+                      <a:round/>
+                      <a:headEnd type="none" w="med" len="med"/>
+                      <a:tailEnd type="none" w="med" len="med"/>
+                    </a:lnR>
+                    <a:lnT w="9525" cap="flat" cmpd="sng" algn="ctr">
+                      <a:solidFill>
+                        <a:schemeClr val="bg1"/>
+                      </a:solidFill>
+                      <a:prstDash val="solid"/>
+                      <a:round/>
+                      <a:headEnd type="none" w="med" len="med"/>
+                      <a:tailEnd type="none" w="med" len="med"/>
+                    </a:lnT>
+                    <a:lnB w="9525" cap="flat" cmpd="sng" algn="ctr">
+                      <a:solidFill>
+                        <a:schemeClr val="bg1"/>
+                      </a:solidFill>
+                      <a:prstDash val="solid"/>
+                      <a:round/>
+                      <a:headEnd type="none" w="med" len="med"/>
+                      <a:tailEnd type="none" w="med" len="med"/>
+                    </a:lnB>
+                    <a:noFill/>
+                  </a:tcPr>
+                </a:tc>
+                <a:tc>
+                  <a:txBody>
+                    <a:bodyPr/>
+                    <a:lstStyle/>
+                    <a:p>
+                      <a:pPr>
+                        <a:buNone/>
+                      </a:pPr>
+                      <a:r>
+                        <a:rPr lang="cs-CZ">
+                          <a:effectLst/>
+                          <a:latin typeface="Google Sans Text"/>
+                        </a:rPr>
+                        <a:t>-32 768 až 32 767</a:t>
+                      </a:r>
+                    </a:p>
+                  </a:txBody>
+                  <a:tcPr anchor="ctr">
+                    <a:lnL w="9525" cap="flat" cmpd="sng" algn="ctr">
+                      <a:solidFill>
+                        <a:schemeClr val="bg1"/>
+                      </a:solidFill>
+                      <a:prstDash val="solid"/>
+                      <a:round/>
+                      <a:headEnd type="none" w="med" len="med"/>
+                      <a:tailEnd type="none" w="med" len="med"/>
+                    </a:lnL>
+                    <a:lnR w="9525" cap="flat" cmpd="sng" algn="ctr">
+                      <a:solidFill>
+                        <a:schemeClr val="bg1"/>
+                      </a:solidFill>
+                      <a:prstDash val="solid"/>
+                      <a:round/>
+                      <a:headEnd type="none" w="med" len="med"/>
+                      <a:tailEnd type="none" w="med" len="med"/>
+                    </a:lnR>
+                    <a:lnT w="9525" cap="flat" cmpd="sng" algn="ctr">
+                      <a:solidFill>
+                        <a:schemeClr val="bg1"/>
+                      </a:solidFill>
+                      <a:prstDash val="solid"/>
+                      <a:round/>
+                      <a:headEnd type="none" w="med" len="med"/>
+                      <a:tailEnd type="none" w="med" len="med"/>
+                    </a:lnT>
+                    <a:lnB w="9525" cap="flat" cmpd="sng" algn="ctr">
+                      <a:solidFill>
+                        <a:schemeClr val="bg1"/>
+                      </a:solidFill>
+                      <a:prstDash val="solid"/>
+                      <a:round/>
+                      <a:headEnd type="none" w="med" len="med"/>
+                      <a:tailEnd type="none" w="med" len="med"/>
+                    </a:lnB>
+                    <a:noFill/>
+                  </a:tcPr>
+                </a:tc>
+                <a:extLst>
+                  <a:ext uri="{0D108BD9-81ED-4DB2-BD59-A6C34878D82A}">
+                    <a16:rowId xmlns:a16="http://schemas.microsoft.com/office/drawing/2014/main" val="3805416544"/>
+                  </a:ext>
+                </a:extLst>
+              </a:tr>
+              <a:tr h="0">
+                <a:tc>
+                  <a:txBody>
+                    <a:bodyPr/>
+                    <a:lstStyle/>
+                    <a:p>
+                      <a:pPr>
+                        <a:buNone/>
+                      </a:pPr>
+                      <a:r>
+                        <a:rPr lang="cs-CZ" b="1">
+                          <a:effectLst/>
+                          <a:latin typeface="Google Sans Text"/>
+                        </a:rPr>
+                        <a:t>int</a:t>
+                      </a:r>
+                      <a:endParaRPr lang="cs-CZ">
+                        <a:effectLst/>
+                        <a:latin typeface="Google Sans Text"/>
+                      </a:endParaRPr>
+                    </a:p>
+                  </a:txBody>
+                  <a:tcPr anchor="ctr">
+                    <a:lnL w="9525" cap="flat" cmpd="sng" algn="ctr">
+                      <a:solidFill>
+                        <a:schemeClr val="bg1"/>
+                      </a:solidFill>
+                      <a:prstDash val="solid"/>
+                      <a:round/>
+                      <a:headEnd type="none" w="med" len="med"/>
+                      <a:tailEnd type="none" w="med" len="med"/>
+                    </a:lnL>
+                    <a:lnR w="9525" cap="flat" cmpd="sng" algn="ctr">
+                      <a:solidFill>
+                        <a:schemeClr val="bg1"/>
+                      </a:solidFill>
+                      <a:prstDash val="solid"/>
+                      <a:round/>
+                      <a:headEnd type="none" w="med" len="med"/>
+                      <a:tailEnd type="none" w="med" len="med"/>
+                    </a:lnR>
+                    <a:lnT w="9525" cap="flat" cmpd="sng" algn="ctr">
+                      <a:solidFill>
+                        <a:schemeClr val="bg1"/>
+                      </a:solidFill>
+                      <a:prstDash val="solid"/>
+                      <a:round/>
+                      <a:headEnd type="none" w="med" len="med"/>
+                      <a:tailEnd type="none" w="med" len="med"/>
+                    </a:lnT>
+                    <a:lnB w="9525" cap="flat" cmpd="sng" algn="ctr">
+                      <a:solidFill>
+                        <a:schemeClr val="bg1"/>
+                      </a:solidFill>
+                      <a:prstDash val="solid"/>
+                      <a:round/>
+                      <a:headEnd type="none" w="med" len="med"/>
+                      <a:tailEnd type="none" w="med" len="med"/>
+                    </a:lnB>
+                    <a:noFill/>
+                  </a:tcPr>
+                </a:tc>
+                <a:tc>
+                  <a:txBody>
+                    <a:bodyPr/>
+                    <a:lstStyle/>
+                    <a:p>
+                      <a:pPr>
+                        <a:buNone/>
+                      </a:pPr>
+                      <a:r>
+                        <a:rPr lang="cs-CZ" dirty="0">
+                          <a:effectLst/>
+                          <a:highlight>
+                            <a:srgbClr val="FFFF00"/>
+                          </a:highlight>
+                          <a:latin typeface="Google Sans Text"/>
+                        </a:rPr>
+                        <a:t>Int32</a:t>
+                      </a:r>
+                    </a:p>
+                  </a:txBody>
+                  <a:tcPr anchor="ctr">
+                    <a:lnL w="9525" cap="flat" cmpd="sng" algn="ctr">
+                      <a:solidFill>
+                        <a:schemeClr val="bg1"/>
+                      </a:solidFill>
+                      <a:prstDash val="solid"/>
+                      <a:round/>
+                      <a:headEnd type="none" w="med" len="med"/>
+                      <a:tailEnd type="none" w="med" len="med"/>
+                    </a:lnL>
+                    <a:lnR w="9525" cap="flat" cmpd="sng" algn="ctr">
+                      <a:solidFill>
+                        <a:schemeClr val="bg1"/>
+                      </a:solidFill>
+                      <a:prstDash val="solid"/>
+                      <a:round/>
+                      <a:headEnd type="none" w="med" len="med"/>
+                      <a:tailEnd type="none" w="med" len="med"/>
+                    </a:lnR>
+                    <a:lnT w="9525" cap="flat" cmpd="sng" algn="ctr">
+                      <a:solidFill>
+                        <a:schemeClr val="bg1"/>
+                      </a:solidFill>
+                      <a:prstDash val="solid"/>
+                      <a:round/>
+                      <a:headEnd type="none" w="med" len="med"/>
+                      <a:tailEnd type="none" w="med" len="med"/>
+                    </a:lnT>
+                    <a:lnB w="9525" cap="flat" cmpd="sng" algn="ctr">
+                      <a:solidFill>
+                        <a:schemeClr val="bg1"/>
+                      </a:solidFill>
+                      <a:prstDash val="solid"/>
+                      <a:round/>
+                      <a:headEnd type="none" w="med" len="med"/>
+                      <a:tailEnd type="none" w="med" len="med"/>
+                    </a:lnB>
+                    <a:noFill/>
+                  </a:tcPr>
+                </a:tc>
+                <a:tc>
+                  <a:txBody>
+                    <a:bodyPr/>
+                    <a:lstStyle/>
+                    <a:p>
+                      <a:pPr>
+                        <a:buNone/>
+                      </a:pPr>
+                      <a:r>
+                        <a:rPr lang="cs-CZ" b="1">
+                          <a:effectLst/>
+                          <a:latin typeface="Google Sans Text"/>
+                        </a:rPr>
+                        <a:t>4 B</a:t>
+                      </a:r>
+                      <a:endParaRPr lang="cs-CZ">
+                        <a:effectLst/>
+                        <a:latin typeface="Google Sans Text"/>
+                      </a:endParaRPr>
+                    </a:p>
+                  </a:txBody>
+                  <a:tcPr anchor="ctr">
+                    <a:lnL w="9525" cap="flat" cmpd="sng" algn="ctr">
+                      <a:solidFill>
+                        <a:schemeClr val="bg1"/>
+                      </a:solidFill>
+                      <a:prstDash val="solid"/>
+                      <a:round/>
+                      <a:headEnd type="none" w="med" len="med"/>
+                      <a:tailEnd type="none" w="med" len="med"/>
+                    </a:lnL>
+                    <a:lnR w="9525" cap="flat" cmpd="sng" algn="ctr">
+                      <a:solidFill>
+                        <a:schemeClr val="bg1"/>
+                      </a:solidFill>
+                      <a:prstDash val="solid"/>
+                      <a:round/>
+                      <a:headEnd type="none" w="med" len="med"/>
+                      <a:tailEnd type="none" w="med" len="med"/>
+                    </a:lnR>
+                    <a:lnT w="9525" cap="flat" cmpd="sng" algn="ctr">
+                      <a:solidFill>
+                        <a:schemeClr val="bg1"/>
+                      </a:solidFill>
+                      <a:prstDash val="solid"/>
+                      <a:round/>
+                      <a:headEnd type="none" w="med" len="med"/>
+                      <a:tailEnd type="none" w="med" len="med"/>
+                    </a:lnT>
+                    <a:lnB w="9525" cap="flat" cmpd="sng" algn="ctr">
+                      <a:solidFill>
+                        <a:schemeClr val="bg1"/>
+                      </a:solidFill>
+                      <a:prstDash val="solid"/>
+                      <a:round/>
+                      <a:headEnd type="none" w="med" len="med"/>
+                      <a:tailEnd type="none" w="med" len="med"/>
+                    </a:lnB>
+                    <a:noFill/>
+                  </a:tcPr>
+                </a:tc>
+                <a:tc>
+                  <a:txBody>
+                    <a:bodyPr/>
+                    <a:lstStyle/>
+                    <a:p>
+                      <a:pPr>
+                        <a:buNone/>
+                      </a:pPr>
+                      <a:r>
+                        <a:rPr lang="cs-CZ" b="1">
+                          <a:effectLst/>
+                          <a:latin typeface="Google Sans Text"/>
+                        </a:rPr>
+                        <a:t>-2,1 mld. až 2,1 mld.</a:t>
+                      </a:r>
+                      <a:endParaRPr lang="cs-CZ">
+                        <a:effectLst/>
+                        <a:latin typeface="Google Sans Text"/>
+                      </a:endParaRPr>
+                    </a:p>
+                  </a:txBody>
+                  <a:tcPr anchor="ctr">
+                    <a:lnL w="9525" cap="flat" cmpd="sng" algn="ctr">
+                      <a:solidFill>
+                        <a:schemeClr val="bg1"/>
+                      </a:solidFill>
+                      <a:prstDash val="solid"/>
+                      <a:round/>
+                      <a:headEnd type="none" w="med" len="med"/>
+                      <a:tailEnd type="none" w="med" len="med"/>
+                    </a:lnL>
+                    <a:lnR w="9525" cap="flat" cmpd="sng" algn="ctr">
+                      <a:solidFill>
+                        <a:schemeClr val="bg1"/>
+                      </a:solidFill>
+                      <a:prstDash val="solid"/>
+                      <a:round/>
+                      <a:headEnd type="none" w="med" len="med"/>
+                      <a:tailEnd type="none" w="med" len="med"/>
+                    </a:lnR>
+                    <a:lnT w="9525" cap="flat" cmpd="sng" algn="ctr">
+                      <a:solidFill>
+                        <a:schemeClr val="bg1"/>
+                      </a:solidFill>
+                      <a:prstDash val="solid"/>
+                      <a:round/>
+                      <a:headEnd type="none" w="med" len="med"/>
+                      <a:tailEnd type="none" w="med" len="med"/>
+                    </a:lnT>
+                    <a:lnB w="9525" cap="flat" cmpd="sng" algn="ctr">
+                      <a:solidFill>
+                        <a:schemeClr val="bg1"/>
+                      </a:solidFill>
+                      <a:prstDash val="solid"/>
+                      <a:round/>
+                      <a:headEnd type="none" w="med" len="med"/>
+                      <a:tailEnd type="none" w="med" len="med"/>
+                    </a:lnB>
+                    <a:noFill/>
+                  </a:tcPr>
+                </a:tc>
+                <a:extLst>
+                  <a:ext uri="{0D108BD9-81ED-4DB2-BD59-A6C34878D82A}">
+                    <a16:rowId xmlns:a16="http://schemas.microsoft.com/office/drawing/2014/main" val="415679796"/>
+                  </a:ext>
+                </a:extLst>
+              </a:tr>
+              <a:tr h="0">
+                <a:tc>
+                  <a:txBody>
+                    <a:bodyPr/>
+                    <a:lstStyle/>
+                    <a:p>
+                      <a:pPr>
+                        <a:buNone/>
+                      </a:pPr>
+                      <a:r>
+                        <a:rPr lang="cs-CZ" b="1">
+                          <a:effectLst/>
+                          <a:latin typeface="Google Sans Text"/>
+                        </a:rPr>
+                        <a:t>long</a:t>
+                      </a:r>
+                      <a:endParaRPr lang="cs-CZ">
+                        <a:effectLst/>
+                        <a:latin typeface="Google Sans Text"/>
+                      </a:endParaRPr>
+                    </a:p>
+                  </a:txBody>
+                  <a:tcPr anchor="ctr">
+                    <a:lnL w="9525" cap="flat" cmpd="sng" algn="ctr">
+                      <a:solidFill>
+                        <a:schemeClr val="bg1"/>
+                      </a:solidFill>
+                      <a:prstDash val="solid"/>
+                      <a:round/>
+                      <a:headEnd type="none" w="med" len="med"/>
+                      <a:tailEnd type="none" w="med" len="med"/>
+                    </a:lnL>
+                    <a:lnR w="9525" cap="flat" cmpd="sng" algn="ctr">
+                      <a:solidFill>
+                        <a:schemeClr val="bg1"/>
+                      </a:solidFill>
+                      <a:prstDash val="solid"/>
+                      <a:round/>
+                      <a:headEnd type="none" w="med" len="med"/>
+                      <a:tailEnd type="none" w="med" len="med"/>
+                    </a:lnR>
+                    <a:lnT w="9525" cap="flat" cmpd="sng" algn="ctr">
+                      <a:solidFill>
+                        <a:schemeClr val="bg1"/>
+                      </a:solidFill>
+                      <a:prstDash val="solid"/>
+                      <a:round/>
+                      <a:headEnd type="none" w="med" len="med"/>
+                      <a:tailEnd type="none" w="med" len="med"/>
+                    </a:lnT>
+                    <a:lnB w="9525" cap="flat" cmpd="sng" algn="ctr">
+                      <a:solidFill>
+                        <a:schemeClr val="bg1"/>
+                      </a:solidFill>
+                      <a:prstDash val="solid"/>
+                      <a:round/>
+                      <a:headEnd type="none" w="med" len="med"/>
+                      <a:tailEnd type="none" w="med" len="med"/>
+                    </a:lnB>
+                    <a:noFill/>
+                  </a:tcPr>
+                </a:tc>
+                <a:tc>
+                  <a:txBody>
+                    <a:bodyPr/>
+                    <a:lstStyle/>
+                    <a:p>
+                      <a:pPr>
+                        <a:buNone/>
+                      </a:pPr>
+                      <a:r>
+                        <a:rPr lang="cs-CZ">
+                          <a:effectLst/>
+                          <a:latin typeface="Google Sans Text"/>
+                        </a:rPr>
+                        <a:t>Int64</a:t>
+                      </a:r>
+                    </a:p>
+                  </a:txBody>
+                  <a:tcPr anchor="ctr">
+                    <a:lnL w="9525" cap="flat" cmpd="sng" algn="ctr">
+                      <a:solidFill>
+                        <a:schemeClr val="bg1"/>
+                      </a:solidFill>
+                      <a:prstDash val="solid"/>
+                      <a:round/>
+                      <a:headEnd type="none" w="med" len="med"/>
+                      <a:tailEnd type="none" w="med" len="med"/>
+                    </a:lnL>
+                    <a:lnR w="9525" cap="flat" cmpd="sng" algn="ctr">
+                      <a:solidFill>
+                        <a:schemeClr val="bg1"/>
+                      </a:solidFill>
+                      <a:prstDash val="solid"/>
+                      <a:round/>
+                      <a:headEnd type="none" w="med" len="med"/>
+                      <a:tailEnd type="none" w="med" len="med"/>
+                    </a:lnR>
+                    <a:lnT w="9525" cap="flat" cmpd="sng" algn="ctr">
+                      <a:solidFill>
+                        <a:schemeClr val="bg1"/>
+                      </a:solidFill>
+                      <a:prstDash val="solid"/>
+                      <a:round/>
+                      <a:headEnd type="none" w="med" len="med"/>
+                      <a:tailEnd type="none" w="med" len="med"/>
+                    </a:lnT>
+                    <a:lnB w="9525" cap="flat" cmpd="sng" algn="ctr">
+                      <a:solidFill>
+                        <a:schemeClr val="bg1"/>
+                      </a:solidFill>
+                      <a:prstDash val="solid"/>
+                      <a:round/>
+                      <a:headEnd type="none" w="med" len="med"/>
+                      <a:tailEnd type="none" w="med" len="med"/>
+                    </a:lnB>
+                    <a:noFill/>
+                  </a:tcPr>
+                </a:tc>
+                <a:tc>
+                  <a:txBody>
+                    <a:bodyPr/>
+                    <a:lstStyle/>
+                    <a:p>
+                      <a:pPr>
+                        <a:buNone/>
+                      </a:pPr>
+                      <a:r>
+                        <a:rPr lang="cs-CZ">
+                          <a:effectLst/>
+                          <a:latin typeface="Google Sans Text"/>
+                        </a:rPr>
+                        <a:t>8 B</a:t>
+                      </a:r>
+                    </a:p>
+                  </a:txBody>
+                  <a:tcPr anchor="ctr">
+                    <a:lnL w="9525" cap="flat" cmpd="sng" algn="ctr">
+                      <a:solidFill>
+                        <a:schemeClr val="bg1"/>
+                      </a:solidFill>
+                      <a:prstDash val="solid"/>
+                      <a:round/>
+                      <a:headEnd type="none" w="med" len="med"/>
+                      <a:tailEnd type="none" w="med" len="med"/>
+                    </a:lnL>
+                    <a:lnR w="9525" cap="flat" cmpd="sng" algn="ctr">
+                      <a:solidFill>
+                        <a:schemeClr val="bg1"/>
+                      </a:solidFill>
+                      <a:prstDash val="solid"/>
+                      <a:round/>
+                      <a:headEnd type="none" w="med" len="med"/>
+                      <a:tailEnd type="none" w="med" len="med"/>
+                    </a:lnR>
+                    <a:lnT w="9525" cap="flat" cmpd="sng" algn="ctr">
+                      <a:solidFill>
+                        <a:schemeClr val="bg1"/>
+                      </a:solidFill>
+                      <a:prstDash val="solid"/>
+                      <a:round/>
+                      <a:headEnd type="none" w="med" len="med"/>
+                      <a:tailEnd type="none" w="med" len="med"/>
+                    </a:lnT>
+                    <a:lnB w="9525" cap="flat" cmpd="sng" algn="ctr">
+                      <a:solidFill>
+                        <a:schemeClr val="bg1"/>
+                      </a:solidFill>
+                      <a:prstDash val="solid"/>
+                      <a:round/>
+                      <a:headEnd type="none" w="med" len="med"/>
+                      <a:tailEnd type="none" w="med" len="med"/>
+                    </a:lnB>
+                    <a:noFill/>
+                  </a:tcPr>
+                </a:tc>
+                <a:tc>
+                  <a:txBody>
+                    <a:bodyPr/>
+                    <a:lstStyle/>
+                    <a:p>
+                      <a:pPr>
+                        <a:buNone/>
+                      </a:pPr>
+                      <a:r>
+                        <a:rPr lang="cs-CZ" dirty="0">
+                          <a:effectLst/>
+                          <a:latin typeface="Google Sans Text"/>
+                        </a:rPr>
+                        <a:t>-9 triliónů až 9 triliónů</a:t>
+                      </a:r>
+                    </a:p>
+                  </a:txBody>
+                  <a:tcPr anchor="ctr">
+                    <a:lnL w="9525" cap="flat" cmpd="sng" algn="ctr">
+                      <a:solidFill>
+                        <a:schemeClr val="bg1"/>
+                      </a:solidFill>
+                      <a:prstDash val="solid"/>
+                      <a:round/>
+                      <a:headEnd type="none" w="med" len="med"/>
+                      <a:tailEnd type="none" w="med" len="med"/>
+                    </a:lnL>
+                    <a:lnR w="9525" cap="flat" cmpd="sng" algn="ctr">
+                      <a:solidFill>
+                        <a:schemeClr val="bg1"/>
+                      </a:solidFill>
+                      <a:prstDash val="solid"/>
+                      <a:round/>
+                      <a:headEnd type="none" w="med" len="med"/>
+                      <a:tailEnd type="none" w="med" len="med"/>
+                    </a:lnR>
+                    <a:lnT w="9525" cap="flat" cmpd="sng" algn="ctr">
+                      <a:solidFill>
+                        <a:schemeClr val="bg1"/>
+                      </a:solidFill>
+                      <a:prstDash val="solid"/>
+                      <a:round/>
+                      <a:headEnd type="none" w="med" len="med"/>
+                      <a:tailEnd type="none" w="med" len="med"/>
+                    </a:lnT>
+                    <a:lnB w="9525" cap="flat" cmpd="sng" algn="ctr">
+                      <a:solidFill>
+                        <a:schemeClr val="bg1"/>
+                      </a:solidFill>
+                      <a:prstDash val="solid"/>
+                      <a:round/>
+                      <a:headEnd type="none" w="med" len="med"/>
+                      <a:tailEnd type="none" w="med" len="med"/>
+                    </a:lnB>
+                    <a:noFill/>
+                  </a:tcPr>
+                </a:tc>
+                <a:extLst>
+                  <a:ext uri="{0D108BD9-81ED-4DB2-BD59-A6C34878D82A}">
+                    <a16:rowId xmlns:a16="http://schemas.microsoft.com/office/drawing/2014/main" val="1725362625"/>
+                  </a:ext>
+                </a:extLst>
+              </a:tr>
+            </a:tbl>
+          </a:graphicData>
+        </a:graphic>
+      </p:graphicFrame>
+    </p:spTree>
+    <p:extLst>
+      <p:ext uri="{BB962C8B-B14F-4D97-AF65-F5344CB8AC3E}">
+        <p14:creationId xmlns:p14="http://schemas.microsoft.com/office/powerpoint/2010/main" val="606161950"/>
+      </p:ext>
+    </p:extLst>
+  </p:cSld>
+  <p:clrMapOvr>
+    <a:masterClrMapping/>
+  </p:clrMapOvr>
+</p:sld>
+</file>
+
+<file path=ppt/slides/slide11.xml><?xml version="1.0" encoding="utf-8"?>
+<p:sld xmlns:a="http://schemas.openxmlformats.org/drawingml/2006/main" xmlns:r="http://schemas.openxmlformats.org/officeDocument/2006/relationships" xmlns:p="http://schemas.openxmlformats.org/presentationml/2006/main">
+  <p:cSld>
+    <p:spTree>
+      <p:nvGrpSpPr>
+        <p:cNvPr id="1" name=""/>
+        <p:cNvGrpSpPr/>
+        <p:nvPr/>
+      </p:nvGrpSpPr>
+      <p:grpSpPr>
+        <a:xfrm>
+          <a:off x="0" y="0"/>
+          <a:ext cx="0" cy="0"/>
+          <a:chOff x="0" y="0"/>
+          <a:chExt cx="0" cy="0"/>
+        </a:xfrm>
+      </p:grpSpPr>
+      <p:sp>
+        <p:nvSpPr>
+          <p:cNvPr id="2" name="Nadpis 1">
+            <a:extLst>
+              <a:ext uri="{FF2B5EF4-FFF2-40B4-BE49-F238E27FC236}">
                 <a16:creationId xmlns:a16="http://schemas.microsoft.com/office/drawing/2014/main" id="{F7D93DF5-4BC0-2B15-3889-75B6505A408B}"/>
               </a:ext>
             </a:extLst>
@@ -5419,7 +6819,7 @@
 </p:sld>
 </file>
 
-<file path=ppt/slides/slide11.xml><?xml version="1.0" encoding="utf-8"?>
+<file path=ppt/slides/slide12.xml><?xml version="1.0" encoding="utf-8"?>
 <p:sld xmlns:a="http://schemas.openxmlformats.org/drawingml/2006/main" xmlns:r="http://schemas.openxmlformats.org/officeDocument/2006/relationships" xmlns:p="http://schemas.openxmlformats.org/presentationml/2006/main">
   <p:cSld>
     <p:spTree>
@@ -7038,7 +8438,7 @@
 </p:sld>
 </file>
 
-<file path=ppt/slides/slide12.xml><?xml version="1.0" encoding="utf-8"?>
+<file path=ppt/slides/slide13.xml><?xml version="1.0" encoding="utf-8"?>
 <p:sld xmlns:a="http://schemas.openxmlformats.org/drawingml/2006/main" xmlns:r="http://schemas.openxmlformats.org/officeDocument/2006/relationships" xmlns:p="http://schemas.openxmlformats.org/presentationml/2006/main">
   <p:cSld>
     <p:spTree>
@@ -7159,7 +8559,7 @@
 </p:sld>
 </file>
 
-<file path=ppt/slides/slide13.xml><?xml version="1.0" encoding="utf-8"?>
+<file path=ppt/slides/slide14.xml><?xml version="1.0" encoding="utf-8"?>
 <p:sld xmlns:a="http://schemas.openxmlformats.org/drawingml/2006/main" xmlns:r="http://schemas.openxmlformats.org/officeDocument/2006/relationships" xmlns:p="http://schemas.openxmlformats.org/presentationml/2006/main">
   <p:cSld>
     <p:spTree>
@@ -7493,7 +8893,7 @@
 </p:sld>
 </file>
 
-<file path=ppt/slides/slide14.xml><?xml version="1.0" encoding="utf-8"?>
+<file path=ppt/slides/slide15.xml><?xml version="1.0" encoding="utf-8"?>
 <p:sld xmlns:a="http://schemas.openxmlformats.org/drawingml/2006/main" xmlns:r="http://schemas.openxmlformats.org/officeDocument/2006/relationships" xmlns:p="http://schemas.openxmlformats.org/presentationml/2006/main">
   <p:cSld>
     <p:spTree>
@@ -7578,7 +8978,7 @@
 </p:sld>
 </file>
 
-<file path=ppt/slides/slide15.xml><?xml version="1.0" encoding="utf-8"?>
+<file path=ppt/slides/slide16.xml><?xml version="1.0" encoding="utf-8"?>
 <p:sld xmlns:a="http://schemas.openxmlformats.org/drawingml/2006/main" xmlns:r="http://schemas.openxmlformats.org/officeDocument/2006/relationships" xmlns:p="http://schemas.openxmlformats.org/presentationml/2006/main">
   <p:cSld>
     <p:spTree>
@@ -7856,7 +9256,7 @@
 </p:sld>
 </file>
 
-<file path=ppt/slides/slide16.xml><?xml version="1.0" encoding="utf-8"?>
+<file path=ppt/slides/slide17.xml><?xml version="1.0" encoding="utf-8"?>
 <p:sld xmlns:a="http://schemas.openxmlformats.org/drawingml/2006/main" xmlns:r="http://schemas.openxmlformats.org/officeDocument/2006/relationships" xmlns:p="http://schemas.openxmlformats.org/presentationml/2006/main">
   <p:cSld>
     <p:spTree>
@@ -7916,7 +9316,7 @@
 </p:sld>
 </file>
 
-<file path=ppt/slides/slide17.xml><?xml version="1.0" encoding="utf-8"?>
+<file path=ppt/slides/slide18.xml><?xml version="1.0" encoding="utf-8"?>
 <p:sld xmlns:a="http://schemas.openxmlformats.org/drawingml/2006/main" xmlns:r="http://schemas.openxmlformats.org/officeDocument/2006/relationships" xmlns:p="http://schemas.openxmlformats.org/presentationml/2006/main">
   <p:cSld>
     <p:spTree>
@@ -8211,7 +9611,7 @@
 </p:sld>
 </file>
 
-<file path=ppt/slides/slide18.xml><?xml version="1.0" encoding="utf-8"?>
+<file path=ppt/slides/slide19.xml><?xml version="1.0" encoding="utf-8"?>
 <p:sld xmlns:a="http://schemas.openxmlformats.org/drawingml/2006/main" xmlns:r="http://schemas.openxmlformats.org/officeDocument/2006/relationships" xmlns:p="http://schemas.openxmlformats.org/presentationml/2006/main">
   <p:cSld>
     <p:spTree>
@@ -8523,7 +9923,81 @@
 </p:sld>
 </file>
 
-<file path=ppt/slides/slide19.xml><?xml version="1.0" encoding="utf-8"?>
+<file path=ppt/slides/slide2.xml><?xml version="1.0" encoding="utf-8"?>
+<p:sld xmlns:a="http://schemas.openxmlformats.org/drawingml/2006/main" xmlns:r="http://schemas.openxmlformats.org/officeDocument/2006/relationships" xmlns:p="http://schemas.openxmlformats.org/presentationml/2006/main">
+  <p:cSld>
+    <p:spTree>
+      <p:nvGrpSpPr>
+        <p:cNvPr id="1" name=""/>
+        <p:cNvGrpSpPr/>
+        <p:nvPr/>
+      </p:nvGrpSpPr>
+      <p:grpSpPr>
+        <a:xfrm>
+          <a:off x="0" y="0"/>
+          <a:ext cx="0" cy="0"/>
+          <a:chOff x="0" y="0"/>
+          <a:chExt cx="0" cy="0"/>
+        </a:xfrm>
+      </p:grpSpPr>
+      <p:sp>
+        <p:nvSpPr>
+          <p:cNvPr id="3" name="Zástupný obsah 2">
+            <a:extLst>
+              <a:ext uri="{FF2B5EF4-FFF2-40B4-BE49-F238E27FC236}">
+                <a16:creationId xmlns:a16="http://schemas.microsoft.com/office/drawing/2014/main" id="{7B8E1416-38FB-7FA7-C2B9-F18029269975}"/>
+              </a:ext>
+            </a:extLst>
+          </p:cNvPr>
+          <p:cNvSpPr>
+            <a:spLocks noGrp="1"/>
+          </p:cNvSpPr>
+          <p:nvPr>
+            <p:ph idx="1"/>
+          </p:nvPr>
+        </p:nvSpPr>
+        <p:spPr>
+          <a:xfrm>
+            <a:off x="838200" y="3200400"/>
+            <a:ext cx="10515600" cy="457200"/>
+          </a:xfrm>
+          <a:solidFill>
+            <a:schemeClr val="accent6">
+              <a:lumMod val="20000"/>
+              <a:lumOff val="80000"/>
+            </a:schemeClr>
+          </a:solidFill>
+        </p:spPr>
+        <p:txBody>
+          <a:bodyPr>
+            <a:normAutofit lnSpcReduction="10000"/>
+          </a:bodyPr>
+          <a:lstStyle/>
+          <a:p>
+            <a:pPr marL="0" indent="0" algn="ctr">
+              <a:buNone/>
+            </a:pPr>
+            <a:r>
+              <a:rPr lang="cs-CZ" dirty="0"/>
+              <a:t>Zeleně jsou označeny věci navíc (nepožadované u maturity).</a:t>
+            </a:r>
+          </a:p>
+        </p:txBody>
+      </p:sp>
+    </p:spTree>
+    <p:extLst>
+      <p:ext uri="{BB962C8B-B14F-4D97-AF65-F5344CB8AC3E}">
+        <p14:creationId xmlns:p14="http://schemas.microsoft.com/office/powerpoint/2010/main" val="944681515"/>
+      </p:ext>
+    </p:extLst>
+  </p:cSld>
+  <p:clrMapOvr>
+    <a:masterClrMapping/>
+  </p:clrMapOvr>
+</p:sld>
+</file>
+
+<file path=ppt/slides/slide20.xml><?xml version="1.0" encoding="utf-8"?>
 <p:sld xmlns:a="http://schemas.openxmlformats.org/drawingml/2006/main" xmlns:r="http://schemas.openxmlformats.org/officeDocument/2006/relationships" xmlns:p="http://schemas.openxmlformats.org/presentationml/2006/main">
   <p:cSld>
     <p:bg>
@@ -9431,81 +10905,7 @@
 </p:sld>
 </file>
 
-<file path=ppt/slides/slide2.xml><?xml version="1.0" encoding="utf-8"?>
-<p:sld xmlns:a="http://schemas.openxmlformats.org/drawingml/2006/main" xmlns:r="http://schemas.openxmlformats.org/officeDocument/2006/relationships" xmlns:p="http://schemas.openxmlformats.org/presentationml/2006/main">
-  <p:cSld>
-    <p:spTree>
-      <p:nvGrpSpPr>
-        <p:cNvPr id="1" name=""/>
-        <p:cNvGrpSpPr/>
-        <p:nvPr/>
-      </p:nvGrpSpPr>
-      <p:grpSpPr>
-        <a:xfrm>
-          <a:off x="0" y="0"/>
-          <a:ext cx="0" cy="0"/>
-          <a:chOff x="0" y="0"/>
-          <a:chExt cx="0" cy="0"/>
-        </a:xfrm>
-      </p:grpSpPr>
-      <p:sp>
-        <p:nvSpPr>
-          <p:cNvPr id="3" name="Zástupný obsah 2">
-            <a:extLst>
-              <a:ext uri="{FF2B5EF4-FFF2-40B4-BE49-F238E27FC236}">
-                <a16:creationId xmlns:a16="http://schemas.microsoft.com/office/drawing/2014/main" id="{7B8E1416-38FB-7FA7-C2B9-F18029269975}"/>
-              </a:ext>
-            </a:extLst>
-          </p:cNvPr>
-          <p:cNvSpPr>
-            <a:spLocks noGrp="1"/>
-          </p:cNvSpPr>
-          <p:nvPr>
-            <p:ph idx="1"/>
-          </p:nvPr>
-        </p:nvSpPr>
-        <p:spPr>
-          <a:xfrm>
-            <a:off x="838200" y="3200400"/>
-            <a:ext cx="10515600" cy="457200"/>
-          </a:xfrm>
-          <a:solidFill>
-            <a:schemeClr val="accent6">
-              <a:lumMod val="20000"/>
-              <a:lumOff val="80000"/>
-            </a:schemeClr>
-          </a:solidFill>
-        </p:spPr>
-        <p:txBody>
-          <a:bodyPr>
-            <a:normAutofit lnSpcReduction="10000"/>
-          </a:bodyPr>
-          <a:lstStyle/>
-          <a:p>
-            <a:pPr marL="0" indent="0" algn="ctr">
-              <a:buNone/>
-            </a:pPr>
-            <a:r>
-              <a:rPr lang="cs-CZ" dirty="0"/>
-              <a:t>Zeleně jsou označeny věci navíc (nepožadované u maturity).</a:t>
-            </a:r>
-          </a:p>
-        </p:txBody>
-      </p:sp>
-    </p:spTree>
-    <p:extLst>
-      <p:ext uri="{BB962C8B-B14F-4D97-AF65-F5344CB8AC3E}">
-        <p14:creationId xmlns:p14="http://schemas.microsoft.com/office/powerpoint/2010/main" val="944681515"/>
-      </p:ext>
-    </p:extLst>
-  </p:cSld>
-  <p:clrMapOvr>
-    <a:masterClrMapping/>
-  </p:clrMapOvr>
-</p:sld>
-</file>
-
-<file path=ppt/slides/slide20.xml><?xml version="1.0" encoding="utf-8"?>
+<file path=ppt/slides/slide21.xml><?xml version="1.0" encoding="utf-8"?>
 <p:sld xmlns:a="http://schemas.openxmlformats.org/drawingml/2006/main" xmlns:r="http://schemas.openxmlformats.org/officeDocument/2006/relationships" xmlns:p="http://schemas.openxmlformats.org/presentationml/2006/main">
   <p:cSld>
     <p:bg>
@@ -9651,7 +11051,7 @@
 </p:sld>
 </file>
 
-<file path=ppt/slides/slide21.xml><?xml version="1.0" encoding="utf-8"?>
+<file path=ppt/slides/slide22.xml><?xml version="1.0" encoding="utf-8"?>
 <p:sld xmlns:a="http://schemas.openxmlformats.org/drawingml/2006/main" xmlns:r="http://schemas.openxmlformats.org/officeDocument/2006/relationships" xmlns:p="http://schemas.openxmlformats.org/presentationml/2006/main">
   <p:cSld>
     <p:spTree>
@@ -9927,7 +11327,7 @@
 </p:sld>
 </file>
 
-<file path=ppt/slides/slide22.xml><?xml version="1.0" encoding="utf-8"?>
+<file path=ppt/slides/slide23.xml><?xml version="1.0" encoding="utf-8"?>
 <p:sld xmlns:a="http://schemas.openxmlformats.org/drawingml/2006/main" xmlns:r="http://schemas.openxmlformats.org/officeDocument/2006/relationships" xmlns:p="http://schemas.openxmlformats.org/presentationml/2006/main">
   <p:cSld>
     <p:bg>
@@ -10660,7 +12060,7 @@
 </p:sld>
 </file>
 
-<file path=ppt/slides/slide23.xml><?xml version="1.0" encoding="utf-8"?>
+<file path=ppt/slides/slide24.xml><?xml version="1.0" encoding="utf-8"?>
 <p:sld xmlns:a="http://schemas.openxmlformats.org/drawingml/2006/main" xmlns:r="http://schemas.openxmlformats.org/officeDocument/2006/relationships" xmlns:p="http://schemas.openxmlformats.org/presentationml/2006/main">
   <p:cSld>
     <p:bg>
@@ -10945,7 +12345,7 @@
 </p:sld>
 </file>
 
-<file path=ppt/slides/slide24.xml><?xml version="1.0" encoding="utf-8"?>
+<file path=ppt/slides/slide25.xml><?xml version="1.0" encoding="utf-8"?>
 <p:sld xmlns:a="http://schemas.openxmlformats.org/drawingml/2006/main" xmlns:r="http://schemas.openxmlformats.org/officeDocument/2006/relationships" xmlns:p="http://schemas.openxmlformats.org/presentationml/2006/main">
   <p:cSld>
     <p:spTree>
@@ -14771,6 +16171,174 @@
           <p:cNvPr id="2" name="Nadpis 1">
             <a:extLst>
               <a:ext uri="{FF2B5EF4-FFF2-40B4-BE49-F238E27FC236}">
+                <a16:creationId xmlns:a16="http://schemas.microsoft.com/office/drawing/2014/main" id="{B853ABEA-6314-3C79-8842-28BDA8051134}"/>
+              </a:ext>
+            </a:extLst>
+          </p:cNvPr>
+          <p:cNvSpPr>
+            <a:spLocks noGrp="1"/>
+          </p:cNvSpPr>
+          <p:nvPr>
+            <p:ph type="title"/>
+          </p:nvPr>
+        </p:nvSpPr>
+        <p:spPr/>
+        <p:txBody>
+          <a:bodyPr/>
+          <a:lstStyle/>
+          <a:p>
+            <a:r>
+              <a:rPr lang="cs-CZ" dirty="0"/>
+              <a:t>Zásobník x halda</a:t>
+            </a:r>
+          </a:p>
+        </p:txBody>
+      </p:sp>
+      <p:sp>
+        <p:nvSpPr>
+          <p:cNvPr id="3" name="Zástupný obsah 2">
+            <a:extLst>
+              <a:ext uri="{FF2B5EF4-FFF2-40B4-BE49-F238E27FC236}">
+                <a16:creationId xmlns:a16="http://schemas.microsoft.com/office/drawing/2014/main" id="{D0A4E2A3-4868-6F03-D23E-E09FE2D33E55}"/>
+              </a:ext>
+            </a:extLst>
+          </p:cNvPr>
+          <p:cNvSpPr>
+            <a:spLocks noGrp="1"/>
+          </p:cNvSpPr>
+          <p:nvPr>
+            <p:ph idx="1"/>
+          </p:nvPr>
+        </p:nvSpPr>
+        <p:spPr>
+          <a:xfrm>
+            <a:off x="838200" y="1825624"/>
+            <a:ext cx="10515600" cy="4500747"/>
+          </a:xfrm>
+        </p:spPr>
+        <p:txBody>
+          <a:bodyPr>
+            <a:normAutofit lnSpcReduction="10000"/>
+          </a:bodyPr>
+          <a:lstStyle/>
+          <a:p>
+            <a:r>
+              <a:rPr lang="cs-CZ" dirty="0"/>
+              <a:t>Obojí jsou úložiště v paměti</a:t>
+            </a:r>
+          </a:p>
+          <a:p>
+            <a:r>
+              <a:rPr lang="cs-CZ" dirty="0"/>
+              <a:t>Zásobník - funguje jako LIFO</a:t>
+            </a:r>
+          </a:p>
+          <a:p>
+            <a:pPr lvl="1"/>
+            <a:r>
+              <a:rPr lang="cs-CZ" dirty="0"/>
+              <a:t>trochu rychlejší přístup, menší data</a:t>
+            </a:r>
+          </a:p>
+          <a:p>
+            <a:pPr lvl="1"/>
+            <a:r>
+              <a:rPr lang="cs-CZ" dirty="0"/>
+              <a:t>ukládají se na něj: proměnné hodnotového typu, návratové adresy při volání funkce (-&gt; proto </a:t>
+            </a:r>
+            <a:r>
+              <a:rPr lang="cs-CZ" i="1" dirty="0" err="1"/>
+              <a:t>StackOverflow</a:t>
+            </a:r>
+            <a:r>
+              <a:rPr lang="cs-CZ" dirty="0"/>
+              <a:t> při nekonečné rekurzi), přijaté argumenty funkce, odkazy na haldu při referenčních proměnných</a:t>
+            </a:r>
+          </a:p>
+          <a:p>
+            <a:r>
+              <a:rPr lang="cs-CZ" dirty="0"/>
+              <a:t>Halda	</a:t>
+            </a:r>
+          </a:p>
+          <a:p>
+            <a:pPr lvl="1"/>
+            <a:r>
+              <a:rPr lang="cs-CZ" dirty="0"/>
+              <a:t>Pomalejší přístup, větší data</a:t>
+            </a:r>
+          </a:p>
+          <a:p>
+            <a:pPr lvl="1"/>
+            <a:r>
+              <a:rPr lang="cs-CZ" dirty="0"/>
+              <a:t>Spravuje ji </a:t>
+            </a:r>
+            <a:r>
+              <a:rPr lang="cs-CZ" b="1" dirty="0" err="1"/>
+              <a:t>Garbage</a:t>
+            </a:r>
+            <a:r>
+              <a:rPr lang="cs-CZ" b="1" dirty="0"/>
+              <a:t> </a:t>
+            </a:r>
+            <a:r>
+              <a:rPr lang="cs-CZ" b="1" dirty="0" err="1"/>
+              <a:t>Collector</a:t>
+            </a:r>
+            <a:endParaRPr lang="cs-CZ" b="1" dirty="0"/>
+          </a:p>
+          <a:p>
+            <a:pPr lvl="2"/>
+            <a:r>
+              <a:rPr lang="cs-CZ" dirty="0"/>
+              <a:t>Jakmile na něco v haldě nevede odkaz ze zásobníku, GC to smaže</a:t>
+            </a:r>
+          </a:p>
+          <a:p>
+            <a:pPr lvl="2"/>
+            <a:r>
+              <a:rPr lang="cs-CZ" dirty="0"/>
+              <a:t>Jakmile je potřeba najít větší místo (např. pro dynamicky se zvětšující list), GC ho najde</a:t>
+            </a:r>
+          </a:p>
+        </p:txBody>
+      </p:sp>
+    </p:spTree>
+    <p:extLst>
+      <p:ext uri="{BB962C8B-B14F-4D97-AF65-F5344CB8AC3E}">
+        <p14:creationId xmlns:p14="http://schemas.microsoft.com/office/powerpoint/2010/main" val="3741458586"/>
+      </p:ext>
+    </p:extLst>
+  </p:cSld>
+  <p:clrMapOvr>
+    <a:masterClrMapping/>
+  </p:clrMapOvr>
+</p:sld>
+</file>
+
+<file path=ppt/slides/slide8.xml><?xml version="1.0" encoding="utf-8"?>
+<p:sld xmlns:a="http://schemas.openxmlformats.org/drawingml/2006/main" xmlns:r="http://schemas.openxmlformats.org/officeDocument/2006/relationships" xmlns:p="http://schemas.openxmlformats.org/presentationml/2006/main">
+  <p:cSld>
+    <p:spTree>
+      <p:nvGrpSpPr>
+        <p:cNvPr id="1" name=""/>
+        <p:cNvGrpSpPr/>
+        <p:nvPr/>
+      </p:nvGrpSpPr>
+      <p:grpSpPr>
+        <a:xfrm>
+          <a:off x="0" y="0"/>
+          <a:ext cx="0" cy="0"/>
+          <a:chOff x="0" y="0"/>
+          <a:chExt cx="0" cy="0"/>
+        </a:xfrm>
+      </p:grpSpPr>
+      <p:sp>
+        <p:nvSpPr>
+          <p:cNvPr id="2" name="Nadpis 1">
+            <a:extLst>
+              <a:ext uri="{FF2B5EF4-FFF2-40B4-BE49-F238E27FC236}">
                 <a16:creationId xmlns:a16="http://schemas.microsoft.com/office/drawing/2014/main" id="{D8A807B7-3BEE-6322-1F7D-F8116216DB57}"/>
               </a:ext>
             </a:extLst>
@@ -14818,7 +16386,12 @@
             <p:ph idx="1"/>
           </p:nvPr>
         </p:nvSpPr>
-        <p:spPr/>
+        <p:spPr>
+          <a:xfrm>
+            <a:off x="838200" y="3402419"/>
+            <a:ext cx="10515600" cy="547578"/>
+          </a:xfrm>
+        </p:spPr>
         <p:txBody>
           <a:bodyPr/>
           <a:lstStyle/>
@@ -14828,8 +16401,8 @@
               <a:t>Viz program </a:t>
             </a:r>
             <a:r>
-              <a:rPr lang="cs-CZ" i="1" dirty="0" err="1"/>
-              <a:t>Hodnotove_a_referencni_typy</a:t>
+              <a:rPr lang="cs-CZ" i="1" dirty="0"/>
+              <a:t>02_Hodnotove_a_referencni_typy</a:t>
             </a:r>
             <a:endParaRPr lang="cs-CZ" dirty="0"/>
           </a:p>
@@ -14848,7 +16421,7 @@
 </p:sld>
 </file>
 
-<file path=ppt/slides/slide8.xml><?xml version="1.0" encoding="utf-8"?>
+<file path=ppt/slides/slide9.xml><?xml version="1.0" encoding="utf-8"?>
 <p:sld xmlns:a="http://schemas.openxmlformats.org/drawingml/2006/main" xmlns:r="http://schemas.openxmlformats.org/officeDocument/2006/relationships" xmlns:p="http://schemas.openxmlformats.org/presentationml/2006/main">
   <p:cSld>
     <p:bg>
@@ -15349,1405 +16922,6 @@
       <p:bldP spid="10" grpId="0"/>
     </p:bldLst>
   </p:timing>
-</p:sld>
-</file>
-
-<file path=ppt/slides/slide9.xml><?xml version="1.0" encoding="utf-8"?>
-<p:sld xmlns:a="http://schemas.openxmlformats.org/drawingml/2006/main" xmlns:r="http://schemas.openxmlformats.org/officeDocument/2006/relationships" xmlns:p="http://schemas.openxmlformats.org/presentationml/2006/main">
-  <p:cSld>
-    <p:spTree>
-      <p:nvGrpSpPr>
-        <p:cNvPr id="1" name=""/>
-        <p:cNvGrpSpPr/>
-        <p:nvPr/>
-      </p:nvGrpSpPr>
-      <p:grpSpPr>
-        <a:xfrm>
-          <a:off x="0" y="0"/>
-          <a:ext cx="0" cy="0"/>
-          <a:chOff x="0" y="0"/>
-          <a:chExt cx="0" cy="0"/>
-        </a:xfrm>
-      </p:grpSpPr>
-      <p:sp>
-        <p:nvSpPr>
-          <p:cNvPr id="2" name="Nadpis 1">
-            <a:extLst>
-              <a:ext uri="{FF2B5EF4-FFF2-40B4-BE49-F238E27FC236}">
-                <a16:creationId xmlns:a16="http://schemas.microsoft.com/office/drawing/2014/main" id="{2F34CF01-C529-6756-F7BA-5430555FB20D}"/>
-              </a:ext>
-            </a:extLst>
-          </p:cNvPr>
-          <p:cNvSpPr>
-            <a:spLocks noGrp="1"/>
-          </p:cNvSpPr>
-          <p:nvPr>
-            <p:ph type="title"/>
-          </p:nvPr>
-        </p:nvSpPr>
-        <p:spPr/>
-        <p:txBody>
-          <a:bodyPr/>
-          <a:lstStyle/>
-          <a:p>
-            <a:r>
-              <a:rPr lang="cs-CZ" dirty="0"/>
-              <a:t>Základní datové typy</a:t>
-            </a:r>
-          </a:p>
-        </p:txBody>
-      </p:sp>
-      <p:sp>
-        <p:nvSpPr>
-          <p:cNvPr id="3" name="Zástupný obsah 2">
-            <a:extLst>
-              <a:ext uri="{FF2B5EF4-FFF2-40B4-BE49-F238E27FC236}">
-                <a16:creationId xmlns:a16="http://schemas.microsoft.com/office/drawing/2014/main" id="{1EC3BA78-5767-BC77-13AC-A90FA58CE7EA}"/>
-              </a:ext>
-            </a:extLst>
-          </p:cNvPr>
-          <p:cNvSpPr>
-            <a:spLocks noGrp="1"/>
-          </p:cNvSpPr>
-          <p:nvPr>
-            <p:ph idx="1"/>
-          </p:nvPr>
-        </p:nvSpPr>
-        <p:spPr>
-          <a:xfrm>
-            <a:off x="838200" y="1825625"/>
-            <a:ext cx="10515600" cy="501116"/>
-          </a:xfrm>
-        </p:spPr>
-        <p:txBody>
-          <a:bodyPr/>
-          <a:lstStyle/>
-          <a:p>
-            <a:r>
-              <a:rPr lang="cs-CZ" dirty="0"/>
-              <a:t>Celočíselné znaménkové (</a:t>
-            </a:r>
-            <a:r>
-              <a:rPr lang="cs-CZ" dirty="0" err="1"/>
-              <a:t>signed</a:t>
-            </a:r>
-            <a:r>
-              <a:rPr lang="cs-CZ" dirty="0"/>
-              <a:t>) typy</a:t>
-            </a:r>
-          </a:p>
-        </p:txBody>
-      </p:sp>
-      <p:graphicFrame>
-        <p:nvGraphicFramePr>
-          <p:cNvPr id="4" name="Tabulka 3">
-            <a:extLst>
-              <a:ext uri="{FF2B5EF4-FFF2-40B4-BE49-F238E27FC236}">
-                <a16:creationId xmlns:a16="http://schemas.microsoft.com/office/drawing/2014/main" id="{33AF6546-55ED-5892-E75F-D46259D01255}"/>
-              </a:ext>
-            </a:extLst>
-          </p:cNvPr>
-          <p:cNvGraphicFramePr>
-            <a:graphicFrameLocks noGrp="1"/>
-          </p:cNvGraphicFramePr>
-          <p:nvPr>
-            <p:extLst>
-              <p:ext uri="{D42A27DB-BD31-4B8C-83A1-F6EECF244321}">
-                <p14:modId xmlns:p14="http://schemas.microsoft.com/office/powerpoint/2010/main" val="2476371086"/>
-              </p:ext>
-            </p:extLst>
-          </p:nvPr>
-        </p:nvGraphicFramePr>
-        <p:xfrm>
-          <a:off x="838200" y="3086894"/>
-          <a:ext cx="10515600" cy="1828800"/>
-        </p:xfrm>
-        <a:graphic>
-          <a:graphicData uri="http://schemas.openxmlformats.org/drawingml/2006/table">
-            <a:tbl>
-              <a:tblPr/>
-              <a:tblGrid>
-                <a:gridCol w="2628900">
-                  <a:extLst>
-                    <a:ext uri="{9D8B030D-6E8A-4147-A177-3AD203B41FA5}">
-                      <a16:colId xmlns:a16="http://schemas.microsoft.com/office/drawing/2014/main" val="3592932743"/>
-                    </a:ext>
-                  </a:extLst>
-                </a:gridCol>
-                <a:gridCol w="2628900">
-                  <a:extLst>
-                    <a:ext uri="{9D8B030D-6E8A-4147-A177-3AD203B41FA5}">
-                      <a16:colId xmlns:a16="http://schemas.microsoft.com/office/drawing/2014/main" val="3704334404"/>
-                    </a:ext>
-                  </a:extLst>
-                </a:gridCol>
-                <a:gridCol w="2628900">
-                  <a:extLst>
-                    <a:ext uri="{9D8B030D-6E8A-4147-A177-3AD203B41FA5}">
-                      <a16:colId xmlns:a16="http://schemas.microsoft.com/office/drawing/2014/main" val="1214681106"/>
-                    </a:ext>
-                  </a:extLst>
-                </a:gridCol>
-                <a:gridCol w="2628900">
-                  <a:extLst>
-                    <a:ext uri="{9D8B030D-6E8A-4147-A177-3AD203B41FA5}">
-                      <a16:colId xmlns:a16="http://schemas.microsoft.com/office/drawing/2014/main" val="4186449202"/>
-                    </a:ext>
-                  </a:extLst>
-                </a:gridCol>
-              </a:tblGrid>
-              <a:tr h="0">
-                <a:tc>
-                  <a:txBody>
-                    <a:bodyPr/>
-                    <a:lstStyle/>
-                    <a:p>
-                      <a:pPr>
-                        <a:buNone/>
-                      </a:pPr>
-                      <a:r>
-                        <a:rPr lang="cs-CZ" b="1">
-                          <a:effectLst/>
-                          <a:latin typeface="Google Sans Text"/>
-                        </a:rPr>
-                        <a:t>C# Typ</a:t>
-                      </a:r>
-                      <a:endParaRPr lang="cs-CZ">
-                        <a:effectLst/>
-                        <a:latin typeface="Google Sans Text"/>
-                      </a:endParaRPr>
-                    </a:p>
-                  </a:txBody>
-                  <a:tcPr anchor="ctr">
-                    <a:lnL w="9525" cap="flat" cmpd="sng" algn="ctr">
-                      <a:solidFill>
-                        <a:schemeClr val="bg1"/>
-                      </a:solidFill>
-                      <a:prstDash val="solid"/>
-                      <a:round/>
-                      <a:headEnd type="none" w="med" len="med"/>
-                      <a:tailEnd type="none" w="med" len="med"/>
-                    </a:lnL>
-                    <a:lnR w="9525" cap="flat" cmpd="sng" algn="ctr">
-                      <a:solidFill>
-                        <a:schemeClr val="bg1"/>
-                      </a:solidFill>
-                      <a:prstDash val="solid"/>
-                      <a:round/>
-                      <a:headEnd type="none" w="med" len="med"/>
-                      <a:tailEnd type="none" w="med" len="med"/>
-                    </a:lnR>
-                    <a:lnT w="9525" cap="flat" cmpd="sng" algn="ctr">
-                      <a:solidFill>
-                        <a:schemeClr val="bg1"/>
-                      </a:solidFill>
-                      <a:prstDash val="solid"/>
-                      <a:round/>
-                      <a:headEnd type="none" w="med" len="med"/>
-                      <a:tailEnd type="none" w="med" len="med"/>
-                    </a:lnT>
-                    <a:lnB w="9525" cap="flat" cmpd="sng" algn="ctr">
-                      <a:solidFill>
-                        <a:schemeClr val="bg1"/>
-                      </a:solidFill>
-                      <a:prstDash val="solid"/>
-                      <a:round/>
-                      <a:headEnd type="none" w="med" len="med"/>
-                      <a:tailEnd type="none" w="med" len="med"/>
-                    </a:lnB>
-                    <a:noFill/>
-                  </a:tcPr>
-                </a:tc>
-                <a:tc>
-                  <a:txBody>
-                    <a:bodyPr/>
-                    <a:lstStyle/>
-                    <a:p>
-                      <a:pPr>
-                        <a:buNone/>
-                      </a:pPr>
-                      <a:r>
-                        <a:rPr lang="cs-CZ" b="1">
-                          <a:effectLst/>
-                          <a:latin typeface="Google Sans Text"/>
-                        </a:rPr>
-                        <a:t>.NET Typ</a:t>
-                      </a:r>
-                      <a:endParaRPr lang="cs-CZ">
-                        <a:effectLst/>
-                        <a:latin typeface="Google Sans Text"/>
-                      </a:endParaRPr>
-                    </a:p>
-                  </a:txBody>
-                  <a:tcPr anchor="ctr">
-                    <a:lnL w="9525" cap="flat" cmpd="sng" algn="ctr">
-                      <a:solidFill>
-                        <a:schemeClr val="bg1"/>
-                      </a:solidFill>
-                      <a:prstDash val="solid"/>
-                      <a:round/>
-                      <a:headEnd type="none" w="med" len="med"/>
-                      <a:tailEnd type="none" w="med" len="med"/>
-                    </a:lnL>
-                    <a:lnR w="9525" cap="flat" cmpd="sng" algn="ctr">
-                      <a:solidFill>
-                        <a:schemeClr val="bg1"/>
-                      </a:solidFill>
-                      <a:prstDash val="solid"/>
-                      <a:round/>
-                      <a:headEnd type="none" w="med" len="med"/>
-                      <a:tailEnd type="none" w="med" len="med"/>
-                    </a:lnR>
-                    <a:lnT w="9525" cap="flat" cmpd="sng" algn="ctr">
-                      <a:solidFill>
-                        <a:schemeClr val="bg1"/>
-                      </a:solidFill>
-                      <a:prstDash val="solid"/>
-                      <a:round/>
-                      <a:headEnd type="none" w="med" len="med"/>
-                      <a:tailEnd type="none" w="med" len="med"/>
-                    </a:lnT>
-                    <a:lnB w="9525" cap="flat" cmpd="sng" algn="ctr">
-                      <a:solidFill>
-                        <a:schemeClr val="bg1"/>
-                      </a:solidFill>
-                      <a:prstDash val="solid"/>
-                      <a:round/>
-                      <a:headEnd type="none" w="med" len="med"/>
-                      <a:tailEnd type="none" w="med" len="med"/>
-                    </a:lnB>
-                    <a:noFill/>
-                  </a:tcPr>
-                </a:tc>
-                <a:tc>
-                  <a:txBody>
-                    <a:bodyPr/>
-                    <a:lstStyle/>
-                    <a:p>
-                      <a:pPr>
-                        <a:buNone/>
-                      </a:pPr>
-                      <a:r>
-                        <a:rPr lang="cs-CZ" b="1" dirty="0">
-                          <a:effectLst/>
-                          <a:latin typeface="Google Sans Text"/>
-                        </a:rPr>
-                        <a:t>Velikost (Byty)</a:t>
-                      </a:r>
-                      <a:endParaRPr lang="cs-CZ" dirty="0">
-                        <a:effectLst/>
-                        <a:latin typeface="Google Sans Text"/>
-                      </a:endParaRPr>
-                    </a:p>
-                  </a:txBody>
-                  <a:tcPr anchor="ctr">
-                    <a:lnL w="9525" cap="flat" cmpd="sng" algn="ctr">
-                      <a:solidFill>
-                        <a:schemeClr val="bg1"/>
-                      </a:solidFill>
-                      <a:prstDash val="solid"/>
-                      <a:round/>
-                      <a:headEnd type="none" w="med" len="med"/>
-                      <a:tailEnd type="none" w="med" len="med"/>
-                    </a:lnL>
-                    <a:lnR w="9525" cap="flat" cmpd="sng" algn="ctr">
-                      <a:solidFill>
-                        <a:schemeClr val="bg1"/>
-                      </a:solidFill>
-                      <a:prstDash val="solid"/>
-                      <a:round/>
-                      <a:headEnd type="none" w="med" len="med"/>
-                      <a:tailEnd type="none" w="med" len="med"/>
-                    </a:lnR>
-                    <a:lnT w="9525" cap="flat" cmpd="sng" algn="ctr">
-                      <a:solidFill>
-                        <a:schemeClr val="bg1"/>
-                      </a:solidFill>
-                      <a:prstDash val="solid"/>
-                      <a:round/>
-                      <a:headEnd type="none" w="med" len="med"/>
-                      <a:tailEnd type="none" w="med" len="med"/>
-                    </a:lnT>
-                    <a:lnB w="9525" cap="flat" cmpd="sng" algn="ctr">
-                      <a:solidFill>
-                        <a:schemeClr val="bg1"/>
-                      </a:solidFill>
-                      <a:prstDash val="solid"/>
-                      <a:round/>
-                      <a:headEnd type="none" w="med" len="med"/>
-                      <a:tailEnd type="none" w="med" len="med"/>
-                    </a:lnB>
-                    <a:noFill/>
-                  </a:tcPr>
-                </a:tc>
-                <a:tc>
-                  <a:txBody>
-                    <a:bodyPr/>
-                    <a:lstStyle/>
-                    <a:p>
-                      <a:pPr>
-                        <a:buNone/>
-                      </a:pPr>
-                      <a:r>
-                        <a:rPr lang="cs-CZ" b="1">
-                          <a:effectLst/>
-                          <a:latin typeface="Google Sans Text"/>
-                        </a:rPr>
-                        <a:t>Rozsah (přibližně)</a:t>
-                      </a:r>
-                      <a:endParaRPr lang="cs-CZ">
-                        <a:effectLst/>
-                        <a:latin typeface="Google Sans Text"/>
-                      </a:endParaRPr>
-                    </a:p>
-                  </a:txBody>
-                  <a:tcPr anchor="ctr">
-                    <a:lnL w="9525" cap="flat" cmpd="sng" algn="ctr">
-                      <a:solidFill>
-                        <a:schemeClr val="bg1"/>
-                      </a:solidFill>
-                      <a:prstDash val="solid"/>
-                      <a:round/>
-                      <a:headEnd type="none" w="med" len="med"/>
-                      <a:tailEnd type="none" w="med" len="med"/>
-                    </a:lnL>
-                    <a:lnR w="9525" cap="flat" cmpd="sng" algn="ctr">
-                      <a:solidFill>
-                        <a:schemeClr val="bg1"/>
-                      </a:solidFill>
-                      <a:prstDash val="solid"/>
-                      <a:round/>
-                      <a:headEnd type="none" w="med" len="med"/>
-                      <a:tailEnd type="none" w="med" len="med"/>
-                    </a:lnR>
-                    <a:lnT w="9525" cap="flat" cmpd="sng" algn="ctr">
-                      <a:solidFill>
-                        <a:schemeClr val="bg1"/>
-                      </a:solidFill>
-                      <a:prstDash val="solid"/>
-                      <a:round/>
-                      <a:headEnd type="none" w="med" len="med"/>
-                      <a:tailEnd type="none" w="med" len="med"/>
-                    </a:lnT>
-                    <a:lnB w="9525" cap="flat" cmpd="sng" algn="ctr">
-                      <a:solidFill>
-                        <a:schemeClr val="bg1"/>
-                      </a:solidFill>
-                      <a:prstDash val="solid"/>
-                      <a:round/>
-                      <a:headEnd type="none" w="med" len="med"/>
-                      <a:tailEnd type="none" w="med" len="med"/>
-                    </a:lnB>
-                    <a:noFill/>
-                  </a:tcPr>
-                </a:tc>
-                <a:extLst>
-                  <a:ext uri="{0D108BD9-81ED-4DB2-BD59-A6C34878D82A}">
-                    <a16:rowId xmlns:a16="http://schemas.microsoft.com/office/drawing/2014/main" val="217901554"/>
-                  </a:ext>
-                </a:extLst>
-              </a:tr>
-              <a:tr h="0">
-                <a:tc>
-                  <a:txBody>
-                    <a:bodyPr/>
-                    <a:lstStyle/>
-                    <a:p>
-                      <a:pPr>
-                        <a:buNone/>
-                      </a:pPr>
-                      <a:r>
-                        <a:rPr lang="cs-CZ" b="1">
-                          <a:effectLst/>
-                          <a:latin typeface="Google Sans Text"/>
-                        </a:rPr>
-                        <a:t>sbyte</a:t>
-                      </a:r>
-                      <a:endParaRPr lang="cs-CZ">
-                        <a:effectLst/>
-                        <a:latin typeface="Google Sans Text"/>
-                      </a:endParaRPr>
-                    </a:p>
-                  </a:txBody>
-                  <a:tcPr anchor="ctr">
-                    <a:lnL w="9525" cap="flat" cmpd="sng" algn="ctr">
-                      <a:solidFill>
-                        <a:schemeClr val="bg1"/>
-                      </a:solidFill>
-                      <a:prstDash val="solid"/>
-                      <a:round/>
-                      <a:headEnd type="none" w="med" len="med"/>
-                      <a:tailEnd type="none" w="med" len="med"/>
-                    </a:lnL>
-                    <a:lnR w="9525" cap="flat" cmpd="sng" algn="ctr">
-                      <a:solidFill>
-                        <a:schemeClr val="bg1"/>
-                      </a:solidFill>
-                      <a:prstDash val="solid"/>
-                      <a:round/>
-                      <a:headEnd type="none" w="med" len="med"/>
-                      <a:tailEnd type="none" w="med" len="med"/>
-                    </a:lnR>
-                    <a:lnT w="9525" cap="flat" cmpd="sng" algn="ctr">
-                      <a:solidFill>
-                        <a:schemeClr val="bg1"/>
-                      </a:solidFill>
-                      <a:prstDash val="solid"/>
-                      <a:round/>
-                      <a:headEnd type="none" w="med" len="med"/>
-                      <a:tailEnd type="none" w="med" len="med"/>
-                    </a:lnT>
-                    <a:lnB w="9525" cap="flat" cmpd="sng" algn="ctr">
-                      <a:solidFill>
-                        <a:schemeClr val="bg1"/>
-                      </a:solidFill>
-                      <a:prstDash val="solid"/>
-                      <a:round/>
-                      <a:headEnd type="none" w="med" len="med"/>
-                      <a:tailEnd type="none" w="med" len="med"/>
-                    </a:lnB>
-                    <a:solidFill>
-                      <a:schemeClr val="accent6">
-                        <a:lumMod val="20000"/>
-                        <a:lumOff val="80000"/>
-                      </a:schemeClr>
-                    </a:solidFill>
-                  </a:tcPr>
-                </a:tc>
-                <a:tc>
-                  <a:txBody>
-                    <a:bodyPr/>
-                    <a:lstStyle/>
-                    <a:p>
-                      <a:pPr>
-                        <a:buNone/>
-                      </a:pPr>
-                      <a:r>
-                        <a:rPr lang="cs-CZ">
-                          <a:effectLst/>
-                          <a:latin typeface="Google Sans Text"/>
-                        </a:rPr>
-                        <a:t>SByte</a:t>
-                      </a:r>
-                    </a:p>
-                  </a:txBody>
-                  <a:tcPr anchor="ctr">
-                    <a:lnL w="9525" cap="flat" cmpd="sng" algn="ctr">
-                      <a:solidFill>
-                        <a:schemeClr val="bg1"/>
-                      </a:solidFill>
-                      <a:prstDash val="solid"/>
-                      <a:round/>
-                      <a:headEnd type="none" w="med" len="med"/>
-                      <a:tailEnd type="none" w="med" len="med"/>
-                    </a:lnL>
-                    <a:lnR w="9525" cap="flat" cmpd="sng" algn="ctr">
-                      <a:solidFill>
-                        <a:schemeClr val="bg1"/>
-                      </a:solidFill>
-                      <a:prstDash val="solid"/>
-                      <a:round/>
-                      <a:headEnd type="none" w="med" len="med"/>
-                      <a:tailEnd type="none" w="med" len="med"/>
-                    </a:lnR>
-                    <a:lnT w="9525" cap="flat" cmpd="sng" algn="ctr">
-                      <a:solidFill>
-                        <a:schemeClr val="bg1"/>
-                      </a:solidFill>
-                      <a:prstDash val="solid"/>
-                      <a:round/>
-                      <a:headEnd type="none" w="med" len="med"/>
-                      <a:tailEnd type="none" w="med" len="med"/>
-                    </a:lnT>
-                    <a:lnB w="9525" cap="flat" cmpd="sng" algn="ctr">
-                      <a:solidFill>
-                        <a:schemeClr val="bg1"/>
-                      </a:solidFill>
-                      <a:prstDash val="solid"/>
-                      <a:round/>
-                      <a:headEnd type="none" w="med" len="med"/>
-                      <a:tailEnd type="none" w="med" len="med"/>
-                    </a:lnB>
-                    <a:solidFill>
-                      <a:schemeClr val="accent6">
-                        <a:lumMod val="20000"/>
-                        <a:lumOff val="80000"/>
-                      </a:schemeClr>
-                    </a:solidFill>
-                  </a:tcPr>
-                </a:tc>
-                <a:tc>
-                  <a:txBody>
-                    <a:bodyPr/>
-                    <a:lstStyle/>
-                    <a:p>
-                      <a:pPr>
-                        <a:buNone/>
-                      </a:pPr>
-                      <a:r>
-                        <a:rPr lang="cs-CZ">
-                          <a:effectLst/>
-                          <a:latin typeface="Google Sans Text"/>
-                        </a:rPr>
-                        <a:t>1 B</a:t>
-                      </a:r>
-                    </a:p>
-                  </a:txBody>
-                  <a:tcPr anchor="ctr">
-                    <a:lnL w="9525" cap="flat" cmpd="sng" algn="ctr">
-                      <a:solidFill>
-                        <a:schemeClr val="bg1"/>
-                      </a:solidFill>
-                      <a:prstDash val="solid"/>
-                      <a:round/>
-                      <a:headEnd type="none" w="med" len="med"/>
-                      <a:tailEnd type="none" w="med" len="med"/>
-                    </a:lnL>
-                    <a:lnR w="9525" cap="flat" cmpd="sng" algn="ctr">
-                      <a:solidFill>
-                        <a:schemeClr val="bg1"/>
-                      </a:solidFill>
-                      <a:prstDash val="solid"/>
-                      <a:round/>
-                      <a:headEnd type="none" w="med" len="med"/>
-                      <a:tailEnd type="none" w="med" len="med"/>
-                    </a:lnR>
-                    <a:lnT w="9525" cap="flat" cmpd="sng" algn="ctr">
-                      <a:solidFill>
-                        <a:schemeClr val="bg1"/>
-                      </a:solidFill>
-                      <a:prstDash val="solid"/>
-                      <a:round/>
-                      <a:headEnd type="none" w="med" len="med"/>
-                      <a:tailEnd type="none" w="med" len="med"/>
-                    </a:lnT>
-                    <a:lnB w="9525" cap="flat" cmpd="sng" algn="ctr">
-                      <a:solidFill>
-                        <a:schemeClr val="bg1"/>
-                      </a:solidFill>
-                      <a:prstDash val="solid"/>
-                      <a:round/>
-                      <a:headEnd type="none" w="med" len="med"/>
-                      <a:tailEnd type="none" w="med" len="med"/>
-                    </a:lnB>
-                    <a:solidFill>
-                      <a:schemeClr val="accent6">
-                        <a:lumMod val="20000"/>
-                        <a:lumOff val="80000"/>
-                      </a:schemeClr>
-                    </a:solidFill>
-                  </a:tcPr>
-                </a:tc>
-                <a:tc>
-                  <a:txBody>
-                    <a:bodyPr/>
-                    <a:lstStyle/>
-                    <a:p>
-                      <a:pPr>
-                        <a:buNone/>
-                      </a:pPr>
-                      <a:r>
-                        <a:rPr lang="cs-CZ" dirty="0">
-                          <a:effectLst/>
-                          <a:latin typeface="Google Sans Text"/>
-                        </a:rPr>
-                        <a:t>-128 až 127</a:t>
-                      </a:r>
-                    </a:p>
-                  </a:txBody>
-                  <a:tcPr anchor="ctr">
-                    <a:lnL w="9525" cap="flat" cmpd="sng" algn="ctr">
-                      <a:solidFill>
-                        <a:schemeClr val="bg1"/>
-                      </a:solidFill>
-                      <a:prstDash val="solid"/>
-                      <a:round/>
-                      <a:headEnd type="none" w="med" len="med"/>
-                      <a:tailEnd type="none" w="med" len="med"/>
-                    </a:lnL>
-                    <a:lnR w="9525" cap="flat" cmpd="sng" algn="ctr">
-                      <a:solidFill>
-                        <a:schemeClr val="bg1"/>
-                      </a:solidFill>
-                      <a:prstDash val="solid"/>
-                      <a:round/>
-                      <a:headEnd type="none" w="med" len="med"/>
-                      <a:tailEnd type="none" w="med" len="med"/>
-                    </a:lnR>
-                    <a:lnT w="9525" cap="flat" cmpd="sng" algn="ctr">
-                      <a:solidFill>
-                        <a:schemeClr val="bg1"/>
-                      </a:solidFill>
-                      <a:prstDash val="solid"/>
-                      <a:round/>
-                      <a:headEnd type="none" w="med" len="med"/>
-                      <a:tailEnd type="none" w="med" len="med"/>
-                    </a:lnT>
-                    <a:lnB w="9525" cap="flat" cmpd="sng" algn="ctr">
-                      <a:solidFill>
-                        <a:schemeClr val="bg1"/>
-                      </a:solidFill>
-                      <a:prstDash val="solid"/>
-                      <a:round/>
-                      <a:headEnd type="none" w="med" len="med"/>
-                      <a:tailEnd type="none" w="med" len="med"/>
-                    </a:lnB>
-                    <a:solidFill>
-                      <a:schemeClr val="accent6">
-                        <a:lumMod val="20000"/>
-                        <a:lumOff val="80000"/>
-                      </a:schemeClr>
-                    </a:solidFill>
-                  </a:tcPr>
-                </a:tc>
-                <a:extLst>
-                  <a:ext uri="{0D108BD9-81ED-4DB2-BD59-A6C34878D82A}">
-                    <a16:rowId xmlns:a16="http://schemas.microsoft.com/office/drawing/2014/main" val="2378009523"/>
-                  </a:ext>
-                </a:extLst>
-              </a:tr>
-              <a:tr h="0">
-                <a:tc>
-                  <a:txBody>
-                    <a:bodyPr/>
-                    <a:lstStyle/>
-                    <a:p>
-                      <a:pPr>
-                        <a:buNone/>
-                      </a:pPr>
-                      <a:r>
-                        <a:rPr lang="cs-CZ" b="1">
-                          <a:effectLst/>
-                          <a:latin typeface="Google Sans Text"/>
-                        </a:rPr>
-                        <a:t>short</a:t>
-                      </a:r>
-                      <a:endParaRPr lang="cs-CZ">
-                        <a:effectLst/>
-                        <a:latin typeface="Google Sans Text"/>
-                      </a:endParaRPr>
-                    </a:p>
-                  </a:txBody>
-                  <a:tcPr anchor="ctr">
-                    <a:lnL w="9525" cap="flat" cmpd="sng" algn="ctr">
-                      <a:solidFill>
-                        <a:schemeClr val="bg1"/>
-                      </a:solidFill>
-                      <a:prstDash val="solid"/>
-                      <a:round/>
-                      <a:headEnd type="none" w="med" len="med"/>
-                      <a:tailEnd type="none" w="med" len="med"/>
-                    </a:lnL>
-                    <a:lnR w="9525" cap="flat" cmpd="sng" algn="ctr">
-                      <a:solidFill>
-                        <a:schemeClr val="bg1"/>
-                      </a:solidFill>
-                      <a:prstDash val="solid"/>
-                      <a:round/>
-                      <a:headEnd type="none" w="med" len="med"/>
-                      <a:tailEnd type="none" w="med" len="med"/>
-                    </a:lnR>
-                    <a:lnT w="9525" cap="flat" cmpd="sng" algn="ctr">
-                      <a:solidFill>
-                        <a:schemeClr val="bg1"/>
-                      </a:solidFill>
-                      <a:prstDash val="solid"/>
-                      <a:round/>
-                      <a:headEnd type="none" w="med" len="med"/>
-                      <a:tailEnd type="none" w="med" len="med"/>
-                    </a:lnT>
-                    <a:lnB w="9525" cap="flat" cmpd="sng" algn="ctr">
-                      <a:solidFill>
-                        <a:schemeClr val="bg1"/>
-                      </a:solidFill>
-                      <a:prstDash val="solid"/>
-                      <a:round/>
-                      <a:headEnd type="none" w="med" len="med"/>
-                      <a:tailEnd type="none" w="med" len="med"/>
-                    </a:lnB>
-                    <a:noFill/>
-                  </a:tcPr>
-                </a:tc>
-                <a:tc>
-                  <a:txBody>
-                    <a:bodyPr/>
-                    <a:lstStyle/>
-                    <a:p>
-                      <a:pPr>
-                        <a:buNone/>
-                      </a:pPr>
-                      <a:r>
-                        <a:rPr lang="cs-CZ">
-                          <a:effectLst/>
-                          <a:latin typeface="Google Sans Text"/>
-                        </a:rPr>
-                        <a:t>Int16</a:t>
-                      </a:r>
-                    </a:p>
-                  </a:txBody>
-                  <a:tcPr anchor="ctr">
-                    <a:lnL w="9525" cap="flat" cmpd="sng" algn="ctr">
-                      <a:solidFill>
-                        <a:schemeClr val="bg1"/>
-                      </a:solidFill>
-                      <a:prstDash val="solid"/>
-                      <a:round/>
-                      <a:headEnd type="none" w="med" len="med"/>
-                      <a:tailEnd type="none" w="med" len="med"/>
-                    </a:lnL>
-                    <a:lnR w="9525" cap="flat" cmpd="sng" algn="ctr">
-                      <a:solidFill>
-                        <a:schemeClr val="bg1"/>
-                      </a:solidFill>
-                      <a:prstDash val="solid"/>
-                      <a:round/>
-                      <a:headEnd type="none" w="med" len="med"/>
-                      <a:tailEnd type="none" w="med" len="med"/>
-                    </a:lnR>
-                    <a:lnT w="9525" cap="flat" cmpd="sng" algn="ctr">
-                      <a:solidFill>
-                        <a:schemeClr val="bg1"/>
-                      </a:solidFill>
-                      <a:prstDash val="solid"/>
-                      <a:round/>
-                      <a:headEnd type="none" w="med" len="med"/>
-                      <a:tailEnd type="none" w="med" len="med"/>
-                    </a:lnT>
-                    <a:lnB w="9525" cap="flat" cmpd="sng" algn="ctr">
-                      <a:solidFill>
-                        <a:schemeClr val="bg1"/>
-                      </a:solidFill>
-                      <a:prstDash val="solid"/>
-                      <a:round/>
-                      <a:headEnd type="none" w="med" len="med"/>
-                      <a:tailEnd type="none" w="med" len="med"/>
-                    </a:lnB>
-                    <a:noFill/>
-                  </a:tcPr>
-                </a:tc>
-                <a:tc>
-                  <a:txBody>
-                    <a:bodyPr/>
-                    <a:lstStyle/>
-                    <a:p>
-                      <a:pPr>
-                        <a:buNone/>
-                      </a:pPr>
-                      <a:r>
-                        <a:rPr lang="cs-CZ" dirty="0">
-                          <a:effectLst/>
-                          <a:latin typeface="Google Sans Text"/>
-                        </a:rPr>
-                        <a:t>2 B</a:t>
-                      </a:r>
-                    </a:p>
-                  </a:txBody>
-                  <a:tcPr anchor="ctr">
-                    <a:lnL w="9525" cap="flat" cmpd="sng" algn="ctr">
-                      <a:solidFill>
-                        <a:schemeClr val="bg1"/>
-                      </a:solidFill>
-                      <a:prstDash val="solid"/>
-                      <a:round/>
-                      <a:headEnd type="none" w="med" len="med"/>
-                      <a:tailEnd type="none" w="med" len="med"/>
-                    </a:lnL>
-                    <a:lnR w="9525" cap="flat" cmpd="sng" algn="ctr">
-                      <a:solidFill>
-                        <a:schemeClr val="bg1"/>
-                      </a:solidFill>
-                      <a:prstDash val="solid"/>
-                      <a:round/>
-                      <a:headEnd type="none" w="med" len="med"/>
-                      <a:tailEnd type="none" w="med" len="med"/>
-                    </a:lnR>
-                    <a:lnT w="9525" cap="flat" cmpd="sng" algn="ctr">
-                      <a:solidFill>
-                        <a:schemeClr val="bg1"/>
-                      </a:solidFill>
-                      <a:prstDash val="solid"/>
-                      <a:round/>
-                      <a:headEnd type="none" w="med" len="med"/>
-                      <a:tailEnd type="none" w="med" len="med"/>
-                    </a:lnT>
-                    <a:lnB w="9525" cap="flat" cmpd="sng" algn="ctr">
-                      <a:solidFill>
-                        <a:schemeClr val="bg1"/>
-                      </a:solidFill>
-                      <a:prstDash val="solid"/>
-                      <a:round/>
-                      <a:headEnd type="none" w="med" len="med"/>
-                      <a:tailEnd type="none" w="med" len="med"/>
-                    </a:lnB>
-                    <a:noFill/>
-                  </a:tcPr>
-                </a:tc>
-                <a:tc>
-                  <a:txBody>
-                    <a:bodyPr/>
-                    <a:lstStyle/>
-                    <a:p>
-                      <a:pPr>
-                        <a:buNone/>
-                      </a:pPr>
-                      <a:r>
-                        <a:rPr lang="cs-CZ">
-                          <a:effectLst/>
-                          <a:latin typeface="Google Sans Text"/>
-                        </a:rPr>
-                        <a:t>-32 768 až 32 767</a:t>
-                      </a:r>
-                    </a:p>
-                  </a:txBody>
-                  <a:tcPr anchor="ctr">
-                    <a:lnL w="9525" cap="flat" cmpd="sng" algn="ctr">
-                      <a:solidFill>
-                        <a:schemeClr val="bg1"/>
-                      </a:solidFill>
-                      <a:prstDash val="solid"/>
-                      <a:round/>
-                      <a:headEnd type="none" w="med" len="med"/>
-                      <a:tailEnd type="none" w="med" len="med"/>
-                    </a:lnL>
-                    <a:lnR w="9525" cap="flat" cmpd="sng" algn="ctr">
-                      <a:solidFill>
-                        <a:schemeClr val="bg1"/>
-                      </a:solidFill>
-                      <a:prstDash val="solid"/>
-                      <a:round/>
-                      <a:headEnd type="none" w="med" len="med"/>
-                      <a:tailEnd type="none" w="med" len="med"/>
-                    </a:lnR>
-                    <a:lnT w="9525" cap="flat" cmpd="sng" algn="ctr">
-                      <a:solidFill>
-                        <a:schemeClr val="bg1"/>
-                      </a:solidFill>
-                      <a:prstDash val="solid"/>
-                      <a:round/>
-                      <a:headEnd type="none" w="med" len="med"/>
-                      <a:tailEnd type="none" w="med" len="med"/>
-                    </a:lnT>
-                    <a:lnB w="9525" cap="flat" cmpd="sng" algn="ctr">
-                      <a:solidFill>
-                        <a:schemeClr val="bg1"/>
-                      </a:solidFill>
-                      <a:prstDash val="solid"/>
-                      <a:round/>
-                      <a:headEnd type="none" w="med" len="med"/>
-                      <a:tailEnd type="none" w="med" len="med"/>
-                    </a:lnB>
-                    <a:noFill/>
-                  </a:tcPr>
-                </a:tc>
-                <a:extLst>
-                  <a:ext uri="{0D108BD9-81ED-4DB2-BD59-A6C34878D82A}">
-                    <a16:rowId xmlns:a16="http://schemas.microsoft.com/office/drawing/2014/main" val="3805416544"/>
-                  </a:ext>
-                </a:extLst>
-              </a:tr>
-              <a:tr h="0">
-                <a:tc>
-                  <a:txBody>
-                    <a:bodyPr/>
-                    <a:lstStyle/>
-                    <a:p>
-                      <a:pPr>
-                        <a:buNone/>
-                      </a:pPr>
-                      <a:r>
-                        <a:rPr lang="cs-CZ" b="1">
-                          <a:effectLst/>
-                          <a:latin typeface="Google Sans Text"/>
-                        </a:rPr>
-                        <a:t>int</a:t>
-                      </a:r>
-                      <a:endParaRPr lang="cs-CZ">
-                        <a:effectLst/>
-                        <a:latin typeface="Google Sans Text"/>
-                      </a:endParaRPr>
-                    </a:p>
-                  </a:txBody>
-                  <a:tcPr anchor="ctr">
-                    <a:lnL w="9525" cap="flat" cmpd="sng" algn="ctr">
-                      <a:solidFill>
-                        <a:schemeClr val="bg1"/>
-                      </a:solidFill>
-                      <a:prstDash val="solid"/>
-                      <a:round/>
-                      <a:headEnd type="none" w="med" len="med"/>
-                      <a:tailEnd type="none" w="med" len="med"/>
-                    </a:lnL>
-                    <a:lnR w="9525" cap="flat" cmpd="sng" algn="ctr">
-                      <a:solidFill>
-                        <a:schemeClr val="bg1"/>
-                      </a:solidFill>
-                      <a:prstDash val="solid"/>
-                      <a:round/>
-                      <a:headEnd type="none" w="med" len="med"/>
-                      <a:tailEnd type="none" w="med" len="med"/>
-                    </a:lnR>
-                    <a:lnT w="9525" cap="flat" cmpd="sng" algn="ctr">
-                      <a:solidFill>
-                        <a:schemeClr val="bg1"/>
-                      </a:solidFill>
-                      <a:prstDash val="solid"/>
-                      <a:round/>
-                      <a:headEnd type="none" w="med" len="med"/>
-                      <a:tailEnd type="none" w="med" len="med"/>
-                    </a:lnT>
-                    <a:lnB w="9525" cap="flat" cmpd="sng" algn="ctr">
-                      <a:solidFill>
-                        <a:schemeClr val="bg1"/>
-                      </a:solidFill>
-                      <a:prstDash val="solid"/>
-                      <a:round/>
-                      <a:headEnd type="none" w="med" len="med"/>
-                      <a:tailEnd type="none" w="med" len="med"/>
-                    </a:lnB>
-                    <a:noFill/>
-                  </a:tcPr>
-                </a:tc>
-                <a:tc>
-                  <a:txBody>
-                    <a:bodyPr/>
-                    <a:lstStyle/>
-                    <a:p>
-                      <a:pPr>
-                        <a:buNone/>
-                      </a:pPr>
-                      <a:r>
-                        <a:rPr lang="cs-CZ" dirty="0">
-                          <a:effectLst/>
-                          <a:highlight>
-                            <a:srgbClr val="FFFF00"/>
-                          </a:highlight>
-                          <a:latin typeface="Google Sans Text"/>
-                        </a:rPr>
-                        <a:t>Int32</a:t>
-                      </a:r>
-                    </a:p>
-                  </a:txBody>
-                  <a:tcPr anchor="ctr">
-                    <a:lnL w="9525" cap="flat" cmpd="sng" algn="ctr">
-                      <a:solidFill>
-                        <a:schemeClr val="bg1"/>
-                      </a:solidFill>
-                      <a:prstDash val="solid"/>
-                      <a:round/>
-                      <a:headEnd type="none" w="med" len="med"/>
-                      <a:tailEnd type="none" w="med" len="med"/>
-                    </a:lnL>
-                    <a:lnR w="9525" cap="flat" cmpd="sng" algn="ctr">
-                      <a:solidFill>
-                        <a:schemeClr val="bg1"/>
-                      </a:solidFill>
-                      <a:prstDash val="solid"/>
-                      <a:round/>
-                      <a:headEnd type="none" w="med" len="med"/>
-                      <a:tailEnd type="none" w="med" len="med"/>
-                    </a:lnR>
-                    <a:lnT w="9525" cap="flat" cmpd="sng" algn="ctr">
-                      <a:solidFill>
-                        <a:schemeClr val="bg1"/>
-                      </a:solidFill>
-                      <a:prstDash val="solid"/>
-                      <a:round/>
-                      <a:headEnd type="none" w="med" len="med"/>
-                      <a:tailEnd type="none" w="med" len="med"/>
-                    </a:lnT>
-                    <a:lnB w="9525" cap="flat" cmpd="sng" algn="ctr">
-                      <a:solidFill>
-                        <a:schemeClr val="bg1"/>
-                      </a:solidFill>
-                      <a:prstDash val="solid"/>
-                      <a:round/>
-                      <a:headEnd type="none" w="med" len="med"/>
-                      <a:tailEnd type="none" w="med" len="med"/>
-                    </a:lnB>
-                    <a:noFill/>
-                  </a:tcPr>
-                </a:tc>
-                <a:tc>
-                  <a:txBody>
-                    <a:bodyPr/>
-                    <a:lstStyle/>
-                    <a:p>
-                      <a:pPr>
-                        <a:buNone/>
-                      </a:pPr>
-                      <a:r>
-                        <a:rPr lang="cs-CZ" b="1">
-                          <a:effectLst/>
-                          <a:latin typeface="Google Sans Text"/>
-                        </a:rPr>
-                        <a:t>4 B</a:t>
-                      </a:r>
-                      <a:endParaRPr lang="cs-CZ">
-                        <a:effectLst/>
-                        <a:latin typeface="Google Sans Text"/>
-                      </a:endParaRPr>
-                    </a:p>
-                  </a:txBody>
-                  <a:tcPr anchor="ctr">
-                    <a:lnL w="9525" cap="flat" cmpd="sng" algn="ctr">
-                      <a:solidFill>
-                        <a:schemeClr val="bg1"/>
-                      </a:solidFill>
-                      <a:prstDash val="solid"/>
-                      <a:round/>
-                      <a:headEnd type="none" w="med" len="med"/>
-                      <a:tailEnd type="none" w="med" len="med"/>
-                    </a:lnL>
-                    <a:lnR w="9525" cap="flat" cmpd="sng" algn="ctr">
-                      <a:solidFill>
-                        <a:schemeClr val="bg1"/>
-                      </a:solidFill>
-                      <a:prstDash val="solid"/>
-                      <a:round/>
-                      <a:headEnd type="none" w="med" len="med"/>
-                      <a:tailEnd type="none" w="med" len="med"/>
-                    </a:lnR>
-                    <a:lnT w="9525" cap="flat" cmpd="sng" algn="ctr">
-                      <a:solidFill>
-                        <a:schemeClr val="bg1"/>
-                      </a:solidFill>
-                      <a:prstDash val="solid"/>
-                      <a:round/>
-                      <a:headEnd type="none" w="med" len="med"/>
-                      <a:tailEnd type="none" w="med" len="med"/>
-                    </a:lnT>
-                    <a:lnB w="9525" cap="flat" cmpd="sng" algn="ctr">
-                      <a:solidFill>
-                        <a:schemeClr val="bg1"/>
-                      </a:solidFill>
-                      <a:prstDash val="solid"/>
-                      <a:round/>
-                      <a:headEnd type="none" w="med" len="med"/>
-                      <a:tailEnd type="none" w="med" len="med"/>
-                    </a:lnB>
-                    <a:noFill/>
-                  </a:tcPr>
-                </a:tc>
-                <a:tc>
-                  <a:txBody>
-                    <a:bodyPr/>
-                    <a:lstStyle/>
-                    <a:p>
-                      <a:pPr>
-                        <a:buNone/>
-                      </a:pPr>
-                      <a:r>
-                        <a:rPr lang="cs-CZ" b="1">
-                          <a:effectLst/>
-                          <a:latin typeface="Google Sans Text"/>
-                        </a:rPr>
-                        <a:t>-2,1 mld. až 2,1 mld.</a:t>
-                      </a:r>
-                      <a:endParaRPr lang="cs-CZ">
-                        <a:effectLst/>
-                        <a:latin typeface="Google Sans Text"/>
-                      </a:endParaRPr>
-                    </a:p>
-                  </a:txBody>
-                  <a:tcPr anchor="ctr">
-                    <a:lnL w="9525" cap="flat" cmpd="sng" algn="ctr">
-                      <a:solidFill>
-                        <a:schemeClr val="bg1"/>
-                      </a:solidFill>
-                      <a:prstDash val="solid"/>
-                      <a:round/>
-                      <a:headEnd type="none" w="med" len="med"/>
-                      <a:tailEnd type="none" w="med" len="med"/>
-                    </a:lnL>
-                    <a:lnR w="9525" cap="flat" cmpd="sng" algn="ctr">
-                      <a:solidFill>
-                        <a:schemeClr val="bg1"/>
-                      </a:solidFill>
-                      <a:prstDash val="solid"/>
-                      <a:round/>
-                      <a:headEnd type="none" w="med" len="med"/>
-                      <a:tailEnd type="none" w="med" len="med"/>
-                    </a:lnR>
-                    <a:lnT w="9525" cap="flat" cmpd="sng" algn="ctr">
-                      <a:solidFill>
-                        <a:schemeClr val="bg1"/>
-                      </a:solidFill>
-                      <a:prstDash val="solid"/>
-                      <a:round/>
-                      <a:headEnd type="none" w="med" len="med"/>
-                      <a:tailEnd type="none" w="med" len="med"/>
-                    </a:lnT>
-                    <a:lnB w="9525" cap="flat" cmpd="sng" algn="ctr">
-                      <a:solidFill>
-                        <a:schemeClr val="bg1"/>
-                      </a:solidFill>
-                      <a:prstDash val="solid"/>
-                      <a:round/>
-                      <a:headEnd type="none" w="med" len="med"/>
-                      <a:tailEnd type="none" w="med" len="med"/>
-                    </a:lnB>
-                    <a:noFill/>
-                  </a:tcPr>
-                </a:tc>
-                <a:extLst>
-                  <a:ext uri="{0D108BD9-81ED-4DB2-BD59-A6C34878D82A}">
-                    <a16:rowId xmlns:a16="http://schemas.microsoft.com/office/drawing/2014/main" val="415679796"/>
-                  </a:ext>
-                </a:extLst>
-              </a:tr>
-              <a:tr h="0">
-                <a:tc>
-                  <a:txBody>
-                    <a:bodyPr/>
-                    <a:lstStyle/>
-                    <a:p>
-                      <a:pPr>
-                        <a:buNone/>
-                      </a:pPr>
-                      <a:r>
-                        <a:rPr lang="cs-CZ" b="1">
-                          <a:effectLst/>
-                          <a:latin typeface="Google Sans Text"/>
-                        </a:rPr>
-                        <a:t>long</a:t>
-                      </a:r>
-                      <a:endParaRPr lang="cs-CZ">
-                        <a:effectLst/>
-                        <a:latin typeface="Google Sans Text"/>
-                      </a:endParaRPr>
-                    </a:p>
-                  </a:txBody>
-                  <a:tcPr anchor="ctr">
-                    <a:lnL w="9525" cap="flat" cmpd="sng" algn="ctr">
-                      <a:solidFill>
-                        <a:schemeClr val="bg1"/>
-                      </a:solidFill>
-                      <a:prstDash val="solid"/>
-                      <a:round/>
-                      <a:headEnd type="none" w="med" len="med"/>
-                      <a:tailEnd type="none" w="med" len="med"/>
-                    </a:lnL>
-                    <a:lnR w="9525" cap="flat" cmpd="sng" algn="ctr">
-                      <a:solidFill>
-                        <a:schemeClr val="bg1"/>
-                      </a:solidFill>
-                      <a:prstDash val="solid"/>
-                      <a:round/>
-                      <a:headEnd type="none" w="med" len="med"/>
-                      <a:tailEnd type="none" w="med" len="med"/>
-                    </a:lnR>
-                    <a:lnT w="9525" cap="flat" cmpd="sng" algn="ctr">
-                      <a:solidFill>
-                        <a:schemeClr val="bg1"/>
-                      </a:solidFill>
-                      <a:prstDash val="solid"/>
-                      <a:round/>
-                      <a:headEnd type="none" w="med" len="med"/>
-                      <a:tailEnd type="none" w="med" len="med"/>
-                    </a:lnT>
-                    <a:lnB w="9525" cap="flat" cmpd="sng" algn="ctr">
-                      <a:solidFill>
-                        <a:schemeClr val="bg1"/>
-                      </a:solidFill>
-                      <a:prstDash val="solid"/>
-                      <a:round/>
-                      <a:headEnd type="none" w="med" len="med"/>
-                      <a:tailEnd type="none" w="med" len="med"/>
-                    </a:lnB>
-                    <a:noFill/>
-                  </a:tcPr>
-                </a:tc>
-                <a:tc>
-                  <a:txBody>
-                    <a:bodyPr/>
-                    <a:lstStyle/>
-                    <a:p>
-                      <a:pPr>
-                        <a:buNone/>
-                      </a:pPr>
-                      <a:r>
-                        <a:rPr lang="cs-CZ">
-                          <a:effectLst/>
-                          <a:latin typeface="Google Sans Text"/>
-                        </a:rPr>
-                        <a:t>Int64</a:t>
-                      </a:r>
-                    </a:p>
-                  </a:txBody>
-                  <a:tcPr anchor="ctr">
-                    <a:lnL w="9525" cap="flat" cmpd="sng" algn="ctr">
-                      <a:solidFill>
-                        <a:schemeClr val="bg1"/>
-                      </a:solidFill>
-                      <a:prstDash val="solid"/>
-                      <a:round/>
-                      <a:headEnd type="none" w="med" len="med"/>
-                      <a:tailEnd type="none" w="med" len="med"/>
-                    </a:lnL>
-                    <a:lnR w="9525" cap="flat" cmpd="sng" algn="ctr">
-                      <a:solidFill>
-                        <a:schemeClr val="bg1"/>
-                      </a:solidFill>
-                      <a:prstDash val="solid"/>
-                      <a:round/>
-                      <a:headEnd type="none" w="med" len="med"/>
-                      <a:tailEnd type="none" w="med" len="med"/>
-                    </a:lnR>
-                    <a:lnT w="9525" cap="flat" cmpd="sng" algn="ctr">
-                      <a:solidFill>
-                        <a:schemeClr val="bg1"/>
-                      </a:solidFill>
-                      <a:prstDash val="solid"/>
-                      <a:round/>
-                      <a:headEnd type="none" w="med" len="med"/>
-                      <a:tailEnd type="none" w="med" len="med"/>
-                    </a:lnT>
-                    <a:lnB w="9525" cap="flat" cmpd="sng" algn="ctr">
-                      <a:solidFill>
-                        <a:schemeClr val="bg1"/>
-                      </a:solidFill>
-                      <a:prstDash val="solid"/>
-                      <a:round/>
-                      <a:headEnd type="none" w="med" len="med"/>
-                      <a:tailEnd type="none" w="med" len="med"/>
-                    </a:lnB>
-                    <a:noFill/>
-                  </a:tcPr>
-                </a:tc>
-                <a:tc>
-                  <a:txBody>
-                    <a:bodyPr/>
-                    <a:lstStyle/>
-                    <a:p>
-                      <a:pPr>
-                        <a:buNone/>
-                      </a:pPr>
-                      <a:r>
-                        <a:rPr lang="cs-CZ">
-                          <a:effectLst/>
-                          <a:latin typeface="Google Sans Text"/>
-                        </a:rPr>
-                        <a:t>8 B</a:t>
-                      </a:r>
-                    </a:p>
-                  </a:txBody>
-                  <a:tcPr anchor="ctr">
-                    <a:lnL w="9525" cap="flat" cmpd="sng" algn="ctr">
-                      <a:solidFill>
-                        <a:schemeClr val="bg1"/>
-                      </a:solidFill>
-                      <a:prstDash val="solid"/>
-                      <a:round/>
-                      <a:headEnd type="none" w="med" len="med"/>
-                      <a:tailEnd type="none" w="med" len="med"/>
-                    </a:lnL>
-                    <a:lnR w="9525" cap="flat" cmpd="sng" algn="ctr">
-                      <a:solidFill>
-                        <a:schemeClr val="bg1"/>
-                      </a:solidFill>
-                      <a:prstDash val="solid"/>
-                      <a:round/>
-                      <a:headEnd type="none" w="med" len="med"/>
-                      <a:tailEnd type="none" w="med" len="med"/>
-                    </a:lnR>
-                    <a:lnT w="9525" cap="flat" cmpd="sng" algn="ctr">
-                      <a:solidFill>
-                        <a:schemeClr val="bg1"/>
-                      </a:solidFill>
-                      <a:prstDash val="solid"/>
-                      <a:round/>
-                      <a:headEnd type="none" w="med" len="med"/>
-                      <a:tailEnd type="none" w="med" len="med"/>
-                    </a:lnT>
-                    <a:lnB w="9525" cap="flat" cmpd="sng" algn="ctr">
-                      <a:solidFill>
-                        <a:schemeClr val="bg1"/>
-                      </a:solidFill>
-                      <a:prstDash val="solid"/>
-                      <a:round/>
-                      <a:headEnd type="none" w="med" len="med"/>
-                      <a:tailEnd type="none" w="med" len="med"/>
-                    </a:lnB>
-                    <a:noFill/>
-                  </a:tcPr>
-                </a:tc>
-                <a:tc>
-                  <a:txBody>
-                    <a:bodyPr/>
-                    <a:lstStyle/>
-                    <a:p>
-                      <a:pPr>
-                        <a:buNone/>
-                      </a:pPr>
-                      <a:r>
-                        <a:rPr lang="cs-CZ" dirty="0">
-                          <a:effectLst/>
-                          <a:latin typeface="Google Sans Text"/>
-                        </a:rPr>
-                        <a:t>-9 triliónů až 9 triliónů</a:t>
-                      </a:r>
-                    </a:p>
-                  </a:txBody>
-                  <a:tcPr anchor="ctr">
-                    <a:lnL w="9525" cap="flat" cmpd="sng" algn="ctr">
-                      <a:solidFill>
-                        <a:schemeClr val="bg1"/>
-                      </a:solidFill>
-                      <a:prstDash val="solid"/>
-                      <a:round/>
-                      <a:headEnd type="none" w="med" len="med"/>
-                      <a:tailEnd type="none" w="med" len="med"/>
-                    </a:lnL>
-                    <a:lnR w="9525" cap="flat" cmpd="sng" algn="ctr">
-                      <a:solidFill>
-                        <a:schemeClr val="bg1"/>
-                      </a:solidFill>
-                      <a:prstDash val="solid"/>
-                      <a:round/>
-                      <a:headEnd type="none" w="med" len="med"/>
-                      <a:tailEnd type="none" w="med" len="med"/>
-                    </a:lnR>
-                    <a:lnT w="9525" cap="flat" cmpd="sng" algn="ctr">
-                      <a:solidFill>
-                        <a:schemeClr val="bg1"/>
-                      </a:solidFill>
-                      <a:prstDash val="solid"/>
-                      <a:round/>
-                      <a:headEnd type="none" w="med" len="med"/>
-                      <a:tailEnd type="none" w="med" len="med"/>
-                    </a:lnT>
-                    <a:lnB w="9525" cap="flat" cmpd="sng" algn="ctr">
-                      <a:solidFill>
-                        <a:schemeClr val="bg1"/>
-                      </a:solidFill>
-                      <a:prstDash val="solid"/>
-                      <a:round/>
-                      <a:headEnd type="none" w="med" len="med"/>
-                      <a:tailEnd type="none" w="med" len="med"/>
-                    </a:lnB>
-                    <a:noFill/>
-                  </a:tcPr>
-                </a:tc>
-                <a:extLst>
-                  <a:ext uri="{0D108BD9-81ED-4DB2-BD59-A6C34878D82A}">
-                    <a16:rowId xmlns:a16="http://schemas.microsoft.com/office/drawing/2014/main" val="1725362625"/>
-                  </a:ext>
-                </a:extLst>
-              </a:tr>
-            </a:tbl>
-          </a:graphicData>
-        </a:graphic>
-      </p:graphicFrame>
-    </p:spTree>
-    <p:extLst>
-      <p:ext uri="{BB962C8B-B14F-4D97-AF65-F5344CB8AC3E}">
-        <p14:creationId xmlns:p14="http://schemas.microsoft.com/office/powerpoint/2010/main" val="606161950"/>
-      </p:ext>
-    </p:extLst>
-  </p:cSld>
-  <p:clrMapOvr>
-    <a:masterClrMapping/>
-  </p:clrMapOvr>
 </p:sld>
 </file>
 

</xml_diff>